<commit_message>
Fill Person 4 slides with tree-model results (17, 18, 20, 22)
Slide 20 now covers Gradient Boosting with feature importance and PR
curve; slide 21 and the Model 2 rows are relabelled for Nuno.

Co-Authored-By: Claude Opus 5.5 <noreply@anthropic.com>
</commit_message>
<xml_diff>
--- a/reports/presentation/Road Safety Predictive Analytics — Group 6.pptx
+++ b/reports/presentation/Road Safety Predictive Analytics — Group 6.pptx
@@ -10017,7 +10017,7 @@
                 <a:ea typeface="Public Sans" pitchFamily="34" charset="-122"/>
                 <a:cs typeface="Public Sans" pitchFamily="34" charset="-120"/>
               </a:rPr>
-              <a:t>[Best of Nuno's / Pedro's models — must beat lift 2.08× and PR-AUC 0.122 on 2024–25]</a:t>
+              <a:t>Gradient Boosting (Pedro): PR-AUC 0.126, lift 2.10× on 2024–25 · [Nuno's model to add]</a:t>
             </a:r>
             <a:endParaRPr lang="en-US" sz="1200" dirty="0"/>
           </a:p>
@@ -11384,7 +11384,213 @@
                           <a:ea typeface="Public Sans" pitchFamily="34" charset="-122"/>
                           <a:cs typeface="Public Sans" pitchFamily="34" charset="-120"/>
                         </a:rPr>
-                        <a:t>Model 1 — [Nuno]</a:t>
+                        <a:t>Model 1 — Gradient Boosting (Pedro)</a:t>
+                      </a:r>
+                      <a:endParaRPr lang="en-US" sz="1300" dirty="0">
+                        <a:latin typeface="Public Sans" charset="0"/>
+                        <a:ea typeface="Public Sans" charset="0"/>
+                        <a:cs typeface="Public Sans" charset="0"/>
+                      </a:endParaRPr>
+                    </a:p>
+                  </a:txBody>
+                  <a:tcPr marL="57785" marR="57785" marT="57785" marB="57785" anchor="t">
+                    <a:lnL w="12700" cap="flat" cmpd="sng" algn="ctr">
+                      <a:solidFill>
+                        <a:srgbClr val="C8C8C6"/>
+                      </a:solidFill>
+                      <a:prstDash val="solid"/>
+                      <a:round/>
+                      <a:headEnd type="none" w="med" len="med"/>
+                      <a:tailEnd type="none" w="med" len="med"/>
+                    </a:lnL>
+                    <a:lnR w="12700" cap="flat" cmpd="sng" algn="ctr">
+                      <a:solidFill>
+                        <a:srgbClr val="C8C8C6"/>
+                      </a:solidFill>
+                      <a:prstDash val="solid"/>
+                      <a:round/>
+                      <a:headEnd type="none" w="med" len="med"/>
+                      <a:tailEnd type="none" w="med" len="med"/>
+                    </a:lnR>
+                    <a:lnT w="12700" cap="flat" cmpd="sng" algn="ctr">
+                      <a:solidFill>
+                        <a:srgbClr val="C8C8C6"/>
+                      </a:solidFill>
+                      <a:prstDash val="solid"/>
+                      <a:round/>
+                      <a:headEnd type="none" w="med" len="med"/>
+                      <a:tailEnd type="none" w="med" len="med"/>
+                    </a:lnT>
+                    <a:lnB w="12700" cap="flat" cmpd="sng" algn="ctr">
+                      <a:solidFill>
+                        <a:srgbClr val="C8C8C6"/>
+                      </a:solidFill>
+                      <a:prstDash val="solid"/>
+                      <a:round/>
+                      <a:headEnd type="none" w="med" len="med"/>
+                      <a:tailEnd type="none" w="med" len="med"/>
+                    </a:lnB>
+                  </a:tcPr>
+                </a:tc>
+                <a:tc>
+                  <a:txBody>
+                    <a:bodyPr/>
+                    <a:lstStyle/>
+                    <a:p>
+                      <a:pPr indent="0" marL="0">
+                        <a:lnSpc>
+                          <a:spcPts val="1820"/>
+                        </a:lnSpc>
+                        <a:buNone/>
+                      </a:pPr>
+                      <a:r>
+                        <a:rPr lang="en-US" sz="1300" dirty="0">
+                          <a:solidFill>
+                            <a:srgbClr val="15213B"/>
+                          </a:solidFill>
+                          <a:latin typeface="Public Sans" pitchFamily="34" charset="0"/>
+                          <a:ea typeface="Public Sans" pitchFamily="34" charset="-122"/>
+                          <a:cs typeface="Public Sans" pitchFamily="34" charset="-120"/>
+                        </a:rPr>
+                        <a:t>Learns interactions of road, place and time (e.g. rural × night × downhill); Random Forest tested alongside</a:t>
+                      </a:r>
+                      <a:endParaRPr lang="en-US" sz="1300" dirty="0">
+                        <a:latin typeface="Public Sans" charset="0"/>
+                        <a:ea typeface="Public Sans" charset="0"/>
+                        <a:cs typeface="Public Sans" charset="0"/>
+                      </a:endParaRPr>
+                    </a:p>
+                  </a:txBody>
+                  <a:tcPr marL="57785" marR="57785" marT="57785" marB="57785" anchor="t">
+                    <a:lnL w="12700" cap="flat" cmpd="sng" algn="ctr">
+                      <a:solidFill>
+                        <a:srgbClr val="C8C8C6"/>
+                      </a:solidFill>
+                      <a:prstDash val="solid"/>
+                      <a:round/>
+                      <a:headEnd type="none" w="med" len="med"/>
+                      <a:tailEnd type="none" w="med" len="med"/>
+                    </a:lnL>
+                    <a:lnR w="12700" cap="flat" cmpd="sng" algn="ctr">
+                      <a:solidFill>
+                        <a:srgbClr val="C8C8C6"/>
+                      </a:solidFill>
+                      <a:prstDash val="solid"/>
+                      <a:round/>
+                      <a:headEnd type="none" w="med" len="med"/>
+                      <a:tailEnd type="none" w="med" len="med"/>
+                    </a:lnR>
+                    <a:lnT w="12700" cap="flat" cmpd="sng" algn="ctr">
+                      <a:solidFill>
+                        <a:srgbClr val="C8C8C6"/>
+                      </a:solidFill>
+                      <a:prstDash val="solid"/>
+                      <a:round/>
+                      <a:headEnd type="none" w="med" len="med"/>
+                      <a:tailEnd type="none" w="med" len="med"/>
+                    </a:lnT>
+                    <a:lnB w="12700" cap="flat" cmpd="sng" algn="ctr">
+                      <a:solidFill>
+                        <a:srgbClr val="C8C8C6"/>
+                      </a:solidFill>
+                      <a:prstDash val="solid"/>
+                      <a:round/>
+                      <a:headEnd type="none" w="med" len="med"/>
+                      <a:tailEnd type="none" w="med" len="med"/>
+                    </a:lnB>
+                  </a:tcPr>
+                </a:tc>
+                <a:tc>
+                  <a:txBody>
+                    <a:bodyPr/>
+                    <a:lstStyle/>
+                    <a:p>
+                      <a:pPr indent="0" marL="0">
+                        <a:lnSpc>
+                          <a:spcPts val="1820"/>
+                        </a:lnSpc>
+                        <a:buNone/>
+                      </a:pPr>
+                      <a:r>
+                        <a:rPr lang="en-US" sz="1300" dirty="0">
+                          <a:solidFill>
+                            <a:srgbClr val="15213B"/>
+                          </a:solidFill>
+                          <a:latin typeface="Public Sans" pitchFamily="34" charset="0"/>
+                          <a:ea typeface="Public Sans" pitchFamily="34" charset="-122"/>
+                          <a:cs typeface="Public Sans" pitchFamily="34" charset="-120"/>
+                        </a:rPr>
+                        <a:t>✓ Done (Pedro)</a:t>
+                      </a:r>
+                      <a:endParaRPr lang="en-US" sz="1300" dirty="0">
+                        <a:latin typeface="Public Sans" charset="0"/>
+                        <a:ea typeface="Public Sans" charset="0"/>
+                        <a:cs typeface="Public Sans" charset="0"/>
+                      </a:endParaRPr>
+                    </a:p>
+                  </a:txBody>
+                  <a:tcPr marL="57785" marR="57785" marT="57785" marB="57785" anchor="t">
+                    <a:lnL w="12700" cap="flat" cmpd="sng" algn="ctr">
+                      <a:solidFill>
+                        <a:srgbClr val="C8C8C6"/>
+                      </a:solidFill>
+                      <a:prstDash val="solid"/>
+                      <a:round/>
+                      <a:headEnd type="none" w="med" len="med"/>
+                      <a:tailEnd type="none" w="med" len="med"/>
+                    </a:lnL>
+                    <a:lnR w="12700" cap="flat" cmpd="sng" algn="ctr">
+                      <a:solidFill>
+                        <a:srgbClr val="C8C8C6"/>
+                      </a:solidFill>
+                      <a:prstDash val="solid"/>
+                      <a:round/>
+                      <a:headEnd type="none" w="med" len="med"/>
+                      <a:tailEnd type="none" w="med" len="med"/>
+                    </a:lnR>
+                    <a:lnT w="12700" cap="flat" cmpd="sng" algn="ctr">
+                      <a:solidFill>
+                        <a:srgbClr val="C8C8C6"/>
+                      </a:solidFill>
+                      <a:prstDash val="solid"/>
+                      <a:round/>
+                      <a:headEnd type="none" w="med" len="med"/>
+                      <a:tailEnd type="none" w="med" len="med"/>
+                    </a:lnT>
+                    <a:lnB w="12700" cap="flat" cmpd="sng" algn="ctr">
+                      <a:solidFill>
+                        <a:srgbClr val="C8C8C6"/>
+                      </a:solidFill>
+                      <a:prstDash val="solid"/>
+                      <a:round/>
+                      <a:headEnd type="none" w="med" len="med"/>
+                      <a:tailEnd type="none" w="med" len="med"/>
+                    </a:lnB>
+                  </a:tcPr>
+                </a:tc>
+              </a:tr>
+              <a:tr h="359321">
+                <a:tc>
+                  <a:txBody>
+                    <a:bodyPr/>
+                    <a:lstStyle/>
+                    <a:p>
+                      <a:pPr indent="0" marL="0">
+                        <a:lnSpc>
+                          <a:spcPts val="1820"/>
+                        </a:lnSpc>
+                        <a:buNone/>
+                      </a:pPr>
+                      <a:r>
+                        <a:rPr lang="en-US" sz="1300" dirty="0">
+                          <a:solidFill>
+                            <a:srgbClr val="15213B"/>
+                          </a:solidFill>
+                          <a:latin typeface="Public Sans" pitchFamily="34" charset="0"/>
+                          <a:ea typeface="Public Sans" pitchFamily="34" charset="-122"/>
+                          <a:cs typeface="Public Sans" pitchFamily="34" charset="-120"/>
+                        </a:rPr>
+                        <a:t>Model 2 — [Nuno]</a:t>
                       </a:r>
                       <a:endParaRPr lang="en-US" sz="1300" dirty="0">
                         <a:latin typeface="Public Sans" charset="0"/>
@@ -11521,212 +11727,6 @@
                           <a:cs typeface="Public Sans" pitchFamily="34" charset="-120"/>
                         </a:rPr>
                         <a:t>[ ] Nuno</a:t>
-                      </a:r>
-                      <a:endParaRPr lang="en-US" sz="1300" dirty="0">
-                        <a:latin typeface="Public Sans" charset="0"/>
-                        <a:ea typeface="Public Sans" charset="0"/>
-                        <a:cs typeface="Public Sans" charset="0"/>
-                      </a:endParaRPr>
-                    </a:p>
-                  </a:txBody>
-                  <a:tcPr marL="57785" marR="57785" marT="57785" marB="57785" anchor="t">
-                    <a:lnL w="12700" cap="flat" cmpd="sng" algn="ctr">
-                      <a:solidFill>
-                        <a:srgbClr val="C8C8C6"/>
-                      </a:solidFill>
-                      <a:prstDash val="solid"/>
-                      <a:round/>
-                      <a:headEnd type="none" w="med" len="med"/>
-                      <a:tailEnd type="none" w="med" len="med"/>
-                    </a:lnL>
-                    <a:lnR w="12700" cap="flat" cmpd="sng" algn="ctr">
-                      <a:solidFill>
-                        <a:srgbClr val="C8C8C6"/>
-                      </a:solidFill>
-                      <a:prstDash val="solid"/>
-                      <a:round/>
-                      <a:headEnd type="none" w="med" len="med"/>
-                      <a:tailEnd type="none" w="med" len="med"/>
-                    </a:lnR>
-                    <a:lnT w="12700" cap="flat" cmpd="sng" algn="ctr">
-                      <a:solidFill>
-                        <a:srgbClr val="C8C8C6"/>
-                      </a:solidFill>
-                      <a:prstDash val="solid"/>
-                      <a:round/>
-                      <a:headEnd type="none" w="med" len="med"/>
-                      <a:tailEnd type="none" w="med" len="med"/>
-                    </a:lnT>
-                    <a:lnB w="12700" cap="flat" cmpd="sng" algn="ctr">
-                      <a:solidFill>
-                        <a:srgbClr val="C8C8C6"/>
-                      </a:solidFill>
-                      <a:prstDash val="solid"/>
-                      <a:round/>
-                      <a:headEnd type="none" w="med" len="med"/>
-                      <a:tailEnd type="none" w="med" len="med"/>
-                    </a:lnB>
-                  </a:tcPr>
-                </a:tc>
-              </a:tr>
-              <a:tr h="359321">
-                <a:tc>
-                  <a:txBody>
-                    <a:bodyPr/>
-                    <a:lstStyle/>
-                    <a:p>
-                      <a:pPr indent="0" marL="0">
-                        <a:lnSpc>
-                          <a:spcPts val="1820"/>
-                        </a:lnSpc>
-                        <a:buNone/>
-                      </a:pPr>
-                      <a:r>
-                        <a:rPr lang="en-US" sz="1300" dirty="0">
-                          <a:solidFill>
-                            <a:srgbClr val="15213B"/>
-                          </a:solidFill>
-                          <a:latin typeface="Public Sans" pitchFamily="34" charset="0"/>
-                          <a:ea typeface="Public Sans" pitchFamily="34" charset="-122"/>
-                          <a:cs typeface="Public Sans" pitchFamily="34" charset="-120"/>
-                        </a:rPr>
-                        <a:t>Model 2 — [Pedro]</a:t>
-                      </a:r>
-                      <a:endParaRPr lang="en-US" sz="1300" dirty="0">
-                        <a:latin typeface="Public Sans" charset="0"/>
-                        <a:ea typeface="Public Sans" charset="0"/>
-                        <a:cs typeface="Public Sans" charset="0"/>
-                      </a:endParaRPr>
-                    </a:p>
-                  </a:txBody>
-                  <a:tcPr marL="57785" marR="57785" marT="57785" marB="57785" anchor="t">
-                    <a:lnL w="12700" cap="flat" cmpd="sng" algn="ctr">
-                      <a:solidFill>
-                        <a:srgbClr val="C8C8C6"/>
-                      </a:solidFill>
-                      <a:prstDash val="solid"/>
-                      <a:round/>
-                      <a:headEnd type="none" w="med" len="med"/>
-                      <a:tailEnd type="none" w="med" len="med"/>
-                    </a:lnL>
-                    <a:lnR w="12700" cap="flat" cmpd="sng" algn="ctr">
-                      <a:solidFill>
-                        <a:srgbClr val="C8C8C6"/>
-                      </a:solidFill>
-                      <a:prstDash val="solid"/>
-                      <a:round/>
-                      <a:headEnd type="none" w="med" len="med"/>
-                      <a:tailEnd type="none" w="med" len="med"/>
-                    </a:lnR>
-                    <a:lnT w="12700" cap="flat" cmpd="sng" algn="ctr">
-                      <a:solidFill>
-                        <a:srgbClr val="C8C8C6"/>
-                      </a:solidFill>
-                      <a:prstDash val="solid"/>
-                      <a:round/>
-                      <a:headEnd type="none" w="med" len="med"/>
-                      <a:tailEnd type="none" w="med" len="med"/>
-                    </a:lnT>
-                    <a:lnB w="12700" cap="flat" cmpd="sng" algn="ctr">
-                      <a:solidFill>
-                        <a:srgbClr val="C8C8C6"/>
-                      </a:solidFill>
-                      <a:prstDash val="solid"/>
-                      <a:round/>
-                      <a:headEnd type="none" w="med" len="med"/>
-                      <a:tailEnd type="none" w="med" len="med"/>
-                    </a:lnB>
-                  </a:tcPr>
-                </a:tc>
-                <a:tc>
-                  <a:txBody>
-                    <a:bodyPr/>
-                    <a:lstStyle/>
-                    <a:p>
-                      <a:pPr indent="0" marL="0">
-                        <a:lnSpc>
-                          <a:spcPts val="1820"/>
-                        </a:lnSpc>
-                        <a:buNone/>
-                      </a:pPr>
-                      <a:r>
-                        <a:rPr lang="en-US" sz="1300" dirty="0">
-                          <a:solidFill>
-                            <a:srgbClr val="15213B"/>
-                          </a:solidFill>
-                          <a:latin typeface="Public Sans" pitchFamily="34" charset="0"/>
-                          <a:ea typeface="Public Sans" pitchFamily="34" charset="-122"/>
-                          <a:cs typeface="Public Sans" pitchFamily="34" charset="-120"/>
-                        </a:rPr>
-                        <a:t>[to fill]</a:t>
-                      </a:r>
-                      <a:endParaRPr lang="en-US" sz="1300" dirty="0">
-                        <a:latin typeface="Public Sans" charset="0"/>
-                        <a:ea typeface="Public Sans" charset="0"/>
-                        <a:cs typeface="Public Sans" charset="0"/>
-                      </a:endParaRPr>
-                    </a:p>
-                  </a:txBody>
-                  <a:tcPr marL="57785" marR="57785" marT="57785" marB="57785" anchor="t">
-                    <a:lnL w="12700" cap="flat" cmpd="sng" algn="ctr">
-                      <a:solidFill>
-                        <a:srgbClr val="C8C8C6"/>
-                      </a:solidFill>
-                      <a:prstDash val="solid"/>
-                      <a:round/>
-                      <a:headEnd type="none" w="med" len="med"/>
-                      <a:tailEnd type="none" w="med" len="med"/>
-                    </a:lnL>
-                    <a:lnR w="12700" cap="flat" cmpd="sng" algn="ctr">
-                      <a:solidFill>
-                        <a:srgbClr val="C8C8C6"/>
-                      </a:solidFill>
-                      <a:prstDash val="solid"/>
-                      <a:round/>
-                      <a:headEnd type="none" w="med" len="med"/>
-                      <a:tailEnd type="none" w="med" len="med"/>
-                    </a:lnR>
-                    <a:lnT w="12700" cap="flat" cmpd="sng" algn="ctr">
-                      <a:solidFill>
-                        <a:srgbClr val="C8C8C6"/>
-                      </a:solidFill>
-                      <a:prstDash val="solid"/>
-                      <a:round/>
-                      <a:headEnd type="none" w="med" len="med"/>
-                      <a:tailEnd type="none" w="med" len="med"/>
-                    </a:lnT>
-                    <a:lnB w="12700" cap="flat" cmpd="sng" algn="ctr">
-                      <a:solidFill>
-                        <a:srgbClr val="C8C8C6"/>
-                      </a:solidFill>
-                      <a:prstDash val="solid"/>
-                      <a:round/>
-                      <a:headEnd type="none" w="med" len="med"/>
-                      <a:tailEnd type="none" w="med" len="med"/>
-                    </a:lnB>
-                  </a:tcPr>
-                </a:tc>
-                <a:tc>
-                  <a:txBody>
-                    <a:bodyPr/>
-                    <a:lstStyle/>
-                    <a:p>
-                      <a:pPr indent="0" marL="0">
-                        <a:lnSpc>
-                          <a:spcPts val="1820"/>
-                        </a:lnSpc>
-                        <a:buNone/>
-                      </a:pPr>
-                      <a:r>
-                        <a:rPr lang="en-US" sz="1300" dirty="0">
-                          <a:solidFill>
-                            <a:srgbClr val="15213B"/>
-                          </a:solidFill>
-                          <a:latin typeface="Public Sans" pitchFamily="34" charset="0"/>
-                          <a:ea typeface="Public Sans" pitchFamily="34" charset="-122"/>
-                          <a:cs typeface="Public Sans" pitchFamily="34" charset="-120"/>
-                        </a:rPr>
-                        <a:t>[ ] Pedro</a:t>
                       </a:r>
                       <a:endParaRPr lang="en-US" sz="1300" dirty="0">
                         <a:latin typeface="Public Sans" charset="0"/>
@@ -15121,7 +15121,7 @@
                 <a:ea typeface="Libre Baskerville" pitchFamily="18" charset="-122"/>
                 <a:cs typeface="Libre Baskerville" pitchFamily="18" charset="-120"/>
               </a:rPr>
-              <a:t>Model 1 — [Nuno: model name]</a:t>
+              <a:t>Model 1 — Gradient Boosting (tree ensemble)</a:t>
             </a:r>
             <a:endParaRPr lang="en-US" sz="3000" dirty="0"/>
           </a:p>
@@ -15166,7 +15166,7 @@
                 <a:ea typeface="Public Sans" pitchFamily="34" charset="-122"/>
                 <a:cs typeface="Public Sans" pitchFamily="34" charset="-120"/>
               </a:rPr>
-              <a:t>[To be filled by Nuno]</a:t>
+              <a:t>Histogram Gradient Boosting, compared with a Random Forest; class weights for the 5% fatal rate, no scaling needed.</a:t>
             </a:r>
             <a:endParaRPr lang="en-US" sz="1300" dirty="0"/>
           </a:p>
@@ -15187,7 +15187,7 @@
                 <a:ea typeface="Public Sans" pitchFamily="34" charset="-122"/>
                 <a:cs typeface="Public Sans" pitchFamily="34" charset="-120"/>
               </a:rPr>
-              <a:t>[Model chosen and why it fits the problem]</a:t>
+              <a:t>Why: fatality risk comes from combinations (rural × night × downhill); trees learn these interactions without hand-crafting.</a:t>
             </a:r>
             <a:endParaRPr lang="en-US" sz="1300" dirty="0"/>
           </a:p>
@@ -15208,7 +15208,7 @@
                 <a:ea typeface="Public Sans" pitchFamily="34" charset="-122"/>
                 <a:cs typeface="Public Sans" pitchFamily="34" charset="-120"/>
               </a:rPr>
-              <a:t>[Tuning on validation 2022–2023: what was tried, what was kept]</a:t>
+              <a:t>Tuning on validation 2022–23: 13 configs. Small, regularised trees won (lr 0.03, 15 leaves, 150 trees); training on 2015+ only gave no gain.</a:t>
             </a:r>
             <a:endParaRPr lang="en-US" sz="1300" dirty="0"/>
           </a:p>
@@ -15229,7 +15229,7 @@
                 <a:ea typeface="Public Sans" pitchFamily="34" charset="-122"/>
                 <a:cs typeface="Public Sans" pitchFamily="34" charset="-120"/>
               </a:rPr>
-              <a:t>[Validation results: PR-AUC, recall &amp; lift @ top 15%, Brier after calibration]</a:t>
+              <a:t>Validation: PR-AUC 0.134, lift 2.24×. Test 2024–25: PR-AUC 0.126, recall 31.5%, lift 2.10×, Brier 0.064 after sigmoid calibration.</a:t>
             </a:r>
             <a:endParaRPr lang="en-US" sz="1300" dirty="0"/>
           </a:p>
@@ -15250,7 +15250,7 @@
                 <a:ea typeface="Public Sans" pitchFamily="34" charset="-122"/>
                 <a:cs typeface="Public Sans" pitchFamily="34" charset="-120"/>
               </a:rPr>
-              <a:t>[What the model learned: most important features]</a:t>
+              <a:t>Top drivers: time of day, roadway type, historical segment risk, then downhill, rural area and day of week (matches the EDA).</a:t>
             </a:r>
             <a:endParaRPr lang="en-US" sz="1300" dirty="0"/>
           </a:p>
@@ -15344,6 +15344,54 @@
           </a:p>
         </p:txBody>
       </p:sp>
+      <p:pic>
+        <p:nvPicPr>
+          <p:cNvPr id="7" name="Picture 6" descr="task3_trees_feature_importance.png"/>
+          <p:cNvPicPr>
+            <a:picLocks noChangeAspect="1"/>
+          </p:cNvPicPr>
+          <p:nvPr/>
+        </p:nvPicPr>
+        <p:blipFill>
+          <a:blip r:embed="rId2"/>
+          <a:stretch>
+            <a:fillRect/>
+          </a:stretch>
+        </p:blipFill>
+        <p:spPr>
+          <a:xfrm>
+            <a:off x="910844" y="3500000"/>
+            <a:ext cx="3290000" cy="2350000"/>
+          </a:xfrm>
+          <a:prstGeom prst="rect">
+            <a:avLst/>
+          </a:prstGeom>
+        </p:spPr>
+      </p:pic>
+      <p:pic>
+        <p:nvPicPr>
+          <p:cNvPr id="8" name="Picture 7" descr="task3_trees_pr_curve.png"/>
+          <p:cNvPicPr>
+            <a:picLocks noChangeAspect="1"/>
+          </p:cNvPicPr>
+          <p:nvPr/>
+        </p:nvPicPr>
+        <p:blipFill>
+          <a:blip r:embed="rId3"/>
+          <a:stretch>
+            <a:fillRect/>
+          </a:stretch>
+        </p:blipFill>
+        <p:spPr>
+          <a:xfrm>
+            <a:off x="4500844" y="3500000"/>
+            <a:ext cx="3290000" cy="2350000"/>
+          </a:xfrm>
+          <a:prstGeom prst="rect">
+            <a:avLst/>
+          </a:prstGeom>
+        </p:spPr>
+      </p:pic>
     </p:spTree>
   </p:cSld>
   <p:clrMapOvr>
@@ -15460,7 +15508,7 @@
                 <a:ea typeface="Libre Baskerville" pitchFamily="18" charset="-122"/>
                 <a:cs typeface="Libre Baskerville" pitchFamily="18" charset="-120"/>
               </a:rPr>
-              <a:t>Model 2 — [Pedro: model name]</a:t>
+              <a:t>Model 2 — [Nuno: model name]</a:t>
             </a:r>
             <a:endParaRPr lang="en-US" sz="3000" dirty="0"/>
           </a:p>
@@ -15505,7 +15553,7 @@
                 <a:ea typeface="Public Sans" pitchFamily="34" charset="-122"/>
                 <a:cs typeface="Public Sans" pitchFamily="34" charset="-120"/>
               </a:rPr>
-              <a:t>[To be filled by Pedro]</a:t>
+              <a:t>[To be filled by Nuno]</a:t>
             </a:r>
             <a:endParaRPr lang="en-US" sz="1300" dirty="0"/>
           </a:p>
@@ -17104,7 +17152,417 @@
                           <a:ea typeface="Public Sans" pitchFamily="34" charset="-122"/>
                           <a:cs typeface="Public Sans" pitchFamily="34" charset="-120"/>
                         </a:rPr>
-                        <a:t>Model 1 — [Nuno]</a:t>
+                        <a:t>Model 1 — Gradient Boosting + calibration</a:t>
+                      </a:r>
+                      <a:endParaRPr lang="en-US" sz="1300" dirty="0">
+                        <a:latin typeface="Public Sans" charset="0"/>
+                        <a:ea typeface="Public Sans" charset="0"/>
+                        <a:cs typeface="Public Sans" charset="0"/>
+                      </a:endParaRPr>
+                    </a:p>
+                  </a:txBody>
+                  <a:tcPr marL="57785" marR="57785" marT="57785" marB="57785" anchor="t">
+                    <a:lnL w="12700" cap="flat" cmpd="sng" algn="ctr">
+                      <a:solidFill>
+                        <a:srgbClr val="C8C8C6"/>
+                      </a:solidFill>
+                      <a:prstDash val="solid"/>
+                      <a:round/>
+                      <a:headEnd type="none" w="med" len="med"/>
+                      <a:tailEnd type="none" w="med" len="med"/>
+                    </a:lnL>
+                    <a:lnR w="12700" cap="flat" cmpd="sng" algn="ctr">
+                      <a:solidFill>
+                        <a:srgbClr val="C8C8C6"/>
+                      </a:solidFill>
+                      <a:prstDash val="solid"/>
+                      <a:round/>
+                      <a:headEnd type="none" w="med" len="med"/>
+                      <a:tailEnd type="none" w="med" len="med"/>
+                    </a:lnR>
+                    <a:lnT w="12700" cap="flat" cmpd="sng" algn="ctr">
+                      <a:solidFill>
+                        <a:srgbClr val="C8C8C6"/>
+                      </a:solidFill>
+                      <a:prstDash val="solid"/>
+                      <a:round/>
+                      <a:headEnd type="none" w="med" len="med"/>
+                      <a:tailEnd type="none" w="med" len="med"/>
+                    </a:lnT>
+                    <a:lnB w="12700" cap="flat" cmpd="sng" algn="ctr">
+                      <a:solidFill>
+                        <a:srgbClr val="C8C8C6"/>
+                      </a:solidFill>
+                      <a:prstDash val="solid"/>
+                      <a:round/>
+                      <a:headEnd type="none" w="med" len="med"/>
+                      <a:tailEnd type="none" w="med" len="med"/>
+                    </a:lnB>
+                  </a:tcPr>
+                </a:tc>
+                <a:tc>
+                  <a:txBody>
+                    <a:bodyPr/>
+                    <a:lstStyle/>
+                    <a:p>
+                      <a:pPr indent="0" marL="0">
+                        <a:lnSpc>
+                          <a:spcPts val="1820"/>
+                        </a:lnSpc>
+                        <a:buNone/>
+                      </a:pPr>
+                      <a:r>
+                        <a:rPr lang="en-US" sz="1300" dirty="0">
+                          <a:solidFill>
+                            <a:srgbClr val="15213B"/>
+                          </a:solidFill>
+                          <a:latin typeface="Public Sans" pitchFamily="34" charset="0"/>
+                          <a:ea typeface="Public Sans" pitchFamily="34" charset="-122"/>
+                          <a:cs typeface="Public Sans" pitchFamily="34" charset="-120"/>
+                        </a:rPr>
+                        <a:t>0.673</a:t>
+                      </a:r>
+                      <a:endParaRPr lang="en-US" sz="1300" dirty="0">
+                        <a:latin typeface="Public Sans" charset="0"/>
+                        <a:ea typeface="Public Sans" charset="0"/>
+                        <a:cs typeface="Public Sans" charset="0"/>
+                      </a:endParaRPr>
+                    </a:p>
+                  </a:txBody>
+                  <a:tcPr marL="57785" marR="57785" marT="57785" marB="57785" anchor="t">
+                    <a:lnL w="12700" cap="flat" cmpd="sng" algn="ctr">
+                      <a:solidFill>
+                        <a:srgbClr val="C8C8C6"/>
+                      </a:solidFill>
+                      <a:prstDash val="solid"/>
+                      <a:round/>
+                      <a:headEnd type="none" w="med" len="med"/>
+                      <a:tailEnd type="none" w="med" len="med"/>
+                    </a:lnL>
+                    <a:lnR w="12700" cap="flat" cmpd="sng" algn="ctr">
+                      <a:solidFill>
+                        <a:srgbClr val="C8C8C6"/>
+                      </a:solidFill>
+                      <a:prstDash val="solid"/>
+                      <a:round/>
+                      <a:headEnd type="none" w="med" len="med"/>
+                      <a:tailEnd type="none" w="med" len="med"/>
+                    </a:lnR>
+                    <a:lnT w="12700" cap="flat" cmpd="sng" algn="ctr">
+                      <a:solidFill>
+                        <a:srgbClr val="C8C8C6"/>
+                      </a:solidFill>
+                      <a:prstDash val="solid"/>
+                      <a:round/>
+                      <a:headEnd type="none" w="med" len="med"/>
+                      <a:tailEnd type="none" w="med" len="med"/>
+                    </a:lnT>
+                    <a:lnB w="12700" cap="flat" cmpd="sng" algn="ctr">
+                      <a:solidFill>
+                        <a:srgbClr val="C8C8C6"/>
+                      </a:solidFill>
+                      <a:prstDash val="solid"/>
+                      <a:round/>
+                      <a:headEnd type="none" w="med" len="med"/>
+                      <a:tailEnd type="none" w="med" len="med"/>
+                    </a:lnB>
+                  </a:tcPr>
+                </a:tc>
+                <a:tc>
+                  <a:txBody>
+                    <a:bodyPr/>
+                    <a:lstStyle/>
+                    <a:p>
+                      <a:pPr indent="0" marL="0">
+                        <a:lnSpc>
+                          <a:spcPts val="1820"/>
+                        </a:lnSpc>
+                        <a:buNone/>
+                      </a:pPr>
+                      <a:r>
+                        <a:rPr lang="en-US" sz="1300" dirty="0">
+                          <a:solidFill>
+                            <a:srgbClr val="15213B"/>
+                          </a:solidFill>
+                          <a:latin typeface="Public Sans" pitchFamily="34" charset="0"/>
+                          <a:ea typeface="Public Sans" pitchFamily="34" charset="-122"/>
+                          <a:cs typeface="Public Sans" pitchFamily="34" charset="-120"/>
+                        </a:rPr>
+                        <a:t>0.126</a:t>
+                      </a:r>
+                      <a:endParaRPr lang="en-US" sz="1300" dirty="0">
+                        <a:latin typeface="Public Sans" charset="0"/>
+                        <a:ea typeface="Public Sans" charset="0"/>
+                        <a:cs typeface="Public Sans" charset="0"/>
+                      </a:endParaRPr>
+                    </a:p>
+                  </a:txBody>
+                  <a:tcPr marL="57785" marR="57785" marT="57785" marB="57785" anchor="t">
+                    <a:lnL w="12700" cap="flat" cmpd="sng" algn="ctr">
+                      <a:solidFill>
+                        <a:srgbClr val="C8C8C6"/>
+                      </a:solidFill>
+                      <a:prstDash val="solid"/>
+                      <a:round/>
+                      <a:headEnd type="none" w="med" len="med"/>
+                      <a:tailEnd type="none" w="med" len="med"/>
+                    </a:lnL>
+                    <a:lnR w="12700" cap="flat" cmpd="sng" algn="ctr">
+                      <a:solidFill>
+                        <a:srgbClr val="C8C8C6"/>
+                      </a:solidFill>
+                      <a:prstDash val="solid"/>
+                      <a:round/>
+                      <a:headEnd type="none" w="med" len="med"/>
+                      <a:tailEnd type="none" w="med" len="med"/>
+                    </a:lnR>
+                    <a:lnT w="12700" cap="flat" cmpd="sng" algn="ctr">
+                      <a:solidFill>
+                        <a:srgbClr val="C8C8C6"/>
+                      </a:solidFill>
+                      <a:prstDash val="solid"/>
+                      <a:round/>
+                      <a:headEnd type="none" w="med" len="med"/>
+                      <a:tailEnd type="none" w="med" len="med"/>
+                    </a:lnT>
+                    <a:lnB w="12700" cap="flat" cmpd="sng" algn="ctr">
+                      <a:solidFill>
+                        <a:srgbClr val="C8C8C6"/>
+                      </a:solidFill>
+                      <a:prstDash val="solid"/>
+                      <a:round/>
+                      <a:headEnd type="none" w="med" len="med"/>
+                      <a:tailEnd type="none" w="med" len="med"/>
+                    </a:lnB>
+                  </a:tcPr>
+                </a:tc>
+                <a:tc>
+                  <a:txBody>
+                    <a:bodyPr/>
+                    <a:lstStyle/>
+                    <a:p>
+                      <a:pPr indent="0" marL="0">
+                        <a:lnSpc>
+                          <a:spcPts val="1820"/>
+                        </a:lnSpc>
+                        <a:buNone/>
+                      </a:pPr>
+                      <a:r>
+                        <a:rPr lang="en-US" sz="1300" dirty="0">
+                          <a:solidFill>
+                            <a:srgbClr val="15213B"/>
+                          </a:solidFill>
+                          <a:latin typeface="Public Sans" pitchFamily="34" charset="0"/>
+                          <a:ea typeface="Public Sans" pitchFamily="34" charset="-122"/>
+                          <a:cs typeface="Public Sans" pitchFamily="34" charset="-120"/>
+                        </a:rPr>
+                        <a:t>31.5%</a:t>
+                      </a:r>
+                      <a:endParaRPr lang="en-US" sz="1300" dirty="0">
+                        <a:latin typeface="Public Sans" charset="0"/>
+                        <a:ea typeface="Public Sans" charset="0"/>
+                        <a:cs typeface="Public Sans" charset="0"/>
+                      </a:endParaRPr>
+                    </a:p>
+                  </a:txBody>
+                  <a:tcPr marL="57785" marR="57785" marT="57785" marB="57785" anchor="t">
+                    <a:lnL w="12700" cap="flat" cmpd="sng" algn="ctr">
+                      <a:solidFill>
+                        <a:srgbClr val="C8C8C6"/>
+                      </a:solidFill>
+                      <a:prstDash val="solid"/>
+                      <a:round/>
+                      <a:headEnd type="none" w="med" len="med"/>
+                      <a:tailEnd type="none" w="med" len="med"/>
+                    </a:lnL>
+                    <a:lnR w="12700" cap="flat" cmpd="sng" algn="ctr">
+                      <a:solidFill>
+                        <a:srgbClr val="C8C8C6"/>
+                      </a:solidFill>
+                      <a:prstDash val="solid"/>
+                      <a:round/>
+                      <a:headEnd type="none" w="med" len="med"/>
+                      <a:tailEnd type="none" w="med" len="med"/>
+                    </a:lnR>
+                    <a:lnT w="12700" cap="flat" cmpd="sng" algn="ctr">
+                      <a:solidFill>
+                        <a:srgbClr val="C8C8C6"/>
+                      </a:solidFill>
+                      <a:prstDash val="solid"/>
+                      <a:round/>
+                      <a:headEnd type="none" w="med" len="med"/>
+                      <a:tailEnd type="none" w="med" len="med"/>
+                    </a:lnT>
+                    <a:lnB w="12700" cap="flat" cmpd="sng" algn="ctr">
+                      <a:solidFill>
+                        <a:srgbClr val="C8C8C6"/>
+                      </a:solidFill>
+                      <a:prstDash val="solid"/>
+                      <a:round/>
+                      <a:headEnd type="none" w="med" len="med"/>
+                      <a:tailEnd type="none" w="med" len="med"/>
+                    </a:lnB>
+                  </a:tcPr>
+                </a:tc>
+                <a:tc>
+                  <a:txBody>
+                    <a:bodyPr/>
+                    <a:lstStyle/>
+                    <a:p>
+                      <a:pPr indent="0" marL="0">
+                        <a:lnSpc>
+                          <a:spcPts val="1820"/>
+                        </a:lnSpc>
+                        <a:buNone/>
+                      </a:pPr>
+                      <a:r>
+                        <a:rPr lang="en-US" sz="1300" dirty="0">
+                          <a:solidFill>
+                            <a:srgbClr val="15213B"/>
+                          </a:solidFill>
+                          <a:latin typeface="Public Sans" pitchFamily="34" charset="0"/>
+                          <a:ea typeface="Public Sans" pitchFamily="34" charset="-122"/>
+                          <a:cs typeface="Public Sans" pitchFamily="34" charset="-120"/>
+                        </a:rPr>
+                        <a:t>2.10×</a:t>
+                      </a:r>
+                      <a:endParaRPr lang="en-US" sz="1300" dirty="0">
+                        <a:latin typeface="Public Sans" charset="0"/>
+                        <a:ea typeface="Public Sans" charset="0"/>
+                        <a:cs typeface="Public Sans" charset="0"/>
+                      </a:endParaRPr>
+                    </a:p>
+                  </a:txBody>
+                  <a:tcPr marL="57785" marR="57785" marT="57785" marB="57785" anchor="t">
+                    <a:lnL w="12700" cap="flat" cmpd="sng" algn="ctr">
+                      <a:solidFill>
+                        <a:srgbClr val="C8C8C6"/>
+                      </a:solidFill>
+                      <a:prstDash val="solid"/>
+                      <a:round/>
+                      <a:headEnd type="none" w="med" len="med"/>
+                      <a:tailEnd type="none" w="med" len="med"/>
+                    </a:lnL>
+                    <a:lnR w="12700" cap="flat" cmpd="sng" algn="ctr">
+                      <a:solidFill>
+                        <a:srgbClr val="C8C8C6"/>
+                      </a:solidFill>
+                      <a:prstDash val="solid"/>
+                      <a:round/>
+                      <a:headEnd type="none" w="med" len="med"/>
+                      <a:tailEnd type="none" w="med" len="med"/>
+                    </a:lnR>
+                    <a:lnT w="12700" cap="flat" cmpd="sng" algn="ctr">
+                      <a:solidFill>
+                        <a:srgbClr val="C8C8C6"/>
+                      </a:solidFill>
+                      <a:prstDash val="solid"/>
+                      <a:round/>
+                      <a:headEnd type="none" w="med" len="med"/>
+                      <a:tailEnd type="none" w="med" len="med"/>
+                    </a:lnT>
+                    <a:lnB w="12700" cap="flat" cmpd="sng" algn="ctr">
+                      <a:solidFill>
+                        <a:srgbClr val="C8C8C6"/>
+                      </a:solidFill>
+                      <a:prstDash val="solid"/>
+                      <a:round/>
+                      <a:headEnd type="none" w="med" len="med"/>
+                      <a:tailEnd type="none" w="med" len="med"/>
+                    </a:lnB>
+                  </a:tcPr>
+                </a:tc>
+                <a:tc>
+                  <a:txBody>
+                    <a:bodyPr/>
+                    <a:lstStyle/>
+                    <a:p>
+                      <a:pPr indent="0" marL="0">
+                        <a:lnSpc>
+                          <a:spcPts val="1820"/>
+                        </a:lnSpc>
+                        <a:buNone/>
+                      </a:pPr>
+                      <a:r>
+                        <a:rPr lang="en-US" sz="1300" dirty="0">
+                          <a:solidFill>
+                            <a:srgbClr val="15213B"/>
+                          </a:solidFill>
+                          <a:latin typeface="Public Sans" pitchFamily="34" charset="0"/>
+                          <a:ea typeface="Public Sans" pitchFamily="34" charset="-122"/>
+                          <a:cs typeface="Public Sans" pitchFamily="34" charset="-120"/>
+                        </a:rPr>
+                        <a:t>0.064</a:t>
+                      </a:r>
+                      <a:endParaRPr lang="en-US" sz="1300" dirty="0">
+                        <a:latin typeface="Public Sans" charset="0"/>
+                        <a:ea typeface="Public Sans" charset="0"/>
+                        <a:cs typeface="Public Sans" charset="0"/>
+                      </a:endParaRPr>
+                    </a:p>
+                  </a:txBody>
+                  <a:tcPr marL="57785" marR="57785" marT="57785" marB="57785" anchor="t">
+                    <a:lnL w="12700" cap="flat" cmpd="sng" algn="ctr">
+                      <a:solidFill>
+                        <a:srgbClr val="C8C8C6"/>
+                      </a:solidFill>
+                      <a:prstDash val="solid"/>
+                      <a:round/>
+                      <a:headEnd type="none" w="med" len="med"/>
+                      <a:tailEnd type="none" w="med" len="med"/>
+                    </a:lnL>
+                    <a:lnR w="12700" cap="flat" cmpd="sng" algn="ctr">
+                      <a:solidFill>
+                        <a:srgbClr val="C8C8C6"/>
+                      </a:solidFill>
+                      <a:prstDash val="solid"/>
+                      <a:round/>
+                      <a:headEnd type="none" w="med" len="med"/>
+                      <a:tailEnd type="none" w="med" len="med"/>
+                    </a:lnR>
+                    <a:lnT w="12700" cap="flat" cmpd="sng" algn="ctr">
+                      <a:solidFill>
+                        <a:srgbClr val="C8C8C6"/>
+                      </a:solidFill>
+                      <a:prstDash val="solid"/>
+                      <a:round/>
+                      <a:headEnd type="none" w="med" len="med"/>
+                      <a:tailEnd type="none" w="med" len="med"/>
+                    </a:lnT>
+                    <a:lnB w="12700" cap="flat" cmpd="sng" algn="ctr">
+                      <a:solidFill>
+                        <a:srgbClr val="C8C8C6"/>
+                      </a:solidFill>
+                      <a:prstDash val="solid"/>
+                      <a:round/>
+                      <a:headEnd type="none" w="med" len="med"/>
+                      <a:tailEnd type="none" w="med" len="med"/>
+                    </a:lnB>
+                  </a:tcPr>
+                </a:tc>
+              </a:tr>
+              <a:tr h="359321">
+                <a:tc>
+                  <a:txBody>
+                    <a:bodyPr/>
+                    <a:lstStyle/>
+                    <a:p>
+                      <a:pPr indent="0" marL="0">
+                        <a:lnSpc>
+                          <a:spcPts val="1820"/>
+                        </a:lnSpc>
+                        <a:buNone/>
+                      </a:pPr>
+                      <a:r>
+                        <a:rPr lang="en-US" sz="1300" dirty="0">
+                          <a:solidFill>
+                            <a:srgbClr val="15213B"/>
+                          </a:solidFill>
+                          <a:latin typeface="Public Sans" pitchFamily="34" charset="0"/>
+                          <a:ea typeface="Public Sans" pitchFamily="34" charset="-122"/>
+                          <a:cs typeface="Public Sans" pitchFamily="34" charset="-120"/>
+                        </a:rPr>
+                        <a:t>Model 2 — [Nuno]</a:t>
                       </a:r>
                       <a:endParaRPr lang="en-US" sz="1300" dirty="0">
                         <a:latin typeface="Public Sans" charset="0"/>
@@ -17493,416 +17951,6 @@
                   </a:tcPr>
                 </a:tc>
               </a:tr>
-              <a:tr h="359321">
-                <a:tc>
-                  <a:txBody>
-                    <a:bodyPr/>
-                    <a:lstStyle/>
-                    <a:p>
-                      <a:pPr indent="0" marL="0">
-                        <a:lnSpc>
-                          <a:spcPts val="1820"/>
-                        </a:lnSpc>
-                        <a:buNone/>
-                      </a:pPr>
-                      <a:r>
-                        <a:rPr lang="en-US" sz="1300" dirty="0">
-                          <a:solidFill>
-                            <a:srgbClr val="15213B"/>
-                          </a:solidFill>
-                          <a:latin typeface="Public Sans" pitchFamily="34" charset="0"/>
-                          <a:ea typeface="Public Sans" pitchFamily="34" charset="-122"/>
-                          <a:cs typeface="Public Sans" pitchFamily="34" charset="-120"/>
-                        </a:rPr>
-                        <a:t>Model 2 — [Pedro]</a:t>
-                      </a:r>
-                      <a:endParaRPr lang="en-US" sz="1300" dirty="0">
-                        <a:latin typeface="Public Sans" charset="0"/>
-                        <a:ea typeface="Public Sans" charset="0"/>
-                        <a:cs typeface="Public Sans" charset="0"/>
-                      </a:endParaRPr>
-                    </a:p>
-                  </a:txBody>
-                  <a:tcPr marL="57785" marR="57785" marT="57785" marB="57785" anchor="t">
-                    <a:lnL w="12700" cap="flat" cmpd="sng" algn="ctr">
-                      <a:solidFill>
-                        <a:srgbClr val="C8C8C6"/>
-                      </a:solidFill>
-                      <a:prstDash val="solid"/>
-                      <a:round/>
-                      <a:headEnd type="none" w="med" len="med"/>
-                      <a:tailEnd type="none" w="med" len="med"/>
-                    </a:lnL>
-                    <a:lnR w="12700" cap="flat" cmpd="sng" algn="ctr">
-                      <a:solidFill>
-                        <a:srgbClr val="C8C8C6"/>
-                      </a:solidFill>
-                      <a:prstDash val="solid"/>
-                      <a:round/>
-                      <a:headEnd type="none" w="med" len="med"/>
-                      <a:tailEnd type="none" w="med" len="med"/>
-                    </a:lnR>
-                    <a:lnT w="12700" cap="flat" cmpd="sng" algn="ctr">
-                      <a:solidFill>
-                        <a:srgbClr val="C8C8C6"/>
-                      </a:solidFill>
-                      <a:prstDash val="solid"/>
-                      <a:round/>
-                      <a:headEnd type="none" w="med" len="med"/>
-                      <a:tailEnd type="none" w="med" len="med"/>
-                    </a:lnT>
-                    <a:lnB w="12700" cap="flat" cmpd="sng" algn="ctr">
-                      <a:solidFill>
-                        <a:srgbClr val="C8C8C6"/>
-                      </a:solidFill>
-                      <a:prstDash val="solid"/>
-                      <a:round/>
-                      <a:headEnd type="none" w="med" len="med"/>
-                      <a:tailEnd type="none" w="med" len="med"/>
-                    </a:lnB>
-                  </a:tcPr>
-                </a:tc>
-                <a:tc>
-                  <a:txBody>
-                    <a:bodyPr/>
-                    <a:lstStyle/>
-                    <a:p>
-                      <a:pPr indent="0" marL="0">
-                        <a:lnSpc>
-                          <a:spcPts val="1820"/>
-                        </a:lnSpc>
-                        <a:buNone/>
-                      </a:pPr>
-                      <a:r>
-                        <a:rPr lang="en-US" sz="1300" dirty="0">
-                          <a:solidFill>
-                            <a:srgbClr val="15213B"/>
-                          </a:solidFill>
-                          <a:latin typeface="Public Sans" pitchFamily="34" charset="0"/>
-                          <a:ea typeface="Public Sans" pitchFamily="34" charset="-122"/>
-                          <a:cs typeface="Public Sans" pitchFamily="34" charset="-120"/>
-                        </a:rPr>
-                        <a:t/>
-                      </a:r>
-                      <a:endParaRPr lang="en-US" sz="1300" dirty="0">
-                        <a:latin typeface="Public Sans" charset="0"/>
-                        <a:ea typeface="Public Sans" charset="0"/>
-                        <a:cs typeface="Public Sans" charset="0"/>
-                      </a:endParaRPr>
-                    </a:p>
-                  </a:txBody>
-                  <a:tcPr marL="57785" marR="57785" marT="57785" marB="57785" anchor="t">
-                    <a:lnL w="12700" cap="flat" cmpd="sng" algn="ctr">
-                      <a:solidFill>
-                        <a:srgbClr val="C8C8C6"/>
-                      </a:solidFill>
-                      <a:prstDash val="solid"/>
-                      <a:round/>
-                      <a:headEnd type="none" w="med" len="med"/>
-                      <a:tailEnd type="none" w="med" len="med"/>
-                    </a:lnL>
-                    <a:lnR w="12700" cap="flat" cmpd="sng" algn="ctr">
-                      <a:solidFill>
-                        <a:srgbClr val="C8C8C6"/>
-                      </a:solidFill>
-                      <a:prstDash val="solid"/>
-                      <a:round/>
-                      <a:headEnd type="none" w="med" len="med"/>
-                      <a:tailEnd type="none" w="med" len="med"/>
-                    </a:lnR>
-                    <a:lnT w="12700" cap="flat" cmpd="sng" algn="ctr">
-                      <a:solidFill>
-                        <a:srgbClr val="C8C8C6"/>
-                      </a:solidFill>
-                      <a:prstDash val="solid"/>
-                      <a:round/>
-                      <a:headEnd type="none" w="med" len="med"/>
-                      <a:tailEnd type="none" w="med" len="med"/>
-                    </a:lnT>
-                    <a:lnB w="12700" cap="flat" cmpd="sng" algn="ctr">
-                      <a:solidFill>
-                        <a:srgbClr val="C8C8C6"/>
-                      </a:solidFill>
-                      <a:prstDash val="solid"/>
-                      <a:round/>
-                      <a:headEnd type="none" w="med" len="med"/>
-                      <a:tailEnd type="none" w="med" len="med"/>
-                    </a:lnB>
-                  </a:tcPr>
-                </a:tc>
-                <a:tc>
-                  <a:txBody>
-                    <a:bodyPr/>
-                    <a:lstStyle/>
-                    <a:p>
-                      <a:pPr indent="0" marL="0">
-                        <a:lnSpc>
-                          <a:spcPts val="1820"/>
-                        </a:lnSpc>
-                        <a:buNone/>
-                      </a:pPr>
-                      <a:r>
-                        <a:rPr lang="en-US" sz="1300" dirty="0">
-                          <a:solidFill>
-                            <a:srgbClr val="15213B"/>
-                          </a:solidFill>
-                          <a:latin typeface="Public Sans" pitchFamily="34" charset="0"/>
-                          <a:ea typeface="Public Sans" pitchFamily="34" charset="-122"/>
-                          <a:cs typeface="Public Sans" pitchFamily="34" charset="-120"/>
-                        </a:rPr>
-                        <a:t/>
-                      </a:r>
-                      <a:endParaRPr lang="en-US" sz="1300" dirty="0">
-                        <a:latin typeface="Public Sans" charset="0"/>
-                        <a:ea typeface="Public Sans" charset="0"/>
-                        <a:cs typeface="Public Sans" charset="0"/>
-                      </a:endParaRPr>
-                    </a:p>
-                  </a:txBody>
-                  <a:tcPr marL="57785" marR="57785" marT="57785" marB="57785" anchor="t">
-                    <a:lnL w="12700" cap="flat" cmpd="sng" algn="ctr">
-                      <a:solidFill>
-                        <a:srgbClr val="C8C8C6"/>
-                      </a:solidFill>
-                      <a:prstDash val="solid"/>
-                      <a:round/>
-                      <a:headEnd type="none" w="med" len="med"/>
-                      <a:tailEnd type="none" w="med" len="med"/>
-                    </a:lnL>
-                    <a:lnR w="12700" cap="flat" cmpd="sng" algn="ctr">
-                      <a:solidFill>
-                        <a:srgbClr val="C8C8C6"/>
-                      </a:solidFill>
-                      <a:prstDash val="solid"/>
-                      <a:round/>
-                      <a:headEnd type="none" w="med" len="med"/>
-                      <a:tailEnd type="none" w="med" len="med"/>
-                    </a:lnR>
-                    <a:lnT w="12700" cap="flat" cmpd="sng" algn="ctr">
-                      <a:solidFill>
-                        <a:srgbClr val="C8C8C6"/>
-                      </a:solidFill>
-                      <a:prstDash val="solid"/>
-                      <a:round/>
-                      <a:headEnd type="none" w="med" len="med"/>
-                      <a:tailEnd type="none" w="med" len="med"/>
-                    </a:lnT>
-                    <a:lnB w="12700" cap="flat" cmpd="sng" algn="ctr">
-                      <a:solidFill>
-                        <a:srgbClr val="C8C8C6"/>
-                      </a:solidFill>
-                      <a:prstDash val="solid"/>
-                      <a:round/>
-                      <a:headEnd type="none" w="med" len="med"/>
-                      <a:tailEnd type="none" w="med" len="med"/>
-                    </a:lnB>
-                  </a:tcPr>
-                </a:tc>
-                <a:tc>
-                  <a:txBody>
-                    <a:bodyPr/>
-                    <a:lstStyle/>
-                    <a:p>
-                      <a:pPr indent="0" marL="0">
-                        <a:lnSpc>
-                          <a:spcPts val="1820"/>
-                        </a:lnSpc>
-                        <a:buNone/>
-                      </a:pPr>
-                      <a:r>
-                        <a:rPr lang="en-US" sz="1300" dirty="0">
-                          <a:solidFill>
-                            <a:srgbClr val="15213B"/>
-                          </a:solidFill>
-                          <a:latin typeface="Public Sans" pitchFamily="34" charset="0"/>
-                          <a:ea typeface="Public Sans" pitchFamily="34" charset="-122"/>
-                          <a:cs typeface="Public Sans" pitchFamily="34" charset="-120"/>
-                        </a:rPr>
-                        <a:t/>
-                      </a:r>
-                      <a:endParaRPr lang="en-US" sz="1300" dirty="0">
-                        <a:latin typeface="Public Sans" charset="0"/>
-                        <a:ea typeface="Public Sans" charset="0"/>
-                        <a:cs typeface="Public Sans" charset="0"/>
-                      </a:endParaRPr>
-                    </a:p>
-                  </a:txBody>
-                  <a:tcPr marL="57785" marR="57785" marT="57785" marB="57785" anchor="t">
-                    <a:lnL w="12700" cap="flat" cmpd="sng" algn="ctr">
-                      <a:solidFill>
-                        <a:srgbClr val="C8C8C6"/>
-                      </a:solidFill>
-                      <a:prstDash val="solid"/>
-                      <a:round/>
-                      <a:headEnd type="none" w="med" len="med"/>
-                      <a:tailEnd type="none" w="med" len="med"/>
-                    </a:lnL>
-                    <a:lnR w="12700" cap="flat" cmpd="sng" algn="ctr">
-                      <a:solidFill>
-                        <a:srgbClr val="C8C8C6"/>
-                      </a:solidFill>
-                      <a:prstDash val="solid"/>
-                      <a:round/>
-                      <a:headEnd type="none" w="med" len="med"/>
-                      <a:tailEnd type="none" w="med" len="med"/>
-                    </a:lnR>
-                    <a:lnT w="12700" cap="flat" cmpd="sng" algn="ctr">
-                      <a:solidFill>
-                        <a:srgbClr val="C8C8C6"/>
-                      </a:solidFill>
-                      <a:prstDash val="solid"/>
-                      <a:round/>
-                      <a:headEnd type="none" w="med" len="med"/>
-                      <a:tailEnd type="none" w="med" len="med"/>
-                    </a:lnT>
-                    <a:lnB w="12700" cap="flat" cmpd="sng" algn="ctr">
-                      <a:solidFill>
-                        <a:srgbClr val="C8C8C6"/>
-                      </a:solidFill>
-                      <a:prstDash val="solid"/>
-                      <a:round/>
-                      <a:headEnd type="none" w="med" len="med"/>
-                      <a:tailEnd type="none" w="med" len="med"/>
-                    </a:lnB>
-                  </a:tcPr>
-                </a:tc>
-                <a:tc>
-                  <a:txBody>
-                    <a:bodyPr/>
-                    <a:lstStyle/>
-                    <a:p>
-                      <a:pPr indent="0" marL="0">
-                        <a:lnSpc>
-                          <a:spcPts val="1820"/>
-                        </a:lnSpc>
-                        <a:buNone/>
-                      </a:pPr>
-                      <a:r>
-                        <a:rPr lang="en-US" sz="1300" dirty="0">
-                          <a:solidFill>
-                            <a:srgbClr val="15213B"/>
-                          </a:solidFill>
-                          <a:latin typeface="Public Sans" pitchFamily="34" charset="0"/>
-                          <a:ea typeface="Public Sans" pitchFamily="34" charset="-122"/>
-                          <a:cs typeface="Public Sans" pitchFamily="34" charset="-120"/>
-                        </a:rPr>
-                        <a:t/>
-                      </a:r>
-                      <a:endParaRPr lang="en-US" sz="1300" dirty="0">
-                        <a:latin typeface="Public Sans" charset="0"/>
-                        <a:ea typeface="Public Sans" charset="0"/>
-                        <a:cs typeface="Public Sans" charset="0"/>
-                      </a:endParaRPr>
-                    </a:p>
-                  </a:txBody>
-                  <a:tcPr marL="57785" marR="57785" marT="57785" marB="57785" anchor="t">
-                    <a:lnL w="12700" cap="flat" cmpd="sng" algn="ctr">
-                      <a:solidFill>
-                        <a:srgbClr val="C8C8C6"/>
-                      </a:solidFill>
-                      <a:prstDash val="solid"/>
-                      <a:round/>
-                      <a:headEnd type="none" w="med" len="med"/>
-                      <a:tailEnd type="none" w="med" len="med"/>
-                    </a:lnL>
-                    <a:lnR w="12700" cap="flat" cmpd="sng" algn="ctr">
-                      <a:solidFill>
-                        <a:srgbClr val="C8C8C6"/>
-                      </a:solidFill>
-                      <a:prstDash val="solid"/>
-                      <a:round/>
-                      <a:headEnd type="none" w="med" len="med"/>
-                      <a:tailEnd type="none" w="med" len="med"/>
-                    </a:lnR>
-                    <a:lnT w="12700" cap="flat" cmpd="sng" algn="ctr">
-                      <a:solidFill>
-                        <a:srgbClr val="C8C8C6"/>
-                      </a:solidFill>
-                      <a:prstDash val="solid"/>
-                      <a:round/>
-                      <a:headEnd type="none" w="med" len="med"/>
-                      <a:tailEnd type="none" w="med" len="med"/>
-                    </a:lnT>
-                    <a:lnB w="12700" cap="flat" cmpd="sng" algn="ctr">
-                      <a:solidFill>
-                        <a:srgbClr val="C8C8C6"/>
-                      </a:solidFill>
-                      <a:prstDash val="solid"/>
-                      <a:round/>
-                      <a:headEnd type="none" w="med" len="med"/>
-                      <a:tailEnd type="none" w="med" len="med"/>
-                    </a:lnB>
-                  </a:tcPr>
-                </a:tc>
-                <a:tc>
-                  <a:txBody>
-                    <a:bodyPr/>
-                    <a:lstStyle/>
-                    <a:p>
-                      <a:pPr indent="0" marL="0">
-                        <a:lnSpc>
-                          <a:spcPts val="1820"/>
-                        </a:lnSpc>
-                        <a:buNone/>
-                      </a:pPr>
-                      <a:r>
-                        <a:rPr lang="en-US" sz="1300" dirty="0">
-                          <a:solidFill>
-                            <a:srgbClr val="15213B"/>
-                          </a:solidFill>
-                          <a:latin typeface="Public Sans" pitchFamily="34" charset="0"/>
-                          <a:ea typeface="Public Sans" pitchFamily="34" charset="-122"/>
-                          <a:cs typeface="Public Sans" pitchFamily="34" charset="-120"/>
-                        </a:rPr>
-                        <a:t/>
-                      </a:r>
-                      <a:endParaRPr lang="en-US" sz="1300" dirty="0">
-                        <a:latin typeface="Public Sans" charset="0"/>
-                        <a:ea typeface="Public Sans" charset="0"/>
-                        <a:cs typeface="Public Sans" charset="0"/>
-                      </a:endParaRPr>
-                    </a:p>
-                  </a:txBody>
-                  <a:tcPr marL="57785" marR="57785" marT="57785" marB="57785" anchor="t">
-                    <a:lnL w="12700" cap="flat" cmpd="sng" algn="ctr">
-                      <a:solidFill>
-                        <a:srgbClr val="C8C8C6"/>
-                      </a:solidFill>
-                      <a:prstDash val="solid"/>
-                      <a:round/>
-                      <a:headEnd type="none" w="med" len="med"/>
-                      <a:tailEnd type="none" w="med" len="med"/>
-                    </a:lnL>
-                    <a:lnR w="12700" cap="flat" cmpd="sng" algn="ctr">
-                      <a:solidFill>
-                        <a:srgbClr val="C8C8C6"/>
-                      </a:solidFill>
-                      <a:prstDash val="solid"/>
-                      <a:round/>
-                      <a:headEnd type="none" w="med" len="med"/>
-                      <a:tailEnd type="none" w="med" len="med"/>
-                    </a:lnR>
-                    <a:lnT w="12700" cap="flat" cmpd="sng" algn="ctr">
-                      <a:solidFill>
-                        <a:srgbClr val="C8C8C6"/>
-                      </a:solidFill>
-                      <a:prstDash val="solid"/>
-                      <a:round/>
-                      <a:headEnd type="none" w="med" len="med"/>
-                      <a:tailEnd type="none" w="med" len="med"/>
-                    </a:lnT>
-                    <a:lnB w="12700" cap="flat" cmpd="sng" algn="ctr">
-                      <a:solidFill>
-                        <a:srgbClr val="C8C8C6"/>
-                      </a:solidFill>
-                      <a:prstDash val="solid"/>
-                      <a:round/>
-                      <a:headEnd type="none" w="med" len="med"/>
-                      <a:tailEnd type="none" w="med" len="med"/>
-                    </a:lnB>
-                  </a:tcPr>
-                </a:tc>
-              </a:tr>
             </a:tbl>
           </a:graphicData>
         </a:graphic>
@@ -17916,7 +17964,7 @@
         <p:spPr>
           <a:xfrm>
             <a:off x="812800" y="4114800"/>
-            <a:ext cx="10566400" cy="853380"/>
+            <a:ext cx="10566400" cy="1150000"/>
           </a:xfrm>
           <a:prstGeom prst="roundRect">
             <a:avLst>
@@ -17949,7 +17997,7 @@
                 <a:ea typeface="Public Sans" pitchFamily="34" charset="-122"/>
                 <a:cs typeface="Public Sans" pitchFamily="34" charset="-120"/>
               </a:rPr>
-              <a:t>[To be filled once Nuno's and Pedro's models are scored: which model wins, and what it means for dispatch — share of fatal crashes reached with 15% of ALS capacity, and cost vs. p*]</a:t>
+              <a:t>Best so far: Gradient Boosting reaches 31.5% of fatal crashes with 15% of ALS capacity (225 of 715 in 2024–25), 2.1× random, 3 more than the baseline. Small gain: with only road, location and time at t=0, the data limits ranking more than the algorithm. [Nuno: add Model 2 and final winner]</a:t>
             </a:r>
             <a:endParaRPr lang="en-US" sz="1400" dirty="0"/>
           </a:p>

</xml_diff>

<commit_message>
Add non-tree models and originality analysis to Task 3 (Person 5)
- Section 7.2: bag of 5 undersampled MLPs and LDA, tuned on validation,
  sigmoid-calibrated, scored once on test 2024-2025
- Section 7.3: final comparison of all models, winner chosen on validation
  (Gradient Boosting)
- Section 8: cost-benefit of ALS capacity, GPS hotspot grid checked
  out-of-time, interactive Folium map, value of GPS location risk
- Slides 17, 18, 21, 22, 26 filled; two originality slides added (23, 24)
- Notebook run on Python 3.13 / scikit-learn 1.9 (matches Pedro's results);
  folium added to requirements

Co-Authored-By: Claude Opus 5.5 <noreply@anthropic.com>
</commit_message>
<xml_diff>
--- a/reports/presentation/Road Safety Predictive Analytics — Group 6.pptx
+++ b/reports/presentation/Road Safety Predictive Analytics — Group 6.pptx
@@ -27,6 +27,8 @@
     <p:sldId id="280" r:id="rId35"/>
     <p:sldId id="281" r:id="rId36"/>
     <p:sldId id="282" r:id="rId37"/>
+    <p:sldId id="284" r:id="rId39"/>
+    <p:sldId id="285" r:id="rId40"/>
     <p:sldId id="272" r:id="rId18"/>
     <p:sldId id="273" r:id="rId19"/>
     <p:sldId id="283" r:id="rId38"/>
@@ -10017,7 +10019,7 @@
                 <a:ea typeface="Public Sans" pitchFamily="34" charset="-122"/>
                 <a:cs typeface="Public Sans" pitchFamily="34" charset="-120"/>
               </a:rPr>
-              <a:t>Gradient Boosting (Pedro): PR-AUC 0.126, lift 2.10× on 2024–25 · [Nuno's model to add]</a:t>
+              <a:t>Gradient Boosting (Pedro): PR-AUC 0.126, lift 2.10× · MLP (Nuno): PR-AUC 0.118, lift 2.08×</a:t>
             </a:r>
             <a:endParaRPr lang="en-US" sz="1200" dirty="0"/>
           </a:p>
@@ -11590,7 +11592,7 @@
                           <a:ea typeface="Public Sans" pitchFamily="34" charset="-122"/>
                           <a:cs typeface="Public Sans" pitchFamily="34" charset="-120"/>
                         </a:rPr>
-                        <a:t>Model 2 — [Nuno]</a:t>
+                        <a:t>Model 2 — MLP neural network (Nuno)</a:t>
                       </a:r>
                       <a:endParaRPr lang="en-US" sz="1300" dirty="0">
                         <a:latin typeface="Public Sans" charset="0"/>
@@ -11658,7 +11660,7 @@
                           <a:ea typeface="Public Sans" pitchFamily="34" charset="-122"/>
                           <a:cs typeface="Public Sans" pitchFamily="34" charset="-120"/>
                         </a:rPr>
-                        <a:t>[to fill]</a:t>
+                        <a:t>Different bias from trees: smooth combinations of all features; bag of 5 networks on undersampled data; LDA tested alongside</a:t>
                       </a:r>
                       <a:endParaRPr lang="en-US" sz="1300" dirty="0">
                         <a:latin typeface="Public Sans" charset="0"/>
@@ -11726,7 +11728,7 @@
                           <a:ea typeface="Public Sans" pitchFamily="34" charset="-122"/>
                           <a:cs typeface="Public Sans" pitchFamily="34" charset="-120"/>
                         </a:rPr>
-                        <a:t>[ ] Nuno</a:t>
+                        <a:t>✓ Done (Nuno)</a:t>
                       </a:r>
                       <a:endParaRPr lang="en-US" sz="1300" dirty="0">
                         <a:latin typeface="Public Sans" charset="0"/>
@@ -15508,7 +15510,7 @@
                 <a:ea typeface="Libre Baskerville" pitchFamily="18" charset="-122"/>
                 <a:cs typeface="Libre Baskerville" pitchFamily="18" charset="-120"/>
               </a:rPr>
-              <a:t>Model 2 — [Nuno: model name]</a:t>
+              <a:t>Model 2 — MLP neural network (non-tree)</a:t>
             </a:r>
             <a:endParaRPr lang="en-US" sz="3000" dirty="0"/>
           </a:p>
@@ -15553,7 +15555,7 @@
                 <a:ea typeface="Public Sans" pitchFamily="34" charset="-122"/>
                 <a:cs typeface="Public Sans" pitchFamily="34" charset="-120"/>
               </a:rPr>
-              <a:t>[To be filled by Nuno]</a:t>
+              <a:t>Bag of 5 MLPs (32 → 16 neurons) on the one-hot encoded, scaled features; compared with LDA (linear discriminant analysis).</a:t>
             </a:r>
             <a:endParaRPr lang="en-US" sz="1300" dirty="0"/>
           </a:p>
@@ -15574,7 +15576,7 @@
                 <a:ea typeface="Public Sans" pitchFamily="34" charset="-122"/>
                 <a:cs typeface="Public Sans" pitchFamily="34" charset="-120"/>
               </a:rPr>
-              <a:t>[Model chosen and why it fits the problem]</a:t>
+              <a:t>Why: a different bias from trees (smooth combinations of all features), so it tests whether the ceiling is the algorithm or the data.</a:t>
             </a:r>
             <a:endParaRPr lang="en-US" sz="1300" dirty="0"/>
           </a:p>
@@ -15595,7 +15597,7 @@
                 <a:ea typeface="Public Sans" pitchFamily="34" charset="-122"/>
                 <a:cs typeface="Public Sans" pitchFamily="34" charset="-120"/>
               </a:rPr>
-              <a:t>[Tuning on validation 2022–2023: what was tried, what was kept]</a:t>
+              <a:t>Imbalance &amp; tuning on validation 2022–23: each network sees all fatal crashes + an equal random sample of non-fatal ones; 8 configs. One network varied 0.115–0.125 PR-AUC by seed alone; the average of 5 gave 0.130.</a:t>
             </a:r>
             <a:endParaRPr lang="en-US" sz="1300" dirty="0"/>
           </a:p>
@@ -15616,7 +15618,7 @@
                 <a:ea typeface="Public Sans" pitchFamily="34" charset="-122"/>
                 <a:cs typeface="Public Sans" pitchFamily="34" charset="-120"/>
               </a:rPr>
-              <a:t>[Validation results: PR-AUC, recall &amp; lift @ top 15%, Brier after calibration]</a:t>
+              <a:t>Validation: PR-AUC 0.130, lift 2.17×. Test 2024–25: PR-AUC 0.118, recall 31.2%, lift 2.08×, Brier 0.065 after sigmoid calibration. LDA: lift 1.88×.</a:t>
             </a:r>
             <a:endParaRPr lang="en-US" sz="1300" dirty="0"/>
           </a:p>
@@ -15637,7 +15639,7 @@
                 <a:ea typeface="Public Sans" pitchFamily="34" charset="-122"/>
                 <a:cs typeface="Public Sans" pitchFamily="34" charset="-120"/>
               </a:rPr>
-              <a:t>[What the model learned: most important features]</a:t>
+              <a:t>Top drivers: time of day, roadway type, segment risk, downhill / uphill — the same as Gradient Boosting.</a:t>
             </a:r>
             <a:endParaRPr lang="en-US" sz="1300" dirty="0"/>
           </a:p>
@@ -15731,6 +15733,54 @@
           </a:p>
         </p:txBody>
       </p:sp>
+      <p:pic>
+        <p:nvPicPr>
+          <p:cNvPr id="7" name="Picture 6" descr="task3_nontree_pr_curve.png"/>
+          <p:cNvPicPr>
+            <a:picLocks noChangeAspect="1"/>
+          </p:cNvPicPr>
+          <p:nvPr/>
+        </p:nvPicPr>
+        <p:blipFill>
+          <a:blip r:embed="rId2"/>
+          <a:stretch>
+            <a:fillRect/>
+          </a:stretch>
+        </p:blipFill>
+        <p:spPr>
+          <a:xfrm>
+            <a:off x="910844" y="3500000"/>
+            <a:ext cx="3309184" cy="2350000"/>
+          </a:xfrm>
+          <a:prstGeom prst="rect">
+            <a:avLst/>
+          </a:prstGeom>
+        </p:spPr>
+      </p:pic>
+      <p:pic>
+        <p:nvPicPr>
+          <p:cNvPr id="8" name="Picture 7" descr="task3_nontree_feature_importance.png"/>
+          <p:cNvPicPr>
+            <a:picLocks noChangeAspect="1"/>
+          </p:cNvPicPr>
+          <p:nvPr/>
+        </p:nvPicPr>
+        <p:blipFill>
+          <a:blip r:embed="rId3"/>
+          <a:stretch>
+            <a:fillRect/>
+          </a:stretch>
+        </p:blipFill>
+        <p:spPr>
+          <a:xfrm>
+            <a:off x="4500844" y="3500000"/>
+            <a:ext cx="5702347" cy="2350000"/>
+          </a:xfrm>
+          <a:prstGeom prst="rect">
+            <a:avLst/>
+          </a:prstGeom>
+        </p:spPr>
+      </p:pic>
     </p:spTree>
   </p:cSld>
   <p:clrMapOvr>
@@ -17562,7 +17612,7 @@
                           <a:ea typeface="Public Sans" pitchFamily="34" charset="-122"/>
                           <a:cs typeface="Public Sans" pitchFamily="34" charset="-120"/>
                         </a:rPr>
-                        <a:t>Model 2 — [Nuno]</a:t>
+                        <a:t>Model 2 — MLP neural net (5-bag) + calibration</a:t>
                       </a:r>
                       <a:endParaRPr lang="en-US" sz="1300" dirty="0">
                         <a:latin typeface="Public Sans" charset="0"/>
@@ -17630,7 +17680,7 @@
                           <a:ea typeface="Public Sans" pitchFamily="34" charset="-122"/>
                           <a:cs typeface="Public Sans" pitchFamily="34" charset="-120"/>
                         </a:rPr>
-                        <a:t/>
+                        <a:t>0.665</a:t>
                       </a:r>
                       <a:endParaRPr lang="en-US" sz="1300" dirty="0">
                         <a:latin typeface="Public Sans" charset="0"/>
@@ -17698,7 +17748,7 @@
                           <a:ea typeface="Public Sans" pitchFamily="34" charset="-122"/>
                           <a:cs typeface="Public Sans" pitchFamily="34" charset="-120"/>
                         </a:rPr>
-                        <a:t/>
+                        <a:t>0.118</a:t>
                       </a:r>
                       <a:endParaRPr lang="en-US" sz="1300" dirty="0">
                         <a:latin typeface="Public Sans" charset="0"/>
@@ -17766,7 +17816,7 @@
                           <a:ea typeface="Public Sans" pitchFamily="34" charset="-122"/>
                           <a:cs typeface="Public Sans" pitchFamily="34" charset="-120"/>
                         </a:rPr>
-                        <a:t/>
+                        <a:t>31.2%</a:t>
                       </a:r>
                       <a:endParaRPr lang="en-US" sz="1300" dirty="0">
                         <a:latin typeface="Public Sans" charset="0"/>
@@ -17834,7 +17884,7 @@
                           <a:ea typeface="Public Sans" pitchFamily="34" charset="-122"/>
                           <a:cs typeface="Public Sans" pitchFamily="34" charset="-120"/>
                         </a:rPr>
-                        <a:t/>
+                        <a:t>2.08×</a:t>
                       </a:r>
                       <a:endParaRPr lang="en-US" sz="1300" dirty="0">
                         <a:latin typeface="Public Sans" charset="0"/>
@@ -17902,7 +17952,7 @@
                           <a:ea typeface="Public Sans" pitchFamily="34" charset="-122"/>
                           <a:cs typeface="Public Sans" pitchFamily="34" charset="-120"/>
                         </a:rPr>
-                        <a:t/>
+                        <a:t>0.065</a:t>
                       </a:r>
                       <a:endParaRPr lang="en-US" sz="1300" dirty="0">
                         <a:latin typeface="Public Sans" charset="0"/>
@@ -17997,7 +18047,7 @@
                 <a:ea typeface="Public Sans" pitchFamily="34" charset="-122"/>
                 <a:cs typeface="Public Sans" pitchFamily="34" charset="-120"/>
               </a:rPr>
-              <a:t>Best so far: Gradient Boosting reaches 31.5% of fatal crashes with 15% of ALS capacity (225 of 715 in 2024–25), 2.1× random, 3 more than the baseline. Small gain: with only road, location and time at t=0, the data limits ranking more than the algorithm. [Nuno: add Model 2 and final winner]</a:t>
+              <a:t>Winner, chosen on validation 2022–23 and confirmed on test: Gradient Boosting reaches 31.5% of fatal crashes with 15% of ALS capacity (225 of 715 in 2024–25), 2.1× random. The MLP reaches 223 and the baseline 222: three model families hit the same ceiling — with only road, location and time at t=0, the data limits ranking, not the algorithm. Random Forest (2.08×) and LDA (1.88×) are in the notebook.</a:t>
             </a:r>
             <a:endParaRPr lang="en-US" sz="1400" dirty="0"/>
           </a:p>
@@ -18492,7 +18542,7 @@
                 <a:ea typeface="Public Sans" pitchFamily="34" charset="-122"/>
                 <a:cs typeface="Public Sans" pitchFamily="34" charset="-120"/>
               </a:rPr>
-              <a:t>[After the final models — e.g. best model reaches X% of fatal crashes with 15% of ALS capacity]</a:t>
+              <a:t>Gradient Boosting: 31.5% of fatal crashes with 15% of ALS capacity (2.1× random); MLP &amp; LR within 3 crashes</a:t>
             </a:r>
             <a:endParaRPr lang="en-US" sz="1300" dirty="0"/>
           </a:p>
@@ -18611,7 +18661,7 @@
                 <a:ea typeface="Public Sans" pitchFamily="34" charset="-122"/>
                 <a:cs typeface="Public Sans" pitchFamily="34" charset="-120"/>
               </a:rPr>
-              <a:t>[What dispatch should do — e.g. send ALS to the top-15% risk calls]</a:t>
+              <a:t>Send ALS to the top-15% risk calls (≈ €585k per 1,000 calls vs. random) · base ALS near North-East hotspots</a:t>
             </a:r>
             <a:endParaRPr lang="en-US" sz="1300" dirty="0"/>
           </a:p>
@@ -18849,7 +18899,7 @@
                 <a:ea typeface="Public Sans" pitchFamily="34" charset="-122"/>
                 <a:cs typeface="Public Sans" pitchFamily="34" charset="-120"/>
               </a:rPr>
-              <a:t>Add weather, traffic and caller details at call intake · finer location once GPS covers all years · test training on 2015+ only</a:t>
+              <a:t>Collect GPS at every call and retrain with location risk (test PR-AUC 0.131 → 0.141) · add weather, traffic &amp; caller details</a:t>
             </a:r>
             <a:endParaRPr lang="en-US" sz="1300" dirty="0"/>
           </a:p>
@@ -18937,7 +18987,7 @@
                 <a:ea typeface="Public Sans" pitchFamily="34" charset="-122"/>
                 <a:cs typeface="Public Sans" pitchFamily="34" charset="-120"/>
               </a:rPr>
-              <a:t>24</a:t>
+              <a:t>26</a:t>
             </a:r>
             <a:endParaRPr lang="en-US" sz="1200" dirty="0"/>
           </a:p>
@@ -19898,7 +19948,7 @@
                 <a:ea typeface="Public Sans" pitchFamily="34" charset="-122"/>
                 <a:cs typeface="Public Sans" pitchFamily="34" charset="-120"/>
               </a:rPr>
-              <a:t>26</a:t>
+              <a:t>28</a:t>
             </a:r>
             <a:endParaRPr lang="en-US" sz="1200" dirty="0"/>
           </a:p>
@@ -20744,7 +20794,7 @@
                 <a:ea typeface="Public Sans" pitchFamily="34" charset="-122"/>
                 <a:cs typeface="Public Sans" pitchFamily="34" charset="-120"/>
               </a:rPr>
-              <a:t>27</a:t>
+              <a:t>29</a:t>
             </a:r>
             <a:endParaRPr lang="en-US" sz="1200" dirty="0"/>
           </a:p>
@@ -20924,6 +20974,334 @@
 </p:sld>
 </file>
 
+<file path=ppt/slides/slide29.xml><?xml version="1.0" encoding="utf-8"?>
+<p:sld xmlns:a="http://schemas.openxmlformats.org/drawingml/2006/main" xmlns:p="http://schemas.openxmlformats.org/presentationml/2006/main" xmlns:r="http://schemas.openxmlformats.org/officeDocument/2006/relationships">
+  <p:cSld>
+    <p:spTree>
+      <p:nvGrpSpPr>
+        <p:cNvPr id="1" name=""/>
+        <p:cNvGrpSpPr/>
+        <p:nvPr/>
+      </p:nvGrpSpPr>
+      <p:grpSpPr/>
+      <p:sp>
+        <p:nvSpPr>
+          <p:cNvPr id="2" name="Text 0"/>
+          <p:cNvSpPr/>
+          <p:nvPr/>
+        </p:nvSpPr>
+        <p:spPr>
+          <a:xfrm>
+            <a:off x="812800" y="812800"/>
+            <a:ext cx="10883392" cy="238720"/>
+          </a:xfrm>
+          <a:prstGeom prst="rect">
+            <a:avLst/>
+          </a:prstGeom>
+          <a:noFill/>
+          <a:ln/>
+        </p:spPr>
+        <p:txBody>
+          <a:bodyPr wrap="square" lIns="0" tIns="0" rIns="0" bIns="0" rtlCol="0" anchor="t">
+            <a:normAutofit/>
+          </a:bodyPr>
+          <a:lstStyle/>
+          <a:p>
+            <a:pPr algn="l" indent="0" marL="0">
+              <a:lnSpc>
+                <a:spcPts val="1680"/>
+              </a:lnSpc>
+              <a:buNone/>
+            </a:pPr>
+            <a:r>
+              <a:rPr lang="en-US" sz="1200" b="1" spc="150" kern="0" dirty="0">
+                <a:solidFill>
+                  <a:srgbClr val="15213B"/>
+                </a:solidFill>
+                <a:latin typeface="Public Sans" pitchFamily="34" charset="0"/>
+                <a:ea typeface="Public Sans" pitchFamily="34" charset="-122"/>
+                <a:cs typeface="Public Sans" pitchFamily="34" charset="-120"/>
+              </a:rPr>
+              <a:t>04 · ORIGINALITY</a:t>
+            </a:r>
+            <a:endParaRPr lang="en-US" sz="1200" dirty="0"/>
+          </a:p>
+        </p:txBody>
+      </p:sp>
+      <p:sp>
+        <p:nvSpPr>
+          <p:cNvPr id="3" name="Text 1"/>
+          <p:cNvSpPr/>
+          <p:nvPr>
+            <p:ph type="title"/>
+          </p:nvPr>
+        </p:nvSpPr>
+        <p:spPr>
+          <a:xfrm>
+            <a:off x="812800" y="1026120"/>
+            <a:ext cx="10883392" cy="463550"/>
+          </a:xfrm>
+          <a:prstGeom prst="rect">
+            <a:avLst/>
+          </a:prstGeom>
+          <a:noFill/>
+          <a:ln/>
+        </p:spPr>
+        <p:txBody>
+          <a:bodyPr wrap="square" lIns="0" tIns="0" rIns="0" bIns="0" rtlCol="0" anchor="t">
+            <a:normAutofit/>
+          </a:bodyPr>
+          <a:lstStyle/>
+          <a:p>
+            <a:pPr algn="l" indent="0" marL="0">
+              <a:lnSpc>
+                <a:spcPts val="3450"/>
+              </a:lnSpc>
+              <a:buNone/>
+            </a:pPr>
+            <a:r>
+              <a:rPr lang="en-US" sz="3000" b="1" i="0" dirty="0">
+                <a:solidFill>
+                  <a:srgbClr val="15213B"/>
+                </a:solidFill>
+                <a:latin typeface="Libre Baskerville" pitchFamily="18" charset="0"/>
+                <a:ea typeface="Libre Baskerville" pitchFamily="18" charset="-122"/>
+                <a:cs typeface="Libre Baskerville" pitchFamily="18" charset="-120"/>
+              </a:rPr>
+              <a:t>What is the model worth? Cost-benefit of ALS capacity</a:t>
+            </a:r>
+            <a:endParaRPr lang="en-US" sz="3000" dirty="0"/>
+          </a:p>
+        </p:txBody>
+      </p:sp>
+      <p:sp>
+        <p:nvSpPr>
+          <p:cNvPr id="4" name="Text 2"/>
+          <p:cNvSpPr/>
+          <p:nvPr/>
+        </p:nvSpPr>
+        <p:spPr>
+          <a:xfrm>
+            <a:off x="6400000" y="1642070"/>
+            <a:ext cx="5288572" cy="4300000"/>
+          </a:xfrm>
+          <a:prstGeom prst="rect">
+            <a:avLst/>
+          </a:prstGeom>
+          <a:noFill/>
+          <a:ln/>
+        </p:spPr>
+        <p:txBody>
+          <a:bodyPr wrap="square" lIns="0" tIns="0" rIns="0" bIns="0" rtlCol="0" anchor="t">
+            <a:normAutofit/>
+          </a:bodyPr>
+          <a:lstStyle/>
+          <a:p>
+            <a:pPr algn="l" marL="155956" indent="-155956">
+              <a:lnSpc>
+                <a:spcPts val="1950"/>
+              </a:lnSpc>
+              <a:buSzPct val="100000"/>
+              <a:buChar char="•"/>
+            </a:pPr>
+            <a:r>
+              <a:rPr lang="en-US" sz="1300" dirty="0">
+                <a:solidFill>
+                  <a:srgbClr val="46516B"/>
+                </a:solidFill>
+                <a:latin typeface="Public Sans" pitchFamily="34" charset="0"/>
+                <a:ea typeface="Public Sans" pitchFamily="34" charset="-122"/>
+                <a:cs typeface="Public Sans" pitchFamily="34" charset="-120"/>
+              </a:rPr>
+              <a:t>At 15% capacity, an ALS unit sent by the model reaches a fatal crash 14.9% of the time — vs. 7.1% when sent at random.</a:t>
+            </a:r>
+            <a:endParaRPr lang="en-US" sz="1300" dirty="0"/>
+          </a:p>
+          <a:p>
+            <a:pPr algn="l" marL="155956" indent="-155956">
+              <a:lnSpc>
+                <a:spcPts val="1950"/>
+              </a:lnSpc>
+              <a:buSzPct val="100000"/>
+              <a:buChar char="•"/>
+            </a:pPr>
+            <a:r>
+              <a:rPr lang="en-US" sz="1300" dirty="0">
+                <a:solidFill>
+                  <a:srgbClr val="46516B"/>
+                </a:solidFill>
+                <a:latin typeface="Public Sans" pitchFamily="34" charset="0"/>
+                <a:ea typeface="Public Sans" pitchFamily="34" charset="-122"/>
+                <a:cs typeface="Public Sans" pitchFamily="34" charset="-120"/>
+              </a:rPr>
+              <a:t>≈ €585k of value added per 1,000 calls vs. random dispatch (€2,500 per ALS, €50,000 per fatal crash reached).</a:t>
+            </a:r>
+            <a:endParaRPr lang="en-US" sz="1300" dirty="0"/>
+          </a:p>
+          <a:p>
+            <a:pPr algn="l" marL="155956" indent="-155956">
+              <a:lnSpc>
+                <a:spcPts val="1950"/>
+              </a:lnSpc>
+              <a:buSzPct val="100000"/>
+              <a:buChar char="•"/>
+            </a:pPr>
+            <a:r>
+              <a:rPr lang="en-US" sz="1300" dirty="0">
+                <a:solidFill>
+                  <a:srgbClr val="46516B"/>
+                </a:solidFill>
+                <a:latin typeface="Public Sans" pitchFamily="34" charset="0"/>
+                <a:ea typeface="Public Sans" pitchFamily="34" charset="-122"/>
+                <a:cs typeface="Public Sans" pitchFamily="34" charset="-120"/>
+              </a:rPr>
+              <a:t>Robust to the €50k assumption: dispatch pays off once reaching a fatal crash is worth &gt; €16.8k with the model, vs. &gt; €35.2k at random.</a:t>
+            </a:r>
+            <a:endParaRPr lang="en-US" sz="1300" dirty="0"/>
+          </a:p>
+          <a:p>
+            <a:pPr algn="l" marL="155956" indent="-155956">
+              <a:lnSpc>
+                <a:spcPts val="1950"/>
+              </a:lnSpc>
+              <a:buSzPct val="100000"/>
+              <a:buChar char="•"/>
+            </a:pPr>
+            <a:r>
+              <a:rPr lang="en-US" sz="1300" dirty="0">
+                <a:solidFill>
+                  <a:srgbClr val="46516B"/>
+                </a:solidFill>
+                <a:latin typeface="Public Sans" pitchFamily="34" charset="0"/>
+                <a:ea typeface="Public Sans" pitchFamily="34" charset="-122"/>
+                <a:cs typeface="Public Sans" pitchFamily="34" charset="-120"/>
+              </a:rPr>
+              <a:t>Net benefit peaks at ~64% capacity: ALS is undersized, with diminishing returns — the first 15% is worth €743k per 1,000 calls, the next 10% only €278k more.</a:t>
+            </a:r>
+            <a:endParaRPr lang="en-US" sz="1300" dirty="0"/>
+          </a:p>
+        </p:txBody>
+      </p:sp>
+      <p:sp>
+        <p:nvSpPr>
+          <p:cNvPr id="5" name="Text 3"/>
+          <p:cNvSpPr/>
+          <p:nvPr/>
+        </p:nvSpPr>
+        <p:spPr>
+          <a:xfrm>
+            <a:off x="812800" y="6238280"/>
+            <a:ext cx="4057174" cy="238720"/>
+          </a:xfrm>
+          <a:prstGeom prst="rect">
+            <a:avLst/>
+          </a:prstGeom>
+          <a:noFill/>
+          <a:ln/>
+        </p:spPr>
+        <p:txBody>
+          <a:bodyPr wrap="square" lIns="0" tIns="0" rIns="0" bIns="0" rtlCol="0" anchor="t">
+            <a:normAutofit/>
+          </a:bodyPr>
+          <a:lstStyle/>
+          <a:p>
+            <a:pPr algn="l" indent="0" marL="0">
+              <a:lnSpc>
+                <a:spcPts val="1680"/>
+              </a:lnSpc>
+              <a:buNone/>
+            </a:pPr>
+            <a:r>
+              <a:rPr lang="en-US" sz="1200" dirty="0">
+                <a:solidFill>
+                  <a:srgbClr val="8B9099"/>
+                </a:solidFill>
+                <a:latin typeface="Public Sans" pitchFamily="34" charset="0"/>
+                <a:ea typeface="Public Sans" pitchFamily="34" charset="-122"/>
+                <a:cs typeface="Public Sans" pitchFamily="34" charset="-120"/>
+              </a:rPr>
+              <a:t>Road Safety Predictive Analytics — Group 6</a:t>
+            </a:r>
+            <a:endParaRPr lang="en-US" sz="1200" dirty="0"/>
+          </a:p>
+        </p:txBody>
+      </p:sp>
+      <p:sp>
+        <p:nvSpPr>
+          <p:cNvPr id="6" name="Text 4"/>
+          <p:cNvSpPr/>
+          <p:nvPr/>
+        </p:nvSpPr>
+        <p:spPr>
+          <a:xfrm>
+            <a:off x="11221145" y="6238280"/>
+            <a:ext cx="208855" cy="238720"/>
+          </a:xfrm>
+          <a:prstGeom prst="rect">
+            <a:avLst/>
+          </a:prstGeom>
+          <a:noFill/>
+          <a:ln/>
+        </p:spPr>
+        <p:txBody>
+          <a:bodyPr wrap="square" lIns="0" tIns="0" rIns="0" bIns="0" rtlCol="0" anchor="t">
+            <a:normAutofit/>
+          </a:bodyPr>
+          <a:lstStyle/>
+          <a:p>
+            <a:pPr algn="l" indent="0" marL="0">
+              <a:lnSpc>
+                <a:spcPts val="1680"/>
+              </a:lnSpc>
+              <a:buNone/>
+            </a:pPr>
+            <a:r>
+              <a:rPr lang="en-US" sz="1200" dirty="0">
+                <a:solidFill>
+                  <a:srgbClr val="8B9099"/>
+                </a:solidFill>
+                <a:latin typeface="Public Sans" pitchFamily="34" charset="0"/>
+                <a:ea typeface="Public Sans" pitchFamily="34" charset="-122"/>
+                <a:cs typeface="Public Sans" pitchFamily="34" charset="-120"/>
+              </a:rPr>
+              <a:t>23</a:t>
+            </a:r>
+            <a:endParaRPr lang="en-US" sz="1200" dirty="0"/>
+          </a:p>
+        </p:txBody>
+      </p:sp>
+      <p:pic>
+        <p:nvPicPr>
+          <p:cNvPr id="7" name="Picture 6" descr="task3_value_vs_capacity.png"/>
+          <p:cNvPicPr>
+            <a:picLocks noChangeAspect="1"/>
+          </p:cNvPicPr>
+          <p:nvPr/>
+        </p:nvPicPr>
+        <p:blipFill>
+          <a:blip r:embed="rId2"/>
+          <a:stretch>
+            <a:fillRect/>
+          </a:stretch>
+        </p:blipFill>
+        <p:spPr>
+          <a:xfrm>
+            <a:off x="812800" y="1642070"/>
+            <a:ext cx="5400000" cy="3349367"/>
+          </a:xfrm>
+          <a:prstGeom prst="rect">
+            <a:avLst/>
+          </a:prstGeom>
+        </p:spPr>
+      </p:pic>
+    </p:spTree>
+  </p:cSld>
+  <p:clrMapOvr>
+    <a:masterClrMapping/>
+  </p:clrMapOvr>
+</p:sld>
+</file>
+
 <file path=ppt/slides/slide3.xml><?xml version="1.0" encoding="utf-8"?>
 <p:sld xmlns:a="http://schemas.openxmlformats.org/drawingml/2006/main" xmlns:r="http://schemas.openxmlformats.org/officeDocument/2006/relationships" xmlns:p="http://schemas.openxmlformats.org/presentationml/2006/main">
   <p:cSld name="Slide 3">
@@ -21451,6 +21829,355 @@
           </a:p>
         </p:txBody>
       </p:sp>
+    </p:spTree>
+  </p:cSld>
+  <p:clrMapOvr>
+    <a:masterClrMapping/>
+  </p:clrMapOvr>
+</p:sld>
+</file>
+
+<file path=ppt/slides/slide30.xml><?xml version="1.0" encoding="utf-8"?>
+<p:sld xmlns:a="http://schemas.openxmlformats.org/drawingml/2006/main" xmlns:p="http://schemas.openxmlformats.org/presentationml/2006/main" xmlns:r="http://schemas.openxmlformats.org/officeDocument/2006/relationships">
+  <p:cSld>
+    <p:spTree>
+      <p:nvGrpSpPr>
+        <p:cNvPr id="1" name=""/>
+        <p:cNvGrpSpPr/>
+        <p:nvPr/>
+      </p:nvGrpSpPr>
+      <p:grpSpPr/>
+      <p:sp>
+        <p:nvSpPr>
+          <p:cNvPr id="2" name="Text 0"/>
+          <p:cNvSpPr/>
+          <p:nvPr/>
+        </p:nvSpPr>
+        <p:spPr>
+          <a:xfrm>
+            <a:off x="812800" y="812800"/>
+            <a:ext cx="10883392" cy="238720"/>
+          </a:xfrm>
+          <a:prstGeom prst="rect">
+            <a:avLst/>
+          </a:prstGeom>
+          <a:noFill/>
+          <a:ln/>
+        </p:spPr>
+        <p:txBody>
+          <a:bodyPr wrap="square" lIns="0" tIns="0" rIns="0" bIns="0" rtlCol="0" anchor="t">
+            <a:normAutofit/>
+          </a:bodyPr>
+          <a:lstStyle/>
+          <a:p>
+            <a:pPr algn="l" indent="0" marL="0">
+              <a:lnSpc>
+                <a:spcPts val="1680"/>
+              </a:lnSpc>
+              <a:buNone/>
+            </a:pPr>
+            <a:r>
+              <a:rPr lang="en-US" sz="1200" b="1" spc="150" kern="0" dirty="0">
+                <a:solidFill>
+                  <a:srgbClr val="15213B"/>
+                </a:solidFill>
+                <a:latin typeface="Public Sans" pitchFamily="34" charset="0"/>
+                <a:ea typeface="Public Sans" pitchFamily="34" charset="-122"/>
+                <a:cs typeface="Public Sans" pitchFamily="34" charset="-120"/>
+              </a:rPr>
+              <a:t>04 · ORIGINALITY</a:t>
+            </a:r>
+            <a:endParaRPr lang="en-US" sz="1200" dirty="0"/>
+          </a:p>
+        </p:txBody>
+      </p:sp>
+      <p:sp>
+        <p:nvSpPr>
+          <p:cNvPr id="3" name="Text 1"/>
+          <p:cNvSpPr/>
+          <p:nvPr>
+            <p:ph type="title"/>
+          </p:nvPr>
+        </p:nvSpPr>
+        <p:spPr>
+          <a:xfrm>
+            <a:off x="812800" y="1026120"/>
+            <a:ext cx="10883392" cy="463550"/>
+          </a:xfrm>
+          <a:prstGeom prst="rect">
+            <a:avLst/>
+          </a:prstGeom>
+          <a:noFill/>
+          <a:ln/>
+        </p:spPr>
+        <p:txBody>
+          <a:bodyPr wrap="square" lIns="0" tIns="0" rIns="0" bIns="0" rtlCol="0" anchor="t">
+            <a:normAutofit/>
+          </a:bodyPr>
+          <a:lstStyle/>
+          <a:p>
+            <a:pPr algn="l" indent="0" marL="0">
+              <a:lnSpc>
+                <a:spcPts val="3450"/>
+              </a:lnSpc>
+              <a:buNone/>
+            </a:pPr>
+            <a:r>
+              <a:rPr lang="en-US" sz="3000" b="1" i="0" dirty="0">
+                <a:solidFill>
+                  <a:srgbClr val="15213B"/>
+                </a:solidFill>
+                <a:latin typeface="Libre Baskerville" pitchFamily="18" charset="0"/>
+                <a:ea typeface="Libre Baskerville" pitchFamily="18" charset="-122"/>
+                <a:cs typeface="Libre Baskerville" pitchFamily="18" charset="-120"/>
+              </a:rPr>
+              <a:t>Fatal hotspots persist — and GPS is the missing signal</a:t>
+            </a:r>
+            <a:endParaRPr lang="en-US" sz="3000" dirty="0"/>
+          </a:p>
+        </p:txBody>
+      </p:sp>
+      <p:sp>
+        <p:nvSpPr>
+          <p:cNvPr id="4" name="Text 2"/>
+          <p:cNvSpPr/>
+          <p:nvPr/>
+        </p:nvSpPr>
+        <p:spPr>
+          <a:xfrm>
+            <a:off x="6400000" y="1642070"/>
+            <a:ext cx="5288572" cy="4300000"/>
+          </a:xfrm>
+          <a:prstGeom prst="rect">
+            <a:avLst/>
+          </a:prstGeom>
+          <a:noFill/>
+          <a:ln/>
+        </p:spPr>
+        <p:txBody>
+          <a:bodyPr wrap="square" lIns="0" tIns="0" rIns="0" bIns="0" rtlCol="0" anchor="t">
+            <a:normAutofit/>
+          </a:bodyPr>
+          <a:lstStyle/>
+          <a:p>
+            <a:pPr algn="l" marL="155956" indent="-155956">
+              <a:lnSpc>
+                <a:spcPts val="1950"/>
+              </a:lnSpc>
+              <a:buSzPct val="100000"/>
+              <a:buChar char="•"/>
+            </a:pPr>
+            <a:r>
+              <a:rPr lang="en-US" sz="1300" dirty="0">
+                <a:solidFill>
+                  <a:srgbClr val="46516B"/>
+                </a:solidFill>
+                <a:latin typeface="Public Sans" pitchFamily="34" charset="0"/>
+                <a:ea typeface="Public Sans" pitchFamily="34" charset="-122"/>
+                <a:cs typeface="Public Sans" pitchFamily="34" charset="-120"/>
+              </a:rPr>
+              <a:t>1° grid (≈ 110 km) on the GPS years 2017–2023; hotspots = riskiest cells holding 15% of crashes (109 cells).</a:t>
+            </a:r>
+            <a:endParaRPr lang="en-US" sz="1300" dirty="0"/>
+          </a:p>
+          <a:p>
+            <a:pPr algn="l" marL="155956" indent="-155956">
+              <a:lnSpc>
+                <a:spcPts val="1950"/>
+              </a:lnSpc>
+              <a:buSzPct val="100000"/>
+              <a:buChar char="•"/>
+            </a:pPr>
+            <a:r>
+              <a:rPr lang="en-US" sz="1300" dirty="0">
+                <a:solidFill>
+                  <a:srgbClr val="46516B"/>
+                </a:solidFill>
+                <a:latin typeface="Public Sans" pitchFamily="34" charset="0"/>
+                <a:ea typeface="Public Sans" pitchFamily="34" charset="-122"/>
+                <a:cs typeface="Public Sans" pitchFamily="34" charset="-120"/>
+              </a:rPr>
+              <a:t>Checked on 2024–25, never seen: 14% of crashes but 25.5% of deaths; fatal rate 12.6% vs. 6.2% elsewhere.</a:t>
+            </a:r>
+            <a:endParaRPr lang="en-US" sz="1300" dirty="0"/>
+          </a:p>
+          <a:p>
+            <a:pPr algn="l" marL="155956" indent="-155956">
+              <a:lnSpc>
+                <a:spcPts val="1950"/>
+              </a:lnSpc>
+              <a:buSzPct val="100000"/>
+              <a:buChar char="•"/>
+            </a:pPr>
+            <a:r>
+              <a:rPr lang="en-US" sz="1300" dirty="0">
+                <a:solidFill>
+                  <a:srgbClr val="46516B"/>
+                </a:solidFill>
+                <a:latin typeface="Public Sans" pitchFamily="34" charset="0"/>
+                <a:ea typeface="Public Sans" pitchFamily="34" charset="-122"/>
+                <a:cs typeface="Public Sans" pitchFamily="34" charset="-120"/>
+              </a:rPr>
+              <a:t>Highest risk in the North-East (Pernambuco, Bahia): candidate ALS / helicopter bases and inspections.</a:t>
+            </a:r>
+            <a:endParaRPr lang="en-US" sz="1300" dirty="0"/>
+          </a:p>
+          <a:p>
+            <a:pPr algn="l" marL="155956" indent="-155956">
+              <a:lnSpc>
+                <a:spcPts val="1950"/>
+              </a:lnSpc>
+              <a:buSzPct val="100000"/>
+              <a:buChar char="•"/>
+            </a:pPr>
+            <a:r>
+              <a:rPr lang="en-US" sz="1300" dirty="0">
+                <a:solidFill>
+                  <a:srgbClr val="46516B"/>
+                </a:solidFill>
+                <a:latin typeface="Public Sans" pitchFamily="34" charset="0"/>
+                <a:ea typeface="Public Sans" pitchFamily="34" charset="-122"/>
+                <a:cs typeface="Public Sans" pitchFamily="34" charset="-120"/>
+              </a:rPr>
+              <a:t>Adding GPS cell risk to Gradient Boosting (train 2017–21): test PR-AUC 0.131 → 0.141, validation 0.132 → 0.153 — more than any change of algorithm.</a:t>
+            </a:r>
+            <a:endParaRPr lang="en-US" sz="1300" dirty="0"/>
+          </a:p>
+          <a:p>
+            <a:pPr algn="l" marL="155956" indent="-155956">
+              <a:lnSpc>
+                <a:spcPts val="1950"/>
+              </a:lnSpc>
+              <a:buSzPct val="100000"/>
+              <a:buChar char="•"/>
+            </a:pPr>
+            <a:r>
+              <a:rPr lang="en-US" sz="1300" dirty="0">
+                <a:solidFill>
+                  <a:srgbClr val="46516B"/>
+                </a:solidFill>
+                <a:latin typeface="Public Sans" pitchFamily="34" charset="0"/>
+                <a:ea typeface="Public Sans" pitchFamily="34" charset="-122"/>
+                <a:cs typeface="Public Sans" pitchFamily="34" charset="-120"/>
+              </a:rPr>
+              <a:t>Interactive Folium map: reports/figures/task3_hotspot_map.html</a:t>
+            </a:r>
+            <a:endParaRPr lang="en-US" sz="1300" dirty="0"/>
+          </a:p>
+        </p:txBody>
+      </p:sp>
+      <p:sp>
+        <p:nvSpPr>
+          <p:cNvPr id="5" name="Text 3"/>
+          <p:cNvSpPr/>
+          <p:nvPr/>
+        </p:nvSpPr>
+        <p:spPr>
+          <a:xfrm>
+            <a:off x="812800" y="6238280"/>
+            <a:ext cx="4057174" cy="238720"/>
+          </a:xfrm>
+          <a:prstGeom prst="rect">
+            <a:avLst/>
+          </a:prstGeom>
+          <a:noFill/>
+          <a:ln/>
+        </p:spPr>
+        <p:txBody>
+          <a:bodyPr wrap="square" lIns="0" tIns="0" rIns="0" bIns="0" rtlCol="0" anchor="t">
+            <a:normAutofit/>
+          </a:bodyPr>
+          <a:lstStyle/>
+          <a:p>
+            <a:pPr algn="l" indent="0" marL="0">
+              <a:lnSpc>
+                <a:spcPts val="1680"/>
+              </a:lnSpc>
+              <a:buNone/>
+            </a:pPr>
+            <a:r>
+              <a:rPr lang="en-US" sz="1200" dirty="0">
+                <a:solidFill>
+                  <a:srgbClr val="8B9099"/>
+                </a:solidFill>
+                <a:latin typeface="Public Sans" pitchFamily="34" charset="0"/>
+                <a:ea typeface="Public Sans" pitchFamily="34" charset="-122"/>
+                <a:cs typeface="Public Sans" pitchFamily="34" charset="-120"/>
+              </a:rPr>
+              <a:t>Road Safety Predictive Analytics — Group 6</a:t>
+            </a:r>
+            <a:endParaRPr lang="en-US" sz="1200" dirty="0"/>
+          </a:p>
+        </p:txBody>
+      </p:sp>
+      <p:sp>
+        <p:nvSpPr>
+          <p:cNvPr id="6" name="Text 4"/>
+          <p:cNvSpPr/>
+          <p:nvPr/>
+        </p:nvSpPr>
+        <p:spPr>
+          <a:xfrm>
+            <a:off x="11221145" y="6238280"/>
+            <a:ext cx="208855" cy="238720"/>
+          </a:xfrm>
+          <a:prstGeom prst="rect">
+            <a:avLst/>
+          </a:prstGeom>
+          <a:noFill/>
+          <a:ln/>
+        </p:spPr>
+        <p:txBody>
+          <a:bodyPr wrap="square" lIns="0" tIns="0" rIns="0" bIns="0" rtlCol="0" anchor="t">
+            <a:normAutofit/>
+          </a:bodyPr>
+          <a:lstStyle/>
+          <a:p>
+            <a:pPr algn="l" indent="0" marL="0">
+              <a:lnSpc>
+                <a:spcPts val="1680"/>
+              </a:lnSpc>
+              <a:buNone/>
+            </a:pPr>
+            <a:r>
+              <a:rPr lang="en-US" sz="1200" dirty="0">
+                <a:solidFill>
+                  <a:srgbClr val="8B9099"/>
+                </a:solidFill>
+                <a:latin typeface="Public Sans" pitchFamily="34" charset="0"/>
+                <a:ea typeface="Public Sans" pitchFamily="34" charset="-122"/>
+                <a:cs typeface="Public Sans" pitchFamily="34" charset="-120"/>
+              </a:rPr>
+              <a:t>24</a:t>
+            </a:r>
+            <a:endParaRPr lang="en-US" sz="1200" dirty="0"/>
+          </a:p>
+        </p:txBody>
+      </p:sp>
+      <p:pic>
+        <p:nvPicPr>
+          <p:cNvPr id="7" name="Picture 6" descr="task3_hotspots.png"/>
+          <p:cNvPicPr>
+            <a:picLocks noChangeAspect="1"/>
+          </p:cNvPicPr>
+          <p:nvPr/>
+        </p:nvPicPr>
+        <p:blipFill>
+          <a:blip r:embed="rId2"/>
+          <a:stretch>
+            <a:fillRect/>
+          </a:stretch>
+        </p:blipFill>
+        <p:spPr>
+          <a:xfrm>
+            <a:off x="812800" y="1642070"/>
+            <a:ext cx="4416202" cy="4450000"/>
+          </a:xfrm>
+          <a:prstGeom prst="rect">
+            <a:avLst/>
+          </a:prstGeom>
+        </p:spPr>
+      </p:pic>
     </p:spTree>
   </p:cSld>
   <p:clrMapOvr>

</xml_diff>

<commit_message>
Redesign slides 20 and 21 and add Pedro's presentation script
Slides 20 (Gradient Boosting) and 21 (MLP) now lead with the key test
numbers in stat cards, four short bullets and one large chart each.
Slide 20's validation numbers now match the notebook (PR-AUC 0.135,
lift 2.22x).

Co-Authored-By: Claude Opus 5.5 <noreply@anthropic.com>
</commit_message>
<xml_diff>
--- a/reports/presentation/Road Safety Predictive Analytics — Group 6.pptx
+++ b/reports/presentation/Road Safety Predictive Analytics — Group 6.pptx
@@ -15131,135 +15131,6 @@
       </p:sp>
       <p:sp>
         <p:nvSpPr>
-          <p:cNvPr id="4" name="Text 2"/>
-          <p:cNvSpPr/>
-          <p:nvPr/>
-        </p:nvSpPr>
-        <p:spPr>
-          <a:xfrm>
-            <a:off x="910844" y="1642070"/>
-            <a:ext cx="10777728" cy="2006600"/>
-          </a:xfrm>
-          <a:prstGeom prst="rect">
-            <a:avLst/>
-          </a:prstGeom>
-          <a:noFill/>
-          <a:ln/>
-        </p:spPr>
-        <p:txBody>
-          <a:bodyPr wrap="square" lIns="0" tIns="0" rIns="0" bIns="0" rtlCol="0" anchor="t">
-            <a:normAutofit/>
-          </a:bodyPr>
-          <a:lstStyle/>
-          <a:p>
-            <a:pPr algn="l" marL="155956" indent="-155956">
-              <a:lnSpc>
-                <a:spcPts val="1950"/>
-              </a:lnSpc>
-              <a:buSzPct val="100000"/>
-              <a:buChar char="•"/>
-            </a:pPr>
-            <a:r>
-              <a:rPr lang="en-US" sz="1300" dirty="0">
-                <a:solidFill>
-                  <a:srgbClr val="46516B"/>
-                </a:solidFill>
-                <a:latin typeface="Public Sans" pitchFamily="34" charset="0"/>
-                <a:ea typeface="Public Sans" pitchFamily="34" charset="-122"/>
-                <a:cs typeface="Public Sans" pitchFamily="34" charset="-120"/>
-              </a:rPr>
-              <a:t>Histogram Gradient Boosting, compared with a Random Forest; class weights for the 5% fatal rate, no scaling needed.</a:t>
-            </a:r>
-            <a:endParaRPr lang="en-US" sz="1300" dirty="0"/>
-          </a:p>
-          <a:p>
-            <a:pPr algn="l" marL="155956" indent="-155956">
-              <a:lnSpc>
-                <a:spcPts val="1950"/>
-              </a:lnSpc>
-              <a:buSzPct val="100000"/>
-              <a:buChar char="•"/>
-            </a:pPr>
-            <a:r>
-              <a:rPr lang="en-US" sz="1300" dirty="0">
-                <a:solidFill>
-                  <a:srgbClr val="46516B"/>
-                </a:solidFill>
-                <a:latin typeface="Public Sans" pitchFamily="34" charset="0"/>
-                <a:ea typeface="Public Sans" pitchFamily="34" charset="-122"/>
-                <a:cs typeface="Public Sans" pitchFamily="34" charset="-120"/>
-              </a:rPr>
-              <a:t>Why: fatality risk comes from combinations (rural × night × downhill); trees learn these interactions without hand-crafting.</a:t>
-            </a:r>
-            <a:endParaRPr lang="en-US" sz="1300" dirty="0"/>
-          </a:p>
-          <a:p>
-            <a:pPr algn="l" marL="155956" indent="-155956">
-              <a:lnSpc>
-                <a:spcPts val="1950"/>
-              </a:lnSpc>
-              <a:buSzPct val="100000"/>
-              <a:buChar char="•"/>
-            </a:pPr>
-            <a:r>
-              <a:rPr lang="en-US" sz="1300" dirty="0">
-                <a:solidFill>
-                  <a:srgbClr val="46516B"/>
-                </a:solidFill>
-                <a:latin typeface="Public Sans" pitchFamily="34" charset="0"/>
-                <a:ea typeface="Public Sans" pitchFamily="34" charset="-122"/>
-                <a:cs typeface="Public Sans" pitchFamily="34" charset="-120"/>
-              </a:rPr>
-              <a:t>Tuning on validation 2022–23: 13 configs. Small, regularised trees won (lr 0.03, 15 leaves, 150 trees); training on 2015+ only gave no gain.</a:t>
-            </a:r>
-            <a:endParaRPr lang="en-US" sz="1300" dirty="0"/>
-          </a:p>
-          <a:p>
-            <a:pPr algn="l" marL="155956" indent="-155956">
-              <a:lnSpc>
-                <a:spcPts val="1950"/>
-              </a:lnSpc>
-              <a:buSzPct val="100000"/>
-              <a:buChar char="•"/>
-            </a:pPr>
-            <a:r>
-              <a:rPr lang="en-US" sz="1300" dirty="0">
-                <a:solidFill>
-                  <a:srgbClr val="46516B"/>
-                </a:solidFill>
-                <a:latin typeface="Public Sans" pitchFamily="34" charset="0"/>
-                <a:ea typeface="Public Sans" pitchFamily="34" charset="-122"/>
-                <a:cs typeface="Public Sans" pitchFamily="34" charset="-120"/>
-              </a:rPr>
-              <a:t>Validation: PR-AUC 0.134, lift 2.24×. Test 2024–25: PR-AUC 0.126, recall 31.5%, lift 2.10×, Brier 0.064 after sigmoid calibration.</a:t>
-            </a:r>
-            <a:endParaRPr lang="en-US" sz="1300" dirty="0"/>
-          </a:p>
-          <a:p>
-            <a:pPr algn="l" marL="155956" indent="-155956">
-              <a:lnSpc>
-                <a:spcPts val="1950"/>
-              </a:lnSpc>
-              <a:buSzPct val="100000"/>
-              <a:buChar char="•"/>
-            </a:pPr>
-            <a:r>
-              <a:rPr lang="en-US" sz="1300" dirty="0">
-                <a:solidFill>
-                  <a:srgbClr val="46516B"/>
-                </a:solidFill>
-                <a:latin typeface="Public Sans" pitchFamily="34" charset="0"/>
-                <a:ea typeface="Public Sans" pitchFamily="34" charset="-122"/>
-                <a:cs typeface="Public Sans" pitchFamily="34" charset="-120"/>
-              </a:rPr>
-              <a:t>Top drivers: time of day, roadway type, historical segment risk, then downhill, rural area and day of week (matches the EDA).</a:t>
-            </a:r>
-            <a:endParaRPr lang="en-US" sz="1300" dirty="0"/>
-          </a:p>
-        </p:txBody>
-      </p:sp>
-      <p:sp>
-        <p:nvSpPr>
           <p:cNvPr id="5" name="Text 3"/>
           <p:cNvSpPr/>
           <p:nvPr/>
@@ -15343,6 +15214,369 @@
               <a:t>20</a:t>
             </a:r>
             <a:endParaRPr lang="en-US" sz="1200" dirty="0"/>
+          </a:p>
+        </p:txBody>
+      </p:sp>
+      <p:sp>
+        <p:nvSpPr>
+          <p:cNvPr id="40" name="Stat card 1"/>
+          <p:cNvSpPr/>
+          <p:nvPr/>
+        </p:nvSpPr>
+        <p:spPr>
+          <a:xfrm>
+            <a:off x="812800" y="1680000"/>
+            <a:ext cx="2330000" cy="1330000"/>
+          </a:xfrm>
+          <a:prstGeom prst="roundRect">
+            <a:avLst>
+              <a:gd name="adj" fmla="val 7556"/>
+            </a:avLst>
+          </a:prstGeom>
+          <a:solidFill>
+            <a:srgbClr val="FDFDFB"/>
+          </a:solidFill>
+          <a:ln w="6350">
+            <a:solidFill>
+              <a:srgbClr val="E2DFD6"/>
+            </a:solidFill>
+            <a:prstDash val="solid"/>
+          </a:ln>
+        </p:spPr>
+        <p:txBody>
+          <a:bodyPr/>
+          <a:lstStyle/>
+          <a:p>
+            <a:endParaRPr lang="en-US" dirty="0"/>
+          </a:p>
+        </p:txBody>
+      </p:sp>
+      <p:sp>
+        <p:nvSpPr>
+          <p:cNvPr id="41" name="Stat 1"/>
+          <p:cNvSpPr txBox="1"/>
+          <p:nvPr/>
+        </p:nvSpPr>
+        <p:spPr>
+          <a:xfrm>
+            <a:off x="1002800" y="1830000"/>
+            <a:ext cx="1950000" cy="1070000"/>
+          </a:xfrm>
+          <a:prstGeom prst="rect">
+            <a:avLst/>
+          </a:prstGeom>
+          <a:noFill/>
+          <a:ln/>
+        </p:spPr>
+        <p:txBody>
+          <a:bodyPr wrap="square" lIns="0" tIns="0" rIns="0" bIns="0" rtlCol="0" anchor="t">
+            <a:noAutofit/>
+          </a:bodyPr>
+          <a:lstStyle/>
+          <a:p>
+            <a:pPr algn="l" marL="0" indent="0">
+              <a:lnSpc>
+                <a:spcPts val="3800"/>
+              </a:lnSpc>
+              <a:buNone/>
+            </a:pPr>
+            <a:r>
+              <a:rPr lang="en-US" sz="3000" b="1" dirty="0">
+                <a:solidFill>
+                  <a:srgbClr val="B05A26"/>
+                </a:solidFill>
+                <a:latin typeface="Public Sans" pitchFamily="34" charset="0"/>
+                <a:ea typeface="Public Sans" pitchFamily="34" charset="-122"/>
+                <a:cs typeface="Public Sans" pitchFamily="34" charset="-120"/>
+              </a:rPr>
+              <a:t>31.5%</a:t>
+            </a:r>
+            <a:endParaRPr lang="en-US" sz="3000" dirty="0"/>
+          </a:p>
+          <a:p>
+            <a:pPr algn="l" marL="0" indent="0">
+              <a:lnSpc>
+                <a:spcPts val="1560"/>
+              </a:lnSpc>
+              <a:spcBef>
+                <a:spcPts val="300"/>
+              </a:spcBef>
+              <a:buNone/>
+            </a:pPr>
+            <a:r>
+              <a:rPr lang="en-US" sz="1200" dirty="0">
+                <a:solidFill>
+                  <a:srgbClr val="46516B"/>
+                </a:solidFill>
+                <a:latin typeface="Public Sans" pitchFamily="34" charset="0"/>
+                <a:ea typeface="Public Sans" pitchFamily="34" charset="-122"/>
+                <a:cs typeface="Public Sans" pitchFamily="34" charset="-120"/>
+              </a:rPr>
+              <a:t>of fatal crashes reached with 15% of ALS capacity</a:t>
+            </a:r>
+            <a:endParaRPr lang="en-US" sz="1200" dirty="0"/>
+          </a:p>
+        </p:txBody>
+      </p:sp>
+      <p:sp>
+        <p:nvSpPr>
+          <p:cNvPr id="42" name="Stat card 2"/>
+          <p:cNvSpPr/>
+          <p:nvPr/>
+        </p:nvSpPr>
+        <p:spPr>
+          <a:xfrm>
+            <a:off x="3282800" y="1680000"/>
+            <a:ext cx="2330000" cy="1330000"/>
+          </a:xfrm>
+          <a:prstGeom prst="roundRect">
+            <a:avLst>
+              <a:gd name="adj" fmla="val 7556"/>
+            </a:avLst>
+          </a:prstGeom>
+          <a:solidFill>
+            <a:srgbClr val="FDFDFB"/>
+          </a:solidFill>
+          <a:ln w="6350">
+            <a:solidFill>
+              <a:srgbClr val="E2DFD6"/>
+            </a:solidFill>
+            <a:prstDash val="solid"/>
+          </a:ln>
+        </p:spPr>
+        <p:txBody>
+          <a:bodyPr/>
+          <a:lstStyle/>
+          <a:p>
+            <a:endParaRPr lang="en-US" dirty="0"/>
+          </a:p>
+        </p:txBody>
+      </p:sp>
+      <p:sp>
+        <p:nvSpPr>
+          <p:cNvPr id="43" name="Stat 2"/>
+          <p:cNvSpPr txBox="1"/>
+          <p:nvPr/>
+        </p:nvSpPr>
+        <p:spPr>
+          <a:xfrm>
+            <a:off x="3472800" y="1830000"/>
+            <a:ext cx="1950000" cy="1070000"/>
+          </a:xfrm>
+          <a:prstGeom prst="rect">
+            <a:avLst/>
+          </a:prstGeom>
+          <a:noFill/>
+          <a:ln/>
+        </p:spPr>
+        <p:txBody>
+          <a:bodyPr wrap="square" lIns="0" tIns="0" rIns="0" bIns="0" rtlCol="0" anchor="t">
+            <a:noAutofit/>
+          </a:bodyPr>
+          <a:lstStyle/>
+          <a:p>
+            <a:pPr algn="l" marL="0" indent="0">
+              <a:lnSpc>
+                <a:spcPts val="3800"/>
+              </a:lnSpc>
+              <a:buNone/>
+            </a:pPr>
+            <a:r>
+              <a:rPr lang="en-US" sz="3000" b="1" dirty="0">
+                <a:solidFill>
+                  <a:srgbClr val="B05A26"/>
+                </a:solidFill>
+                <a:latin typeface="Public Sans" pitchFamily="34" charset="0"/>
+                <a:ea typeface="Public Sans" pitchFamily="34" charset="-122"/>
+                <a:cs typeface="Public Sans" pitchFamily="34" charset="-120"/>
+              </a:rPr>
+              <a:t>2.1×</a:t>
+            </a:r>
+            <a:endParaRPr lang="en-US" sz="3000" dirty="0"/>
+          </a:p>
+          <a:p>
+            <a:pPr algn="l" marL="0" indent="0">
+              <a:lnSpc>
+                <a:spcPts val="1560"/>
+              </a:lnSpc>
+              <a:spcBef>
+                <a:spcPts val="300"/>
+              </a:spcBef>
+              <a:buNone/>
+            </a:pPr>
+            <a:r>
+              <a:rPr lang="en-US" sz="1200" dirty="0">
+                <a:solidFill>
+                  <a:srgbClr val="46516B"/>
+                </a:solidFill>
+                <a:latin typeface="Public Sans" pitchFamily="34" charset="0"/>
+                <a:ea typeface="Public Sans" pitchFamily="34" charset="-122"/>
+                <a:cs typeface="Public Sans" pitchFamily="34" charset="-120"/>
+              </a:rPr>
+              <a:t>better than random dispatch (test 2024–25)</a:t>
+            </a:r>
+            <a:endParaRPr lang="en-US" sz="1200" dirty="0"/>
+          </a:p>
+        </p:txBody>
+      </p:sp>
+      <p:sp>
+        <p:nvSpPr>
+          <p:cNvPr id="44" name="Bullets"/>
+          <p:cNvSpPr txBox="1"/>
+          <p:nvPr/>
+        </p:nvSpPr>
+        <p:spPr>
+          <a:xfrm>
+            <a:off x="812800" y="3310000"/>
+            <a:ext cx="4800000" cy="2740000"/>
+          </a:xfrm>
+          <a:prstGeom prst="rect">
+            <a:avLst/>
+          </a:prstGeom>
+          <a:noFill/>
+          <a:ln/>
+        </p:spPr>
+        <p:txBody>
+          <a:bodyPr wrap="square" lIns="0" tIns="0" rIns="0" bIns="0" rtlCol="0" anchor="t">
+            <a:noAutofit/>
+          </a:bodyPr>
+          <a:lstStyle/>
+          <a:p>
+            <a:pPr algn="l" marL="171450" indent="-171450">
+              <a:lnSpc>
+                <a:spcPts val="1950"/>
+              </a:lnSpc>
+              <a:buSzPct val="100000"/>
+              <a:buChar char="•"/>
+            </a:pPr>
+            <a:r>
+              <a:rPr lang="en-US" sz="1400" b="1" dirty="0">
+                <a:solidFill>
+                  <a:srgbClr val="15213B"/>
+                </a:solidFill>
+                <a:latin typeface="Public Sans" pitchFamily="34" charset="0"/>
+                <a:ea typeface="Public Sans" pitchFamily="34" charset="-122"/>
+                <a:cs typeface="Public Sans" pitchFamily="34" charset="-120"/>
+              </a:rPr>
+              <a:t>Why trees: </a:t>
+            </a:r>
+            <a:r>
+              <a:rPr lang="en-US" sz="1400" dirty="0">
+                <a:solidFill>
+                  <a:srgbClr val="46516B"/>
+                </a:solidFill>
+                <a:latin typeface="Public Sans" pitchFamily="34" charset="0"/>
+                <a:ea typeface="Public Sans" pitchFamily="34" charset="-122"/>
+                <a:cs typeface="Public Sans" pitchFamily="34" charset="-120"/>
+              </a:rPr>
+              <a:t>fatal risk comes from combinations (rural × night × downhill), which trees learn without hand-crafting.</a:t>
+            </a:r>
+            <a:endParaRPr lang="en-US" sz="1400" dirty="0"/>
+          </a:p>
+          <a:p>
+            <a:pPr algn="l" marL="171450" indent="-171450">
+              <a:lnSpc>
+                <a:spcPts val="1950"/>
+              </a:lnSpc>
+              <a:spcBef>
+                <a:spcPts val="700"/>
+              </a:spcBef>
+              <a:buSzPct val="100000"/>
+              <a:buChar char="•"/>
+            </a:pPr>
+            <a:r>
+              <a:rPr lang="en-US" sz="1400" b="1" dirty="0">
+                <a:solidFill>
+                  <a:srgbClr val="15213B"/>
+                </a:solidFill>
+                <a:latin typeface="Public Sans" pitchFamily="34" charset="0"/>
+                <a:ea typeface="Public Sans" pitchFamily="34" charset="-122"/>
+                <a:cs typeface="Public Sans" pitchFamily="34" charset="-120"/>
+              </a:rPr>
+              <a:t>Setup: </a:t>
+            </a:r>
+            <a:r>
+              <a:rPr lang="en-US" sz="1400" dirty="0">
+                <a:solidFill>
+                  <a:srgbClr val="46516B"/>
+                </a:solidFill>
+                <a:latin typeface="Public Sans" pitchFamily="34" charset="0"/>
+                <a:ea typeface="Public Sans" pitchFamily="34" charset="-122"/>
+                <a:cs typeface="Public Sans" pitchFamily="34" charset="-120"/>
+              </a:rPr>
+              <a:t>Histogram Gradient Boosting vs. Random Forest; class weights for the ~5% fatal rate; tuned on validation 2022–23.</a:t>
+            </a:r>
+            <a:endParaRPr lang="en-US" sz="1400" dirty="0"/>
+          </a:p>
+          <a:p>
+            <a:pPr algn="l" marL="171450" indent="-171450">
+              <a:lnSpc>
+                <a:spcPts val="1950"/>
+              </a:lnSpc>
+              <a:spcBef>
+                <a:spcPts val="700"/>
+              </a:spcBef>
+              <a:buSzPct val="100000"/>
+              <a:buChar char="•"/>
+            </a:pPr>
+            <a:r>
+              <a:rPr lang="en-US" sz="1400" b="1" dirty="0">
+                <a:solidFill>
+                  <a:srgbClr val="15213B"/>
+                </a:solidFill>
+                <a:latin typeface="Public Sans" pitchFamily="34" charset="0"/>
+                <a:ea typeface="Public Sans" pitchFamily="34" charset="-122"/>
+                <a:cs typeface="Public Sans" pitchFamily="34" charset="-120"/>
+              </a:rPr>
+              <a:t>Test 2024–25: </a:t>
+            </a:r>
+            <a:r>
+              <a:rPr lang="en-US" sz="1400" dirty="0">
+                <a:solidFill>
+                  <a:srgbClr val="46516B"/>
+                </a:solidFill>
+                <a:latin typeface="Public Sans" pitchFamily="34" charset="0"/>
+                <a:ea typeface="Public Sans" pitchFamily="34" charset="-122"/>
+                <a:cs typeface="Public Sans" pitchFamily="34" charset="-120"/>
+              </a:rPr>
+              <a:t>PR-AUC 0.126 vs. 0.118 for the baseline; Brier 0.064 after calibration.</a:t>
+            </a:r>
+            <a:endParaRPr lang="en-US" sz="1400" dirty="0"/>
+          </a:p>
+          <a:p>
+            <a:pPr algn="l" marL="171450" indent="-171450">
+              <a:lnSpc>
+                <a:spcPts val="1950"/>
+              </a:lnSpc>
+              <a:spcBef>
+                <a:spcPts val="700"/>
+              </a:spcBef>
+              <a:buSzPct val="100000"/>
+              <a:buChar char="•"/>
+            </a:pPr>
+            <a:r>
+              <a:rPr lang="en-US" sz="1400" b="1" dirty="0">
+                <a:solidFill>
+                  <a:srgbClr val="15213B"/>
+                </a:solidFill>
+                <a:latin typeface="Public Sans" pitchFamily="34" charset="0"/>
+                <a:ea typeface="Public Sans" pitchFamily="34" charset="-122"/>
+                <a:cs typeface="Public Sans" pitchFamily="34" charset="-120"/>
+              </a:rPr>
+              <a:t>Drivers: </a:t>
+            </a:r>
+            <a:r>
+              <a:rPr lang="en-US" sz="1400" dirty="0">
+                <a:solidFill>
+                  <a:srgbClr val="46516B"/>
+                </a:solidFill>
+                <a:latin typeface="Public Sans" pitchFamily="34" charset="0"/>
+                <a:ea typeface="Public Sans" pitchFamily="34" charset="-122"/>
+                <a:cs typeface="Public Sans" pitchFamily="34" charset="-120"/>
+              </a:rPr>
+              <a:t>time of day, roadway type and historical segment risk, as in the EDA.</a:t>
+            </a:r>
+            <a:endParaRPr lang="en-US" sz="1400" dirty="0"/>
           </a:p>
         </p:txBody>
       </p:sp>
@@ -15362,32 +15596,8 @@
         </p:blipFill>
         <p:spPr>
           <a:xfrm>
-            <a:off x="910844" y="3500000"/>
-            <a:ext cx="3290000" cy="2350000"/>
-          </a:xfrm>
-          <a:prstGeom prst="rect">
-            <a:avLst/>
-          </a:prstGeom>
-        </p:spPr>
-      </p:pic>
-      <p:pic>
-        <p:nvPicPr>
-          <p:cNvPr id="8" name="Picture 7" descr="task3_trees_pr_curve.png"/>
-          <p:cNvPicPr>
-            <a:picLocks noChangeAspect="1"/>
-          </p:cNvPicPr>
-          <p:nvPr/>
-        </p:nvPicPr>
-        <p:blipFill>
-          <a:blip r:embed="rId3"/>
-          <a:stretch>
-            <a:fillRect/>
-          </a:stretch>
-        </p:blipFill>
-        <p:spPr>
-          <a:xfrm>
-            <a:off x="4500844" y="3500000"/>
-            <a:ext cx="3290000" cy="2350000"/>
+            <a:off x="5880000" y="1680000"/>
+            <a:ext cx="5816192" cy="3958241"/>
           </a:xfrm>
           <a:prstGeom prst="rect">
             <a:avLst/>
@@ -15518,135 +15728,6 @@
       </p:sp>
       <p:sp>
         <p:nvSpPr>
-          <p:cNvPr id="4" name="Text 2"/>
-          <p:cNvSpPr/>
-          <p:nvPr/>
-        </p:nvSpPr>
-        <p:spPr>
-          <a:xfrm>
-            <a:off x="910844" y="1642070"/>
-            <a:ext cx="10777728" cy="2006600"/>
-          </a:xfrm>
-          <a:prstGeom prst="rect">
-            <a:avLst/>
-          </a:prstGeom>
-          <a:noFill/>
-          <a:ln/>
-        </p:spPr>
-        <p:txBody>
-          <a:bodyPr wrap="square" lIns="0" tIns="0" rIns="0" bIns="0" rtlCol="0" anchor="t">
-            <a:normAutofit/>
-          </a:bodyPr>
-          <a:lstStyle/>
-          <a:p>
-            <a:pPr algn="l" marL="155956" indent="-155956">
-              <a:lnSpc>
-                <a:spcPts val="1950"/>
-              </a:lnSpc>
-              <a:buSzPct val="100000"/>
-              <a:buChar char="•"/>
-            </a:pPr>
-            <a:r>
-              <a:rPr lang="en-US" sz="1300" dirty="0">
-                <a:solidFill>
-                  <a:srgbClr val="46516B"/>
-                </a:solidFill>
-                <a:latin typeface="Public Sans" pitchFamily="34" charset="0"/>
-                <a:ea typeface="Public Sans" pitchFamily="34" charset="-122"/>
-                <a:cs typeface="Public Sans" pitchFamily="34" charset="-120"/>
-              </a:rPr>
-              <a:t>Bag of 5 MLPs (32 → 16 neurons) on the one-hot encoded, scaled features; compared with LDA (linear discriminant analysis).</a:t>
-            </a:r>
-            <a:endParaRPr lang="en-US" sz="1300" dirty="0"/>
-          </a:p>
-          <a:p>
-            <a:pPr algn="l" marL="155956" indent="-155956">
-              <a:lnSpc>
-                <a:spcPts val="1950"/>
-              </a:lnSpc>
-              <a:buSzPct val="100000"/>
-              <a:buChar char="•"/>
-            </a:pPr>
-            <a:r>
-              <a:rPr lang="en-US" sz="1300" dirty="0">
-                <a:solidFill>
-                  <a:srgbClr val="46516B"/>
-                </a:solidFill>
-                <a:latin typeface="Public Sans" pitchFamily="34" charset="0"/>
-                <a:ea typeface="Public Sans" pitchFamily="34" charset="-122"/>
-                <a:cs typeface="Public Sans" pitchFamily="34" charset="-120"/>
-              </a:rPr>
-              <a:t>Why: a different bias from trees (smooth combinations of all features), so it tests whether the ceiling is the algorithm or the data.</a:t>
-            </a:r>
-            <a:endParaRPr lang="en-US" sz="1300" dirty="0"/>
-          </a:p>
-          <a:p>
-            <a:pPr algn="l" marL="155956" indent="-155956">
-              <a:lnSpc>
-                <a:spcPts val="1950"/>
-              </a:lnSpc>
-              <a:buSzPct val="100000"/>
-              <a:buChar char="•"/>
-            </a:pPr>
-            <a:r>
-              <a:rPr lang="en-US" sz="1300" dirty="0">
-                <a:solidFill>
-                  <a:srgbClr val="46516B"/>
-                </a:solidFill>
-                <a:latin typeface="Public Sans" pitchFamily="34" charset="0"/>
-                <a:ea typeface="Public Sans" pitchFamily="34" charset="-122"/>
-                <a:cs typeface="Public Sans" pitchFamily="34" charset="-120"/>
-              </a:rPr>
-              <a:t>Imbalance &amp; tuning on validation 2022–23: each network sees all fatal crashes + an equal random sample of non-fatal ones; 8 configs. One network varied 0.115–0.125 PR-AUC by seed alone; the average of 5 gave 0.130.</a:t>
-            </a:r>
-            <a:endParaRPr lang="en-US" sz="1300" dirty="0"/>
-          </a:p>
-          <a:p>
-            <a:pPr algn="l" marL="155956" indent="-155956">
-              <a:lnSpc>
-                <a:spcPts val="1950"/>
-              </a:lnSpc>
-              <a:buSzPct val="100000"/>
-              <a:buChar char="•"/>
-            </a:pPr>
-            <a:r>
-              <a:rPr lang="en-US" sz="1300" dirty="0">
-                <a:solidFill>
-                  <a:srgbClr val="46516B"/>
-                </a:solidFill>
-                <a:latin typeface="Public Sans" pitchFamily="34" charset="0"/>
-                <a:ea typeface="Public Sans" pitchFamily="34" charset="-122"/>
-                <a:cs typeface="Public Sans" pitchFamily="34" charset="-120"/>
-              </a:rPr>
-              <a:t>Validation: PR-AUC 0.130, lift 2.17×. Test 2024–25: PR-AUC 0.118, recall 31.2%, lift 2.08×, Brier 0.065 after sigmoid calibration. LDA: lift 1.88×.</a:t>
-            </a:r>
-            <a:endParaRPr lang="en-US" sz="1300" dirty="0"/>
-          </a:p>
-          <a:p>
-            <a:pPr algn="l" marL="155956" indent="-155956">
-              <a:lnSpc>
-                <a:spcPts val="1950"/>
-              </a:lnSpc>
-              <a:buSzPct val="100000"/>
-              <a:buChar char="•"/>
-            </a:pPr>
-            <a:r>
-              <a:rPr lang="en-US" sz="1300" dirty="0">
-                <a:solidFill>
-                  <a:srgbClr val="46516B"/>
-                </a:solidFill>
-                <a:latin typeface="Public Sans" pitchFamily="34" charset="0"/>
-                <a:ea typeface="Public Sans" pitchFamily="34" charset="-122"/>
-                <a:cs typeface="Public Sans" pitchFamily="34" charset="-120"/>
-              </a:rPr>
-              <a:t>Top drivers: time of day, roadway type, segment risk, downhill / uphill — the same as Gradient Boosting.</a:t>
-            </a:r>
-            <a:endParaRPr lang="en-US" sz="1300" dirty="0"/>
-          </a:p>
-        </p:txBody>
-      </p:sp>
-      <p:sp>
-        <p:nvSpPr>
           <p:cNvPr id="5" name="Text 3"/>
           <p:cNvSpPr/>
           <p:nvPr/>
@@ -15730,6 +15811,369 @@
               <a:t>21</a:t>
             </a:r>
             <a:endParaRPr lang="en-US" sz="1200" dirty="0"/>
+          </a:p>
+        </p:txBody>
+      </p:sp>
+      <p:sp>
+        <p:nvSpPr>
+          <p:cNvPr id="40" name="Stat card 1"/>
+          <p:cNvSpPr/>
+          <p:nvPr/>
+        </p:nvSpPr>
+        <p:spPr>
+          <a:xfrm>
+            <a:off x="812800" y="1680000"/>
+            <a:ext cx="2330000" cy="1330000"/>
+          </a:xfrm>
+          <a:prstGeom prst="roundRect">
+            <a:avLst>
+              <a:gd name="adj" fmla="val 7556"/>
+            </a:avLst>
+          </a:prstGeom>
+          <a:solidFill>
+            <a:srgbClr val="FDFDFB"/>
+          </a:solidFill>
+          <a:ln w="6350">
+            <a:solidFill>
+              <a:srgbClr val="E2DFD6"/>
+            </a:solidFill>
+            <a:prstDash val="solid"/>
+          </a:ln>
+        </p:spPr>
+        <p:txBody>
+          <a:bodyPr/>
+          <a:lstStyle/>
+          <a:p>
+            <a:endParaRPr lang="en-US" dirty="0"/>
+          </a:p>
+        </p:txBody>
+      </p:sp>
+      <p:sp>
+        <p:nvSpPr>
+          <p:cNvPr id="41" name="Stat 1"/>
+          <p:cNvSpPr txBox="1"/>
+          <p:nvPr/>
+        </p:nvSpPr>
+        <p:spPr>
+          <a:xfrm>
+            <a:off x="1002800" y="1830000"/>
+            <a:ext cx="1950000" cy="1070000"/>
+          </a:xfrm>
+          <a:prstGeom prst="rect">
+            <a:avLst/>
+          </a:prstGeom>
+          <a:noFill/>
+          <a:ln/>
+        </p:spPr>
+        <p:txBody>
+          <a:bodyPr wrap="square" lIns="0" tIns="0" rIns="0" bIns="0" rtlCol="0" anchor="t">
+            <a:noAutofit/>
+          </a:bodyPr>
+          <a:lstStyle/>
+          <a:p>
+            <a:pPr algn="l" marL="0" indent="0">
+              <a:lnSpc>
+                <a:spcPts val="3800"/>
+              </a:lnSpc>
+              <a:buNone/>
+            </a:pPr>
+            <a:r>
+              <a:rPr lang="en-US" sz="3000" b="1" dirty="0">
+                <a:solidFill>
+                  <a:srgbClr val="B05A26"/>
+                </a:solidFill>
+                <a:latin typeface="Public Sans" pitchFamily="34" charset="0"/>
+                <a:ea typeface="Public Sans" pitchFamily="34" charset="-122"/>
+                <a:cs typeface="Public Sans" pitchFamily="34" charset="-120"/>
+              </a:rPr>
+              <a:t>31.2%</a:t>
+            </a:r>
+            <a:endParaRPr lang="en-US" sz="3000" dirty="0"/>
+          </a:p>
+          <a:p>
+            <a:pPr algn="l" marL="0" indent="0">
+              <a:lnSpc>
+                <a:spcPts val="1560"/>
+              </a:lnSpc>
+              <a:spcBef>
+                <a:spcPts val="300"/>
+              </a:spcBef>
+              <a:buNone/>
+            </a:pPr>
+            <a:r>
+              <a:rPr lang="en-US" sz="1200" dirty="0">
+                <a:solidFill>
+                  <a:srgbClr val="46516B"/>
+                </a:solidFill>
+                <a:latin typeface="Public Sans" pitchFamily="34" charset="0"/>
+                <a:ea typeface="Public Sans" pitchFamily="34" charset="-122"/>
+                <a:cs typeface="Public Sans" pitchFamily="34" charset="-120"/>
+              </a:rPr>
+              <a:t>of fatal crashes reached with 15% of ALS capacity</a:t>
+            </a:r>
+            <a:endParaRPr lang="en-US" sz="1200" dirty="0"/>
+          </a:p>
+        </p:txBody>
+      </p:sp>
+      <p:sp>
+        <p:nvSpPr>
+          <p:cNvPr id="42" name="Stat card 2"/>
+          <p:cNvSpPr/>
+          <p:nvPr/>
+        </p:nvSpPr>
+        <p:spPr>
+          <a:xfrm>
+            <a:off x="3282800" y="1680000"/>
+            <a:ext cx="2330000" cy="1330000"/>
+          </a:xfrm>
+          <a:prstGeom prst="roundRect">
+            <a:avLst>
+              <a:gd name="adj" fmla="val 7556"/>
+            </a:avLst>
+          </a:prstGeom>
+          <a:solidFill>
+            <a:srgbClr val="FDFDFB"/>
+          </a:solidFill>
+          <a:ln w="6350">
+            <a:solidFill>
+              <a:srgbClr val="E2DFD6"/>
+            </a:solidFill>
+            <a:prstDash val="solid"/>
+          </a:ln>
+        </p:spPr>
+        <p:txBody>
+          <a:bodyPr/>
+          <a:lstStyle/>
+          <a:p>
+            <a:endParaRPr lang="en-US" dirty="0"/>
+          </a:p>
+        </p:txBody>
+      </p:sp>
+      <p:sp>
+        <p:nvSpPr>
+          <p:cNvPr id="43" name="Stat 2"/>
+          <p:cNvSpPr txBox="1"/>
+          <p:nvPr/>
+        </p:nvSpPr>
+        <p:spPr>
+          <a:xfrm>
+            <a:off x="3472800" y="1830000"/>
+            <a:ext cx="1950000" cy="1070000"/>
+          </a:xfrm>
+          <a:prstGeom prst="rect">
+            <a:avLst/>
+          </a:prstGeom>
+          <a:noFill/>
+          <a:ln/>
+        </p:spPr>
+        <p:txBody>
+          <a:bodyPr wrap="square" lIns="0" tIns="0" rIns="0" bIns="0" rtlCol="0" anchor="t">
+            <a:noAutofit/>
+          </a:bodyPr>
+          <a:lstStyle/>
+          <a:p>
+            <a:pPr algn="l" marL="0" indent="0">
+              <a:lnSpc>
+                <a:spcPts val="3800"/>
+              </a:lnSpc>
+              <a:buNone/>
+            </a:pPr>
+            <a:r>
+              <a:rPr lang="en-US" sz="3000" b="1" dirty="0">
+                <a:solidFill>
+                  <a:srgbClr val="B05A26"/>
+                </a:solidFill>
+                <a:latin typeface="Public Sans" pitchFamily="34" charset="0"/>
+                <a:ea typeface="Public Sans" pitchFamily="34" charset="-122"/>
+                <a:cs typeface="Public Sans" pitchFamily="34" charset="-120"/>
+              </a:rPr>
+              <a:t>2.08×</a:t>
+            </a:r>
+            <a:endParaRPr lang="en-US" sz="3000" dirty="0"/>
+          </a:p>
+          <a:p>
+            <a:pPr algn="l" marL="0" indent="0">
+              <a:lnSpc>
+                <a:spcPts val="1560"/>
+              </a:lnSpc>
+              <a:spcBef>
+                <a:spcPts val="300"/>
+              </a:spcBef>
+              <a:buNone/>
+            </a:pPr>
+            <a:r>
+              <a:rPr lang="en-US" sz="1200" dirty="0">
+                <a:solidFill>
+                  <a:srgbClr val="46516B"/>
+                </a:solidFill>
+                <a:latin typeface="Public Sans" pitchFamily="34" charset="0"/>
+                <a:ea typeface="Public Sans" pitchFamily="34" charset="-122"/>
+                <a:cs typeface="Public Sans" pitchFamily="34" charset="-120"/>
+              </a:rPr>
+              <a:t>better than random: the same ceiling as the trees</a:t>
+            </a:r>
+            <a:endParaRPr lang="en-US" sz="1200" dirty="0"/>
+          </a:p>
+        </p:txBody>
+      </p:sp>
+      <p:sp>
+        <p:nvSpPr>
+          <p:cNvPr id="44" name="Bullets"/>
+          <p:cNvSpPr txBox="1"/>
+          <p:nvPr/>
+        </p:nvSpPr>
+        <p:spPr>
+          <a:xfrm>
+            <a:off x="812800" y="3310000"/>
+            <a:ext cx="4800000" cy="2740000"/>
+          </a:xfrm>
+          <a:prstGeom prst="rect">
+            <a:avLst/>
+          </a:prstGeom>
+          <a:noFill/>
+          <a:ln/>
+        </p:spPr>
+        <p:txBody>
+          <a:bodyPr wrap="square" lIns="0" tIns="0" rIns="0" bIns="0" rtlCol="0" anchor="t">
+            <a:noAutofit/>
+          </a:bodyPr>
+          <a:lstStyle/>
+          <a:p>
+            <a:pPr algn="l" marL="171450" indent="-171450">
+              <a:lnSpc>
+                <a:spcPts val="1950"/>
+              </a:lnSpc>
+              <a:buSzPct val="100000"/>
+              <a:buChar char="•"/>
+            </a:pPr>
+            <a:r>
+              <a:rPr lang="en-US" sz="1400" b="1" dirty="0">
+                <a:solidFill>
+                  <a:srgbClr val="15213B"/>
+                </a:solidFill>
+                <a:latin typeface="Public Sans" pitchFamily="34" charset="0"/>
+                <a:ea typeface="Public Sans" pitchFamily="34" charset="-122"/>
+                <a:cs typeface="Public Sans" pitchFamily="34" charset="-120"/>
+              </a:rPr>
+              <a:t>Why a neural net: </a:t>
+            </a:r>
+            <a:r>
+              <a:rPr lang="en-US" sz="1400" dirty="0">
+                <a:solidFill>
+                  <a:srgbClr val="46516B"/>
+                </a:solidFill>
+                <a:latin typeface="Public Sans" pitchFamily="34" charset="0"/>
+                <a:ea typeface="Public Sans" pitchFamily="34" charset="-122"/>
+                <a:cs typeface="Public Sans" pitchFamily="34" charset="-120"/>
+              </a:rPr>
+              <a:t>a different bias from trees: is the limit the algorithm or the data?</a:t>
+            </a:r>
+            <a:endParaRPr lang="en-US" sz="1400" dirty="0"/>
+          </a:p>
+          <a:p>
+            <a:pPr algn="l" marL="171450" indent="-171450">
+              <a:lnSpc>
+                <a:spcPts val="1950"/>
+              </a:lnSpc>
+              <a:spcBef>
+                <a:spcPts val="700"/>
+              </a:spcBef>
+              <a:buSzPct val="100000"/>
+              <a:buChar char="•"/>
+            </a:pPr>
+            <a:r>
+              <a:rPr lang="en-US" sz="1400" b="1" dirty="0">
+                <a:solidFill>
+                  <a:srgbClr val="15213B"/>
+                </a:solidFill>
+                <a:latin typeface="Public Sans" pitchFamily="34" charset="0"/>
+                <a:ea typeface="Public Sans" pitchFamily="34" charset="-122"/>
+                <a:cs typeface="Public Sans" pitchFamily="34" charset="-120"/>
+              </a:rPr>
+              <a:t>Setup: </a:t>
+            </a:r>
+            <a:r>
+              <a:rPr lang="en-US" sz="1400" dirty="0">
+                <a:solidFill>
+                  <a:srgbClr val="46516B"/>
+                </a:solidFill>
+                <a:latin typeface="Public Sans" pitchFamily="34" charset="0"/>
+                <a:ea typeface="Public Sans" pitchFamily="34" charset="-122"/>
+                <a:cs typeface="Public Sans" pitchFamily="34" charset="-120"/>
+              </a:rPr>
+              <a:t>bag of 5 MLPs (32 → 16), each on all fatal crashes + an equal sample of non-fatal ones; LDA as a linear check.</a:t>
+            </a:r>
+            <a:endParaRPr lang="en-US" sz="1400" dirty="0"/>
+          </a:p>
+          <a:p>
+            <a:pPr algn="l" marL="171450" indent="-171450">
+              <a:lnSpc>
+                <a:spcPts val="1950"/>
+              </a:lnSpc>
+              <a:spcBef>
+                <a:spcPts val="700"/>
+              </a:spcBef>
+              <a:buSzPct val="100000"/>
+              <a:buChar char="•"/>
+            </a:pPr>
+            <a:r>
+              <a:rPr lang="en-US" sz="1400" b="1" dirty="0">
+                <a:solidFill>
+                  <a:srgbClr val="15213B"/>
+                </a:solidFill>
+                <a:latin typeface="Public Sans" pitchFamily="34" charset="0"/>
+                <a:ea typeface="Public Sans" pitchFamily="34" charset="-122"/>
+                <a:cs typeface="Public Sans" pitchFamily="34" charset="-120"/>
+              </a:rPr>
+              <a:t>Bagging pays: </a:t>
+            </a:r>
+            <a:r>
+              <a:rPr lang="en-US" sz="1400" dirty="0">
+                <a:solidFill>
+                  <a:srgbClr val="46516B"/>
+                </a:solidFill>
+                <a:latin typeface="Public Sans" pitchFamily="34" charset="0"/>
+                <a:ea typeface="Public Sans" pitchFamily="34" charset="-122"/>
+                <a:cs typeface="Public Sans" pitchFamily="34" charset="-120"/>
+              </a:rPr>
+              <a:t>single networks vary 0.115–0.125 PR-AUC by seed; the bag reaches 0.130 (validation).</a:t>
+            </a:r>
+            <a:endParaRPr lang="en-US" sz="1400" dirty="0"/>
+          </a:p>
+          <a:p>
+            <a:pPr algn="l" marL="171450" indent="-171450">
+              <a:lnSpc>
+                <a:spcPts val="1950"/>
+              </a:lnSpc>
+              <a:spcBef>
+                <a:spcPts val="700"/>
+              </a:spcBef>
+              <a:buSzPct val="100000"/>
+              <a:buChar char="•"/>
+            </a:pPr>
+            <a:r>
+              <a:rPr lang="en-US" sz="1400" b="1" dirty="0">
+                <a:solidFill>
+                  <a:srgbClr val="15213B"/>
+                </a:solidFill>
+                <a:latin typeface="Public Sans" pitchFamily="34" charset="0"/>
+                <a:ea typeface="Public Sans" pitchFamily="34" charset="-122"/>
+                <a:cs typeface="Public Sans" pitchFamily="34" charset="-120"/>
+              </a:rPr>
+              <a:t>Verdict: </a:t>
+            </a:r>
+            <a:r>
+              <a:rPr lang="en-US" sz="1400" dirty="0">
+                <a:solidFill>
+                  <a:srgbClr val="46516B"/>
+                </a:solidFill>
+                <a:latin typeface="Public Sans" pitchFamily="34" charset="0"/>
+                <a:ea typeface="Public Sans" pitchFamily="34" charset="-122"/>
+                <a:cs typeface="Public Sans" pitchFamily="34" charset="-120"/>
+              </a:rPr>
+              <a:t>three model families, near-identical curves: the data is the limit, not the algorithm.</a:t>
+            </a:r>
+            <a:endParaRPr lang="en-US" sz="1400" dirty="0"/>
           </a:p>
         </p:txBody>
       </p:sp>
@@ -15749,32 +16193,8 @@
         </p:blipFill>
         <p:spPr>
           <a:xfrm>
-            <a:off x="910844" y="3500000"/>
-            <a:ext cx="3309184" cy="2350000"/>
-          </a:xfrm>
-          <a:prstGeom prst="rect">
-            <a:avLst/>
-          </a:prstGeom>
-        </p:spPr>
-      </p:pic>
-      <p:pic>
-        <p:nvPicPr>
-          <p:cNvPr id="8" name="Picture 7" descr="task3_nontree_feature_importance.png"/>
-          <p:cNvPicPr>
-            <a:picLocks noChangeAspect="1"/>
-          </p:cNvPicPr>
-          <p:nvPr/>
-        </p:nvPicPr>
-        <p:blipFill>
-          <a:blip r:embed="rId3"/>
-          <a:stretch>
-            <a:fillRect/>
-          </a:stretch>
-        </p:blipFill>
-        <p:spPr>
-          <a:xfrm>
-            <a:off x="4500844" y="3500000"/>
-            <a:ext cx="5702347" cy="2350000"/>
+            <a:off x="5880000" y="1680000"/>
+            <a:ext cx="5816192" cy="4130339"/>
           </a:xfrm>
           <a:prstGeom prst="rect">
             <a:avLst/>
@@ -18150,195 +18570,15 @@
 </file>
 
 <file path=ppt/slides/slide23.xml><?xml version="1.0" encoding="utf-8"?>
-<p:sld xmlns:a="http://schemas.openxmlformats.org/drawingml/2006/main" xmlns:r="http://schemas.openxmlformats.org/officeDocument/2006/relationships" xmlns:p="http://schemas.openxmlformats.org/presentationml/2006/main">
-  <p:cSld name="Slide 17">
-    <p:bg>
-      <p:bgPr>
-        <a:solidFill>
-          <a:srgbClr val="15213B"/>
-        </a:solidFill>
-      </p:bgPr>
-    </p:bg>
+<p:sld xmlns:a="http://schemas.openxmlformats.org/drawingml/2006/main" xmlns:p="http://schemas.openxmlformats.org/presentationml/2006/main" xmlns:r="http://schemas.openxmlformats.org/officeDocument/2006/relationships">
+  <p:cSld>
     <p:spTree>
       <p:nvGrpSpPr>
         <p:cNvPr id="1" name=""/>
         <p:cNvGrpSpPr/>
         <p:nvPr/>
       </p:nvGrpSpPr>
-      <p:grpSpPr>
-        <a:xfrm>
-          <a:off x="0" y="0"/>
-          <a:ext cx="0" cy="0"/>
-          <a:chOff x="0" y="0"/>
-          <a:chExt cx="0" cy="0"/>
-        </a:xfrm>
-      </p:grpSpPr>
-      <p:sp>
-        <p:nvSpPr>
-          <p:cNvPr id="2" name="Text 0"/>
-          <p:cNvSpPr/>
-          <p:nvPr/>
-        </p:nvSpPr>
-        <p:spPr>
-          <a:xfrm>
-            <a:off x="812800" y="2673350"/>
-            <a:ext cx="10883392" cy="381000"/>
-          </a:xfrm>
-          <a:prstGeom prst="rect">
-            <a:avLst/>
-          </a:prstGeom>
-          <a:noFill/>
-          <a:ln/>
-        </p:spPr>
-        <p:txBody>
-          <a:bodyPr wrap="square" lIns="0" tIns="0" rIns="0" bIns="0" rtlCol="0" anchor="t">
-            <a:normAutofit/>
-          </a:bodyPr>
-          <a:lstStyle/>
-          <a:p>
-            <a:pPr algn="l" indent="0" marL="0">
-              <a:lnSpc>
-                <a:spcPts val="2800"/>
-              </a:lnSpc>
-              <a:buNone/>
-            </a:pPr>
-            <a:r>
-              <a:rPr lang="en-US" sz="2000" b="1" dirty="0">
-                <a:solidFill>
-                  <a:srgbClr val="C7CCDD"/>
-                </a:solidFill>
-                <a:latin typeface="Public Sans" pitchFamily="34" charset="0"/>
-                <a:ea typeface="Public Sans" pitchFamily="34" charset="-122"/>
-                <a:cs typeface="Public Sans" pitchFamily="34" charset="-120"/>
-              </a:rPr>
-              <a:t>05</a:t>
-            </a:r>
-            <a:endParaRPr lang="en-US" sz="2000" dirty="0"/>
-          </a:p>
-        </p:txBody>
-      </p:sp>
-      <p:sp>
-        <p:nvSpPr>
-          <p:cNvPr id="3" name="Text 1"/>
-          <p:cNvSpPr/>
-          <p:nvPr>
-            <p:ph type="title"/>
-          </p:nvPr>
-        </p:nvSpPr>
-        <p:spPr>
-          <a:xfrm>
-            <a:off x="812800" y="3181350"/>
-            <a:ext cx="10883392" cy="609600"/>
-          </a:xfrm>
-          <a:prstGeom prst="rect">
-            <a:avLst/>
-          </a:prstGeom>
-          <a:noFill/>
-          <a:ln/>
-        </p:spPr>
-        <p:txBody>
-          <a:bodyPr wrap="square" lIns="0" tIns="0" rIns="0" bIns="0" rtlCol="0" anchor="t">
-            <a:normAutofit/>
-          </a:bodyPr>
-          <a:lstStyle/>
-          <a:p>
-            <a:pPr algn="l" indent="0" marL="0">
-              <a:lnSpc>
-                <a:spcPts val="4600"/>
-              </a:lnSpc>
-              <a:buNone/>
-            </a:pPr>
-            <a:r>
-              <a:rPr lang="en-US" sz="4000" b="1" i="0" dirty="0">
-                <a:solidFill>
-                  <a:srgbClr val="F4F1E8"/>
-                </a:solidFill>
-                <a:latin typeface="Libre Baskerville" pitchFamily="18" charset="0"/>
-                <a:ea typeface="Libre Baskerville" pitchFamily="18" charset="-122"/>
-                <a:cs typeface="Libre Baskerville" pitchFamily="18" charset="-120"/>
-              </a:rPr>
-              <a:t>Conclusions</a:t>
-            </a:r>
-            <a:endParaRPr lang="en-US" sz="4000" dirty="0"/>
-          </a:p>
-        </p:txBody>
-      </p:sp>
-      <p:sp>
-        <p:nvSpPr>
-          <p:cNvPr id="4" name="Text 2"/>
-          <p:cNvSpPr/>
-          <p:nvPr/>
-        </p:nvSpPr>
-        <p:spPr>
-          <a:xfrm>
-            <a:off x="812800" y="3917950"/>
-            <a:ext cx="8502650" cy="292100"/>
-          </a:xfrm>
-          <a:prstGeom prst="rect">
-            <a:avLst/>
-          </a:prstGeom>
-          <a:noFill/>
-          <a:ln/>
-        </p:spPr>
-        <p:txBody>
-          <a:bodyPr wrap="square" lIns="0" tIns="0" rIns="0" bIns="0" rtlCol="0" anchor="t">
-            <a:normAutofit/>
-          </a:bodyPr>
-          <a:lstStyle/>
-          <a:p>
-            <a:pPr algn="l" indent="0" marL="0">
-              <a:lnSpc>
-                <a:spcPts val="2100"/>
-              </a:lnSpc>
-              <a:buNone/>
-            </a:pPr>
-            <a:r>
-              <a:rPr lang="en-US" sz="1500" dirty="0">
-                <a:solidFill>
-                  <a:srgbClr val="C7CCDD"/>
-                </a:solidFill>
-                <a:latin typeface="Public Sans" pitchFamily="34" charset="0"/>
-                <a:ea typeface="Public Sans" pitchFamily="34" charset="-122"/>
-                <a:cs typeface="Public Sans" pitchFamily="34" charset="-120"/>
-              </a:rPr>
-              <a:t>What we found, what we'd still need, and what comes next.</a:t>
-            </a:r>
-            <a:endParaRPr lang="en-US" sz="1500" dirty="0"/>
-          </a:p>
-        </p:txBody>
-      </p:sp>
-    </p:spTree>
-  </p:cSld>
-  <p:clrMapOvr>
-    <a:masterClrMapping/>
-  </p:clrMapOvr>
-</p:sld>
-</file>
-
-<file path=ppt/slides/slide24.xml><?xml version="1.0" encoding="utf-8"?>
-<p:sld xmlns:a="http://schemas.openxmlformats.org/drawingml/2006/main" xmlns:r="http://schemas.openxmlformats.org/officeDocument/2006/relationships" xmlns:p="http://schemas.openxmlformats.org/presentationml/2006/main">
-  <p:cSld name="Slide 18">
-    <p:bg>
-      <p:bgPr>
-        <a:solidFill>
-          <a:srgbClr val="FBFBF8"/>
-        </a:solidFill>
-      </p:bgPr>
-    </p:bg>
-    <p:spTree>
-      <p:nvGrpSpPr>
-        <p:cNvPr id="1" name=""/>
-        <p:cNvGrpSpPr/>
-        <p:nvPr/>
-      </p:nvGrpSpPr>
-      <p:grpSpPr>
-        <a:xfrm>
-          <a:off x="0" y="0"/>
-          <a:ext cx="0" cy="0"/>
-          <a:chOff x="0" y="0"/>
-          <a:chExt cx="0" cy="0"/>
-        </a:xfrm>
-      </p:grpSpPr>
+      <p:grpSpPr/>
       <p:sp>
         <p:nvSpPr>
           <p:cNvPr id="2" name="Text 0"/>
@@ -18377,7 +18617,7 @@
                 <a:ea typeface="Public Sans" pitchFamily="34" charset="-122"/>
                 <a:cs typeface="Public Sans" pitchFamily="34" charset="-120"/>
               </a:rPr>
-              <a:t>05 · CONCLUSIONS</a:t>
+              <a:t>04 · ORIGINALITY</a:t>
             </a:r>
             <a:endParaRPr lang="en-US" sz="1200" dirty="0"/>
           </a:p>
@@ -18394,7 +18634,7 @@
         <p:spPr>
           <a:xfrm>
             <a:off x="812800" y="1026120"/>
-            <a:ext cx="10883392" cy="434330"/>
+            <a:ext cx="10883392" cy="463550"/>
           </a:xfrm>
           <a:prstGeom prst="rect">
             <a:avLst/>
@@ -18410,12 +18650,12 @@
           <a:p>
             <a:pPr algn="l" indent="0" marL="0">
               <a:lnSpc>
-                <a:spcPts val="3220"/>
+                <a:spcPts val="3450"/>
               </a:lnSpc>
               <a:buNone/>
             </a:pPr>
             <a:r>
-              <a:rPr lang="en-US" sz="2800" b="1" i="0" dirty="0">
+              <a:rPr lang="en-US" sz="3000" b="1" i="0" dirty="0">
                 <a:solidFill>
                   <a:srgbClr val="15213B"/>
                 </a:solidFill>
@@ -18423,53 +18663,22 @@
                 <a:ea typeface="Libre Baskerville" pitchFamily="18" charset="-122"/>
                 <a:cs typeface="Libre Baskerville" pitchFamily="18" charset="-120"/>
               </a:rPr>
-              <a:t>Findings, limitations &amp; future work</a:t>
-            </a:r>
-            <a:endParaRPr lang="en-US" sz="2800" dirty="0"/>
-          </a:p>
-        </p:txBody>
-      </p:sp>
-      <p:sp>
-        <p:nvSpPr>
-          <p:cNvPr id="4" name="Shape 2"/>
+              <a:t>What is the model worth? Cost-benefit of ALS capacity</a:t>
+            </a:r>
+            <a:endParaRPr lang="en-US" sz="3000" dirty="0"/>
+          </a:p>
+        </p:txBody>
+      </p:sp>
+      <p:sp>
+        <p:nvSpPr>
+          <p:cNvPr id="4" name="Text 2"/>
           <p:cNvSpPr/>
           <p:nvPr/>
         </p:nvSpPr>
         <p:spPr>
           <a:xfrm>
-            <a:off x="815975" y="1552525"/>
-            <a:ext cx="10560050" cy="516880"/>
-          </a:xfrm>
-          <a:prstGeom prst="roundRect">
-            <a:avLst>
-              <a:gd name="adj" fmla="val 14128"/>
-            </a:avLst>
-          </a:prstGeom>
-          <a:solidFill>
-            <a:srgbClr val="FDFDFB"/>
-          </a:solidFill>
-          <a:ln w="6350">
-            <a:solidFill>
-              <a:srgbClr val="E2DFD6"/>
-            </a:solidFill>
-            <a:prstDash val="solid"/>
-          </a:ln>
-        </p:spPr>
-        <p:txBody>
-          <a:bodyPr/>
-          <a:p/>
-        </p:txBody>
-      </p:sp>
-      <p:sp>
-        <p:nvSpPr>
-          <p:cNvPr id="5" name="Text 3"/>
-          <p:cNvSpPr/>
-          <p:nvPr/>
-        </p:nvSpPr>
-        <p:spPr>
-          <a:xfrm>
-            <a:off x="1022350" y="1695400"/>
-            <a:ext cx="2223770" cy="256530"/>
+            <a:off x="6400000" y="1642070"/>
+            <a:ext cx="5288572" cy="4300000"/>
           </a:xfrm>
           <a:prstGeom prst="rect">
             <a:avLst/>
@@ -18483,55 +18692,12 @@
           </a:bodyPr>
           <a:lstStyle/>
           <a:p>
-            <a:pPr algn="l" indent="0" marL="0">
+            <a:pPr algn="l" marL="155956" indent="-155956">
               <a:lnSpc>
-                <a:spcPts val="1820"/>
+                <a:spcPts val="1950"/>
               </a:lnSpc>
-              <a:buNone/>
-            </a:pPr>
-            <a:r>
-              <a:rPr lang="en-US" sz="1300" b="1" dirty="0">
-                <a:solidFill>
-                  <a:srgbClr val="B05A26"/>
-                </a:solidFill>
-                <a:latin typeface="Public Sans" pitchFamily="34" charset="0"/>
-                <a:ea typeface="Public Sans" pitchFamily="34" charset="-122"/>
-                <a:cs typeface="Public Sans" pitchFamily="34" charset="-120"/>
-              </a:rPr>
-              <a:t>Key finding</a:t>
-            </a:r>
-            <a:endParaRPr lang="en-US" sz="1300" dirty="0"/>
-          </a:p>
-        </p:txBody>
-      </p:sp>
-      <p:sp>
-        <p:nvSpPr>
-          <p:cNvPr id="6" name="Text 4"/>
-          <p:cNvSpPr/>
-          <p:nvPr/>
-        </p:nvSpPr>
-        <p:spPr>
-          <a:xfrm>
-            <a:off x="3333750" y="1695400"/>
-            <a:ext cx="8070977" cy="256530"/>
-          </a:xfrm>
-          <a:prstGeom prst="rect">
-            <a:avLst/>
-          </a:prstGeom>
-          <a:noFill/>
-          <a:ln/>
-        </p:spPr>
-        <p:txBody>
-          <a:bodyPr wrap="square" lIns="0" tIns="0" rIns="0" bIns="0" rtlCol="0" anchor="t">
-            <a:normAutofit/>
-          </a:bodyPr>
-          <a:lstStyle/>
-          <a:p>
-            <a:pPr algn="l" indent="0" marL="0">
-              <a:lnSpc>
-                <a:spcPts val="1820"/>
-              </a:lnSpc>
-              <a:buNone/>
+              <a:buSzPct val="100000"/>
+              <a:buChar char="•"/>
             </a:pPr>
             <a:r>
               <a:rPr lang="en-US" sz="1300" dirty="0">
@@ -18542,115 +18708,17 @@
                 <a:ea typeface="Public Sans" pitchFamily="34" charset="-122"/>
                 <a:cs typeface="Public Sans" pitchFamily="34" charset="-120"/>
               </a:rPr>
-              <a:t>Gradient Boosting: 31.5% of fatal crashes with 15% of ALS capacity (2.1× random); MLP &amp; LR within 3 crashes</a:t>
+              <a:t>At 15% capacity, an ALS unit sent by the model reaches a fatal crash 14.9% of the time — vs. 7.1% when sent at random.</a:t>
             </a:r>
             <a:endParaRPr lang="en-US" sz="1300" dirty="0"/>
           </a:p>
-        </p:txBody>
-      </p:sp>
-      <p:sp>
-        <p:nvSpPr>
-          <p:cNvPr id="7" name="Shape 5"/>
-          <p:cNvSpPr/>
-          <p:nvPr/>
-        </p:nvSpPr>
-        <p:spPr>
-          <a:xfrm>
-            <a:off x="815975" y="2151955"/>
-            <a:ext cx="10560050" cy="516880"/>
-          </a:xfrm>
-          <a:prstGeom prst="roundRect">
-            <a:avLst>
-              <a:gd name="adj" fmla="val 14128"/>
-            </a:avLst>
-          </a:prstGeom>
-          <a:solidFill>
-            <a:srgbClr val="FDFDFB"/>
-          </a:solidFill>
-          <a:ln w="6350">
-            <a:solidFill>
-              <a:srgbClr val="E2DFD6"/>
-            </a:solidFill>
-            <a:prstDash val="solid"/>
-          </a:ln>
-        </p:spPr>
-        <p:txBody>
-          <a:bodyPr/>
-          <a:p/>
-        </p:txBody>
-      </p:sp>
-      <p:sp>
-        <p:nvSpPr>
-          <p:cNvPr id="8" name="Text 6"/>
-          <p:cNvSpPr/>
-          <p:nvPr/>
-        </p:nvSpPr>
-        <p:spPr>
-          <a:xfrm>
-            <a:off x="1022350" y="2294830"/>
-            <a:ext cx="2223770" cy="256530"/>
-          </a:xfrm>
-          <a:prstGeom prst="rect">
-            <a:avLst/>
-          </a:prstGeom>
-          <a:noFill/>
-          <a:ln/>
-        </p:spPr>
-        <p:txBody>
-          <a:bodyPr wrap="square" lIns="0" tIns="0" rIns="0" bIns="0" rtlCol="0" anchor="t">
-            <a:normAutofit/>
-          </a:bodyPr>
-          <a:lstStyle/>
-          <a:p>
-            <a:pPr algn="l" indent="0" marL="0">
+          <a:p>
+            <a:pPr algn="l" marL="155956" indent="-155956">
               <a:lnSpc>
-                <a:spcPts val="1820"/>
+                <a:spcPts val="1950"/>
               </a:lnSpc>
-              <a:buNone/>
-            </a:pPr>
-            <a:r>
-              <a:rPr lang="en-US" sz="1300" b="1" dirty="0">
-                <a:solidFill>
-                  <a:srgbClr val="B05A26"/>
-                </a:solidFill>
-                <a:latin typeface="Public Sans" pitchFamily="34" charset="0"/>
-                <a:ea typeface="Public Sans" pitchFamily="34" charset="-122"/>
-                <a:cs typeface="Public Sans" pitchFamily="34" charset="-120"/>
-              </a:rPr>
-              <a:t>Actionable insight</a:t>
-            </a:r>
-            <a:endParaRPr lang="en-US" sz="1300" dirty="0"/>
-          </a:p>
-        </p:txBody>
-      </p:sp>
-      <p:sp>
-        <p:nvSpPr>
-          <p:cNvPr id="9" name="Text 7"/>
-          <p:cNvSpPr/>
-          <p:nvPr/>
-        </p:nvSpPr>
-        <p:spPr>
-          <a:xfrm>
-            <a:off x="3333750" y="2294830"/>
-            <a:ext cx="8070977" cy="256530"/>
-          </a:xfrm>
-          <a:prstGeom prst="rect">
-            <a:avLst/>
-          </a:prstGeom>
-          <a:noFill/>
-          <a:ln/>
-        </p:spPr>
-        <p:txBody>
-          <a:bodyPr wrap="square" lIns="0" tIns="0" rIns="0" bIns="0" rtlCol="0" anchor="t">
-            <a:normAutofit/>
-          </a:bodyPr>
-          <a:lstStyle/>
-          <a:p>
-            <a:pPr algn="l" indent="0" marL="0">
-              <a:lnSpc>
-                <a:spcPts val="1820"/>
-              </a:lnSpc>
-              <a:buNone/>
+              <a:buSzPct val="100000"/>
+              <a:buChar char="•"/>
             </a:pPr>
             <a:r>
               <a:rPr lang="en-US" sz="1300" dirty="0">
@@ -18661,115 +18729,17 @@
                 <a:ea typeface="Public Sans" pitchFamily="34" charset="-122"/>
                 <a:cs typeface="Public Sans" pitchFamily="34" charset="-120"/>
               </a:rPr>
-              <a:t>Send ALS to the top-15% risk calls (≈ €585k per 1,000 calls vs. random) · base ALS near North-East hotspots</a:t>
+              <a:t>≈ €585k of value added per 1,000 calls vs. random dispatch (€2,500 per ALS, €50,000 per fatal crash reached).</a:t>
             </a:r>
             <a:endParaRPr lang="en-US" sz="1300" dirty="0"/>
           </a:p>
-        </p:txBody>
-      </p:sp>
-      <p:sp>
-        <p:nvSpPr>
-          <p:cNvPr id="10" name="Shape 8"/>
-          <p:cNvSpPr/>
-          <p:nvPr/>
-        </p:nvSpPr>
-        <p:spPr>
-          <a:xfrm>
-            <a:off x="815975" y="2751386"/>
-            <a:ext cx="10560050" cy="748010"/>
-          </a:xfrm>
-          <a:prstGeom prst="roundRect">
-            <a:avLst>
-              <a:gd name="adj" fmla="val 9763"/>
-            </a:avLst>
-          </a:prstGeom>
-          <a:solidFill>
-            <a:srgbClr val="FDFDFB"/>
-          </a:solidFill>
-          <a:ln w="6350">
-            <a:solidFill>
-              <a:srgbClr val="E2DFD6"/>
-            </a:solidFill>
-            <a:prstDash val="solid"/>
-          </a:ln>
-        </p:spPr>
-        <p:txBody>
-          <a:bodyPr/>
-          <a:p/>
-        </p:txBody>
-      </p:sp>
-      <p:sp>
-        <p:nvSpPr>
-          <p:cNvPr id="11" name="Text 9"/>
-          <p:cNvSpPr/>
-          <p:nvPr/>
-        </p:nvSpPr>
-        <p:spPr>
-          <a:xfrm>
-            <a:off x="1022350" y="2894261"/>
-            <a:ext cx="2223770" cy="487660"/>
-          </a:xfrm>
-          <a:prstGeom prst="rect">
-            <a:avLst/>
-          </a:prstGeom>
-          <a:noFill/>
-          <a:ln/>
-        </p:spPr>
-        <p:txBody>
-          <a:bodyPr wrap="square" lIns="0" tIns="0" rIns="0" bIns="0" rtlCol="0" anchor="t">
-            <a:normAutofit/>
-          </a:bodyPr>
-          <a:lstStyle/>
-          <a:p>
-            <a:pPr algn="l" indent="0" marL="0">
+          <a:p>
+            <a:pPr algn="l" marL="155956" indent="-155956">
               <a:lnSpc>
-                <a:spcPts val="1820"/>
+                <a:spcPts val="1950"/>
               </a:lnSpc>
-              <a:buNone/>
-            </a:pPr>
-            <a:r>
-              <a:rPr lang="en-US" sz="1300" b="1" dirty="0">
-                <a:solidFill>
-                  <a:srgbClr val="B05A26"/>
-                </a:solidFill>
-                <a:latin typeface="Public Sans" pitchFamily="34" charset="0"/>
-                <a:ea typeface="Public Sans" pitchFamily="34" charset="-122"/>
-                <a:cs typeface="Public Sans" pitchFamily="34" charset="-120"/>
-              </a:rPr>
-              <a:t>Limitations</a:t>
-            </a:r>
-            <a:endParaRPr lang="en-US" sz="1300" dirty="0"/>
-          </a:p>
-        </p:txBody>
-      </p:sp>
-      <p:sp>
-        <p:nvSpPr>
-          <p:cNvPr id="12" name="Text 10"/>
-          <p:cNvSpPr/>
-          <p:nvPr/>
-        </p:nvSpPr>
-        <p:spPr>
-          <a:xfrm>
-            <a:off x="3333750" y="2894261"/>
-            <a:ext cx="8070977" cy="487660"/>
-          </a:xfrm>
-          <a:prstGeom prst="rect">
-            <a:avLst/>
-          </a:prstGeom>
-          <a:noFill/>
-          <a:ln/>
-        </p:spPr>
-        <p:txBody>
-          <a:bodyPr wrap="square" lIns="0" tIns="0" rIns="0" bIns="0" rtlCol="0" anchor="t">
-            <a:normAutofit/>
-          </a:bodyPr>
-          <a:lstStyle/>
-          <a:p>
-            <a:pPr algn="l" indent="0" marL="0">
-              <a:lnSpc>
-                <a:spcPts val="1820"/>
-              </a:lnSpc>
-              <a:buNone/>
+              <a:buSzPct val="100000"/>
+              <a:buChar char="•"/>
             </a:pPr>
             <a:r>
               <a:rPr lang="en-US" sz="1300" dirty="0">
@@ -18780,115 +18750,17 @@
                 <a:ea typeface="Public Sans" pitchFamily="34" charset="-122"/>
                 <a:cs typeface="Public Sans" pitchFamily="34" charset="-120"/>
               </a:rPr>
-              <a:t>Reporting change in 2015 (e-DAT) limits older data · GPS only from 2017 and no highway ID, so location is approximate · no traffic, weather or caller information · 150,000-row sample</a:t>
+              <a:t>Robust to the €50k assumption: dispatch pays off once reaching a fatal crash is worth &gt; €16.8k with the model, vs. &gt; €35.2k at random.</a:t>
             </a:r>
             <a:endParaRPr lang="en-US" sz="1300" dirty="0"/>
           </a:p>
-        </p:txBody>
-      </p:sp>
-      <p:sp>
-        <p:nvSpPr>
-          <p:cNvPr id="13" name="Shape 11"/>
-          <p:cNvSpPr/>
-          <p:nvPr/>
-        </p:nvSpPr>
-        <p:spPr>
-          <a:xfrm>
-            <a:off x="815975" y="3581946"/>
-            <a:ext cx="10560050" cy="516880"/>
-          </a:xfrm>
-          <a:prstGeom prst="roundRect">
-            <a:avLst>
-              <a:gd name="adj" fmla="val 14128"/>
-            </a:avLst>
-          </a:prstGeom>
-          <a:solidFill>
-            <a:srgbClr val="FDFDFB"/>
-          </a:solidFill>
-          <a:ln w="6350">
-            <a:solidFill>
-              <a:srgbClr val="E2DFD6"/>
-            </a:solidFill>
-            <a:prstDash val="solid"/>
-          </a:ln>
-        </p:spPr>
-        <p:txBody>
-          <a:bodyPr/>
-          <a:p/>
-        </p:txBody>
-      </p:sp>
-      <p:sp>
-        <p:nvSpPr>
-          <p:cNvPr id="14" name="Text 12"/>
-          <p:cNvSpPr/>
-          <p:nvPr/>
-        </p:nvSpPr>
-        <p:spPr>
-          <a:xfrm>
-            <a:off x="1022350" y="3724821"/>
-            <a:ext cx="2223770" cy="256530"/>
-          </a:xfrm>
-          <a:prstGeom prst="rect">
-            <a:avLst/>
-          </a:prstGeom>
-          <a:noFill/>
-          <a:ln/>
-        </p:spPr>
-        <p:txBody>
-          <a:bodyPr wrap="square" lIns="0" tIns="0" rIns="0" bIns="0" rtlCol="0" anchor="t">
-            <a:normAutofit/>
-          </a:bodyPr>
-          <a:lstStyle/>
-          <a:p>
-            <a:pPr algn="l" indent="0" marL="0">
+          <a:p>
+            <a:pPr algn="l" marL="155956" indent="-155956">
               <a:lnSpc>
-                <a:spcPts val="1820"/>
+                <a:spcPts val="1950"/>
               </a:lnSpc>
-              <a:buNone/>
-            </a:pPr>
-            <a:r>
-              <a:rPr lang="en-US" sz="1300" b="1" dirty="0">
-                <a:solidFill>
-                  <a:srgbClr val="B05A26"/>
-                </a:solidFill>
-                <a:latin typeface="Public Sans" pitchFamily="34" charset="0"/>
-                <a:ea typeface="Public Sans" pitchFamily="34" charset="-122"/>
-                <a:cs typeface="Public Sans" pitchFamily="34" charset="-120"/>
-              </a:rPr>
-              <a:t>Future work</a:t>
-            </a:r>
-            <a:endParaRPr lang="en-US" sz="1300" dirty="0"/>
-          </a:p>
-        </p:txBody>
-      </p:sp>
-      <p:sp>
-        <p:nvSpPr>
-          <p:cNvPr id="15" name="Text 13"/>
-          <p:cNvSpPr/>
-          <p:nvPr/>
-        </p:nvSpPr>
-        <p:spPr>
-          <a:xfrm>
-            <a:off x="3333750" y="3724821"/>
-            <a:ext cx="8070977" cy="256530"/>
-          </a:xfrm>
-          <a:prstGeom prst="rect">
-            <a:avLst/>
-          </a:prstGeom>
-          <a:noFill/>
-          <a:ln/>
-        </p:spPr>
-        <p:txBody>
-          <a:bodyPr wrap="square" lIns="0" tIns="0" rIns="0" bIns="0" rtlCol="0" anchor="t">
-            <a:normAutofit/>
-          </a:bodyPr>
-          <a:lstStyle/>
-          <a:p>
-            <a:pPr algn="l" indent="0" marL="0">
-              <a:lnSpc>
-                <a:spcPts val="1820"/>
-              </a:lnSpc>
-              <a:buNone/>
+              <a:buSzPct val="100000"/>
+              <a:buChar char="•"/>
             </a:pPr>
             <a:r>
               <a:rPr lang="en-US" sz="1300" dirty="0">
@@ -18899,7 +18771,7 @@
                 <a:ea typeface="Public Sans" pitchFamily="34" charset="-122"/>
                 <a:cs typeface="Public Sans" pitchFamily="34" charset="-120"/>
               </a:rPr>
-              <a:t>Collect GPS at every call and retrain with location risk (test PR-AUC 0.131 → 0.141) · add weather, traffic &amp; caller details</a:t>
+              <a:t>Net benefit peaks at ~64% capacity: ALS is undersized, with diminishing returns — the first 15% is worth €743k per 1,000 calls, the next 10% only €278k more.</a:t>
             </a:r>
             <a:endParaRPr lang="en-US" sz="1300" dirty="0"/>
           </a:p>
@@ -18907,7 +18779,7 @@
       </p:sp>
       <p:sp>
         <p:nvSpPr>
-          <p:cNvPr id="16" name="Text 14"/>
+          <p:cNvPr id="5" name="Text 3"/>
           <p:cNvSpPr/>
           <p:nvPr/>
         </p:nvSpPr>
@@ -18951,14 +18823,14 @@
       </p:sp>
       <p:sp>
         <p:nvSpPr>
-          <p:cNvPr id="17" name="Text 15"/>
+          <p:cNvPr id="6" name="Text 4"/>
           <p:cNvSpPr/>
           <p:nvPr/>
         </p:nvSpPr>
         <p:spPr>
           <a:xfrm>
-            <a:off x="11218466" y="6238280"/>
-            <a:ext cx="211534" cy="238720"/>
+            <a:off x="11221145" y="6238280"/>
+            <a:ext cx="208855" cy="238720"/>
           </a:xfrm>
           <a:prstGeom prst="rect">
             <a:avLst/>
@@ -18987,12 +18859,385 @@
                 <a:ea typeface="Public Sans" pitchFamily="34" charset="-122"/>
                 <a:cs typeface="Public Sans" pitchFamily="34" charset="-120"/>
               </a:rPr>
-              <a:t>26</a:t>
+              <a:t>23</a:t>
             </a:r>
             <a:endParaRPr lang="en-US" sz="1200" dirty="0"/>
           </a:p>
         </p:txBody>
       </p:sp>
+      <p:pic>
+        <p:nvPicPr>
+          <p:cNvPr id="7" name="Picture 6" descr="task3_value_vs_capacity.png"/>
+          <p:cNvPicPr>
+            <a:picLocks noChangeAspect="1"/>
+          </p:cNvPicPr>
+          <p:nvPr/>
+        </p:nvPicPr>
+        <p:blipFill>
+          <a:blip r:embed="rId2"/>
+          <a:stretch>
+            <a:fillRect/>
+          </a:stretch>
+        </p:blipFill>
+        <p:spPr>
+          <a:xfrm>
+            <a:off x="812800" y="1642070"/>
+            <a:ext cx="5400000" cy="3349367"/>
+          </a:xfrm>
+          <a:prstGeom prst="rect">
+            <a:avLst/>
+          </a:prstGeom>
+        </p:spPr>
+      </p:pic>
+    </p:spTree>
+  </p:cSld>
+  <p:clrMapOvr>
+    <a:masterClrMapping/>
+  </p:clrMapOvr>
+</p:sld>
+</file>
+
+<file path=ppt/slides/slide24.xml><?xml version="1.0" encoding="utf-8"?>
+<p:sld xmlns:a="http://schemas.openxmlformats.org/drawingml/2006/main" xmlns:p="http://schemas.openxmlformats.org/presentationml/2006/main" xmlns:r="http://schemas.openxmlformats.org/officeDocument/2006/relationships">
+  <p:cSld>
+    <p:spTree>
+      <p:nvGrpSpPr>
+        <p:cNvPr id="1" name=""/>
+        <p:cNvGrpSpPr/>
+        <p:nvPr/>
+      </p:nvGrpSpPr>
+      <p:grpSpPr/>
+      <p:sp>
+        <p:nvSpPr>
+          <p:cNvPr id="2" name="Text 0"/>
+          <p:cNvSpPr/>
+          <p:nvPr/>
+        </p:nvSpPr>
+        <p:spPr>
+          <a:xfrm>
+            <a:off x="812800" y="812800"/>
+            <a:ext cx="10883392" cy="238720"/>
+          </a:xfrm>
+          <a:prstGeom prst="rect">
+            <a:avLst/>
+          </a:prstGeom>
+          <a:noFill/>
+          <a:ln/>
+        </p:spPr>
+        <p:txBody>
+          <a:bodyPr wrap="square" lIns="0" tIns="0" rIns="0" bIns="0" rtlCol="0" anchor="t">
+            <a:normAutofit/>
+          </a:bodyPr>
+          <a:lstStyle/>
+          <a:p>
+            <a:pPr algn="l" indent="0" marL="0">
+              <a:lnSpc>
+                <a:spcPts val="1680"/>
+              </a:lnSpc>
+              <a:buNone/>
+            </a:pPr>
+            <a:r>
+              <a:rPr lang="en-US" sz="1200" b="1" spc="150" kern="0" dirty="0">
+                <a:solidFill>
+                  <a:srgbClr val="15213B"/>
+                </a:solidFill>
+                <a:latin typeface="Public Sans" pitchFamily="34" charset="0"/>
+                <a:ea typeface="Public Sans" pitchFamily="34" charset="-122"/>
+                <a:cs typeface="Public Sans" pitchFamily="34" charset="-120"/>
+              </a:rPr>
+              <a:t>04 · ORIGINALITY</a:t>
+            </a:r>
+            <a:endParaRPr lang="en-US" sz="1200" dirty="0"/>
+          </a:p>
+        </p:txBody>
+      </p:sp>
+      <p:sp>
+        <p:nvSpPr>
+          <p:cNvPr id="3" name="Text 1"/>
+          <p:cNvSpPr/>
+          <p:nvPr>
+            <p:ph type="title"/>
+          </p:nvPr>
+        </p:nvSpPr>
+        <p:spPr>
+          <a:xfrm>
+            <a:off x="812800" y="1026120"/>
+            <a:ext cx="10883392" cy="463550"/>
+          </a:xfrm>
+          <a:prstGeom prst="rect">
+            <a:avLst/>
+          </a:prstGeom>
+          <a:noFill/>
+          <a:ln/>
+        </p:spPr>
+        <p:txBody>
+          <a:bodyPr wrap="square" lIns="0" tIns="0" rIns="0" bIns="0" rtlCol="0" anchor="t">
+            <a:normAutofit/>
+          </a:bodyPr>
+          <a:lstStyle/>
+          <a:p>
+            <a:pPr algn="l" indent="0" marL="0">
+              <a:lnSpc>
+                <a:spcPts val="3450"/>
+              </a:lnSpc>
+              <a:buNone/>
+            </a:pPr>
+            <a:r>
+              <a:rPr lang="en-US" sz="3000" b="1" i="0" dirty="0">
+                <a:solidFill>
+                  <a:srgbClr val="15213B"/>
+                </a:solidFill>
+                <a:latin typeface="Libre Baskerville" pitchFamily="18" charset="0"/>
+                <a:ea typeface="Libre Baskerville" pitchFamily="18" charset="-122"/>
+                <a:cs typeface="Libre Baskerville" pitchFamily="18" charset="-120"/>
+              </a:rPr>
+              <a:t>Fatal hotspots persist — and GPS is the missing signal</a:t>
+            </a:r>
+            <a:endParaRPr lang="en-US" sz="3000" dirty="0"/>
+          </a:p>
+        </p:txBody>
+      </p:sp>
+      <p:sp>
+        <p:nvSpPr>
+          <p:cNvPr id="4" name="Text 2"/>
+          <p:cNvSpPr/>
+          <p:nvPr/>
+        </p:nvSpPr>
+        <p:spPr>
+          <a:xfrm>
+            <a:off x="6400000" y="1642070"/>
+            <a:ext cx="5288572" cy="4300000"/>
+          </a:xfrm>
+          <a:prstGeom prst="rect">
+            <a:avLst/>
+          </a:prstGeom>
+          <a:noFill/>
+          <a:ln/>
+        </p:spPr>
+        <p:txBody>
+          <a:bodyPr wrap="square" lIns="0" tIns="0" rIns="0" bIns="0" rtlCol="0" anchor="t">
+            <a:normAutofit/>
+          </a:bodyPr>
+          <a:lstStyle/>
+          <a:p>
+            <a:pPr algn="l" marL="155956" indent="-155956">
+              <a:lnSpc>
+                <a:spcPts val="1950"/>
+              </a:lnSpc>
+              <a:buSzPct val="100000"/>
+              <a:buChar char="•"/>
+            </a:pPr>
+            <a:r>
+              <a:rPr lang="en-US" sz="1300" dirty="0">
+                <a:solidFill>
+                  <a:srgbClr val="46516B"/>
+                </a:solidFill>
+                <a:latin typeface="Public Sans" pitchFamily="34" charset="0"/>
+                <a:ea typeface="Public Sans" pitchFamily="34" charset="-122"/>
+                <a:cs typeface="Public Sans" pitchFamily="34" charset="-120"/>
+              </a:rPr>
+              <a:t>1° grid (≈ 110 km) on the GPS years 2017–2023; hotspots = riskiest cells holding 15% of crashes (109 cells).</a:t>
+            </a:r>
+            <a:endParaRPr lang="en-US" sz="1300" dirty="0"/>
+          </a:p>
+          <a:p>
+            <a:pPr algn="l" marL="155956" indent="-155956">
+              <a:lnSpc>
+                <a:spcPts val="1950"/>
+              </a:lnSpc>
+              <a:buSzPct val="100000"/>
+              <a:buChar char="•"/>
+            </a:pPr>
+            <a:r>
+              <a:rPr lang="en-US" sz="1300" dirty="0">
+                <a:solidFill>
+                  <a:srgbClr val="46516B"/>
+                </a:solidFill>
+                <a:latin typeface="Public Sans" pitchFamily="34" charset="0"/>
+                <a:ea typeface="Public Sans" pitchFamily="34" charset="-122"/>
+                <a:cs typeface="Public Sans" pitchFamily="34" charset="-120"/>
+              </a:rPr>
+              <a:t>Checked on 2024–25, never seen: 14% of crashes but 25.5% of deaths; fatal rate 12.6% vs. 6.2% elsewhere.</a:t>
+            </a:r>
+            <a:endParaRPr lang="en-US" sz="1300" dirty="0"/>
+          </a:p>
+          <a:p>
+            <a:pPr algn="l" marL="155956" indent="-155956">
+              <a:lnSpc>
+                <a:spcPts val="1950"/>
+              </a:lnSpc>
+              <a:buSzPct val="100000"/>
+              <a:buChar char="•"/>
+            </a:pPr>
+            <a:r>
+              <a:rPr lang="en-US" sz="1300" dirty="0">
+                <a:solidFill>
+                  <a:srgbClr val="46516B"/>
+                </a:solidFill>
+                <a:latin typeface="Public Sans" pitchFamily="34" charset="0"/>
+                <a:ea typeface="Public Sans" pitchFamily="34" charset="-122"/>
+                <a:cs typeface="Public Sans" pitchFamily="34" charset="-120"/>
+              </a:rPr>
+              <a:t>Highest risk in the North-East (Pernambuco, Bahia): candidate ALS / helicopter bases and inspections.</a:t>
+            </a:r>
+            <a:endParaRPr lang="en-US" sz="1300" dirty="0"/>
+          </a:p>
+          <a:p>
+            <a:pPr algn="l" marL="155956" indent="-155956">
+              <a:lnSpc>
+                <a:spcPts val="1950"/>
+              </a:lnSpc>
+              <a:buSzPct val="100000"/>
+              <a:buChar char="•"/>
+            </a:pPr>
+            <a:r>
+              <a:rPr lang="en-US" sz="1300" dirty="0">
+                <a:solidFill>
+                  <a:srgbClr val="46516B"/>
+                </a:solidFill>
+                <a:latin typeface="Public Sans" pitchFamily="34" charset="0"/>
+                <a:ea typeface="Public Sans" pitchFamily="34" charset="-122"/>
+                <a:cs typeface="Public Sans" pitchFamily="34" charset="-120"/>
+              </a:rPr>
+              <a:t>Adding GPS cell risk to Gradient Boosting (train 2017–21): test PR-AUC 0.131 → 0.141, validation 0.132 → 0.153 — more than any change of algorithm.</a:t>
+            </a:r>
+            <a:endParaRPr lang="en-US" sz="1300" dirty="0"/>
+          </a:p>
+          <a:p>
+            <a:pPr algn="l" marL="155956" indent="-155956">
+              <a:lnSpc>
+                <a:spcPts val="1950"/>
+              </a:lnSpc>
+              <a:buSzPct val="100000"/>
+              <a:buChar char="•"/>
+            </a:pPr>
+            <a:r>
+              <a:rPr lang="en-US" sz="1300" dirty="0">
+                <a:solidFill>
+                  <a:srgbClr val="46516B"/>
+                </a:solidFill>
+                <a:latin typeface="Public Sans" pitchFamily="34" charset="0"/>
+                <a:ea typeface="Public Sans" pitchFamily="34" charset="-122"/>
+                <a:cs typeface="Public Sans" pitchFamily="34" charset="-120"/>
+              </a:rPr>
+              <a:t>Interactive Folium map: reports/figures/task3_hotspot_map.html</a:t>
+            </a:r>
+            <a:endParaRPr lang="en-US" sz="1300" dirty="0"/>
+          </a:p>
+        </p:txBody>
+      </p:sp>
+      <p:sp>
+        <p:nvSpPr>
+          <p:cNvPr id="5" name="Text 3"/>
+          <p:cNvSpPr/>
+          <p:nvPr/>
+        </p:nvSpPr>
+        <p:spPr>
+          <a:xfrm>
+            <a:off x="812800" y="6238280"/>
+            <a:ext cx="4057174" cy="238720"/>
+          </a:xfrm>
+          <a:prstGeom prst="rect">
+            <a:avLst/>
+          </a:prstGeom>
+          <a:noFill/>
+          <a:ln/>
+        </p:spPr>
+        <p:txBody>
+          <a:bodyPr wrap="square" lIns="0" tIns="0" rIns="0" bIns="0" rtlCol="0" anchor="t">
+            <a:normAutofit/>
+          </a:bodyPr>
+          <a:lstStyle/>
+          <a:p>
+            <a:pPr algn="l" indent="0" marL="0">
+              <a:lnSpc>
+                <a:spcPts val="1680"/>
+              </a:lnSpc>
+              <a:buNone/>
+            </a:pPr>
+            <a:r>
+              <a:rPr lang="en-US" sz="1200" dirty="0">
+                <a:solidFill>
+                  <a:srgbClr val="8B9099"/>
+                </a:solidFill>
+                <a:latin typeface="Public Sans" pitchFamily="34" charset="0"/>
+                <a:ea typeface="Public Sans" pitchFamily="34" charset="-122"/>
+                <a:cs typeface="Public Sans" pitchFamily="34" charset="-120"/>
+              </a:rPr>
+              <a:t>Road Safety Predictive Analytics — Group 6</a:t>
+            </a:r>
+            <a:endParaRPr lang="en-US" sz="1200" dirty="0"/>
+          </a:p>
+        </p:txBody>
+      </p:sp>
+      <p:sp>
+        <p:nvSpPr>
+          <p:cNvPr id="6" name="Text 4"/>
+          <p:cNvSpPr/>
+          <p:nvPr/>
+        </p:nvSpPr>
+        <p:spPr>
+          <a:xfrm>
+            <a:off x="11221145" y="6238280"/>
+            <a:ext cx="208855" cy="238720"/>
+          </a:xfrm>
+          <a:prstGeom prst="rect">
+            <a:avLst/>
+          </a:prstGeom>
+          <a:noFill/>
+          <a:ln/>
+        </p:spPr>
+        <p:txBody>
+          <a:bodyPr wrap="square" lIns="0" tIns="0" rIns="0" bIns="0" rtlCol="0" anchor="t">
+            <a:normAutofit/>
+          </a:bodyPr>
+          <a:lstStyle/>
+          <a:p>
+            <a:pPr algn="l" indent="0" marL="0">
+              <a:lnSpc>
+                <a:spcPts val="1680"/>
+              </a:lnSpc>
+              <a:buNone/>
+            </a:pPr>
+            <a:r>
+              <a:rPr lang="en-US" sz="1200" dirty="0">
+                <a:solidFill>
+                  <a:srgbClr val="8B9099"/>
+                </a:solidFill>
+                <a:latin typeface="Public Sans" pitchFamily="34" charset="0"/>
+                <a:ea typeface="Public Sans" pitchFamily="34" charset="-122"/>
+                <a:cs typeface="Public Sans" pitchFamily="34" charset="-120"/>
+              </a:rPr>
+              <a:t>24</a:t>
+            </a:r>
+            <a:endParaRPr lang="en-US" sz="1200" dirty="0"/>
+          </a:p>
+        </p:txBody>
+      </p:sp>
+      <p:pic>
+        <p:nvPicPr>
+          <p:cNvPr id="7" name="Picture 6" descr="task3_hotspots.png"/>
+          <p:cNvPicPr>
+            <a:picLocks noChangeAspect="1"/>
+          </p:cNvPicPr>
+          <p:nvPr/>
+        </p:nvPicPr>
+        <p:blipFill>
+          <a:blip r:embed="rId2"/>
+          <a:stretch>
+            <a:fillRect/>
+          </a:stretch>
+        </p:blipFill>
+        <p:spPr>
+          <a:xfrm>
+            <a:off x="812800" y="1642070"/>
+            <a:ext cx="4416202" cy="4450000"/>
+          </a:xfrm>
+          <a:prstGeom prst="rect">
+            <a:avLst/>
+          </a:prstGeom>
+        </p:spPr>
+      </p:pic>
     </p:spTree>
   </p:cSld>
   <p:clrMapOvr>
@@ -19063,7 +19308,7 @@
                 <a:ea typeface="Public Sans" pitchFamily="34" charset="-122"/>
                 <a:cs typeface="Public Sans" pitchFamily="34" charset="-120"/>
               </a:rPr>
-              <a:t>06</a:t>
+              <a:t>05</a:t>
             </a:r>
             <a:endParaRPr lang="en-US" sz="2000" dirty="0"/>
           </a:p>
@@ -19109,7 +19354,7 @@
                 <a:ea typeface="Libre Baskerville" pitchFamily="18" charset="-122"/>
                 <a:cs typeface="Libre Baskerville" pitchFamily="18" charset="-120"/>
               </a:rPr>
-              <a:t>Annexes</a:t>
+              <a:t>Conclusions</a:t>
             </a:r>
             <a:endParaRPr lang="en-US" sz="4000" dirty="0"/>
           </a:p>
@@ -19153,7 +19398,7 @@
                 <a:ea typeface="Public Sans" pitchFamily="34" charset="-122"/>
                 <a:cs typeface="Public Sans" pitchFamily="34" charset="-120"/>
               </a:rPr>
-              <a:t>Details for questions, not presented in the 10 minutes.</a:t>
+              <a:t>What we found, what we'd still need, and what comes next.</a:t>
             </a:r>
             <a:endParaRPr lang="en-US" sz="1500" dirty="0"/>
           </a:p>
@@ -19168,6 +19413,858 @@
 </file>
 
 <file path=ppt/slides/slide26.xml><?xml version="1.0" encoding="utf-8"?>
+<p:sld xmlns:a="http://schemas.openxmlformats.org/drawingml/2006/main" xmlns:r="http://schemas.openxmlformats.org/officeDocument/2006/relationships" xmlns:p="http://schemas.openxmlformats.org/presentationml/2006/main">
+  <p:cSld name="Slide 18">
+    <p:bg>
+      <p:bgPr>
+        <a:solidFill>
+          <a:srgbClr val="FBFBF8"/>
+        </a:solidFill>
+      </p:bgPr>
+    </p:bg>
+    <p:spTree>
+      <p:nvGrpSpPr>
+        <p:cNvPr id="1" name=""/>
+        <p:cNvGrpSpPr/>
+        <p:nvPr/>
+      </p:nvGrpSpPr>
+      <p:grpSpPr>
+        <a:xfrm>
+          <a:off x="0" y="0"/>
+          <a:ext cx="0" cy="0"/>
+          <a:chOff x="0" y="0"/>
+          <a:chExt cx="0" cy="0"/>
+        </a:xfrm>
+      </p:grpSpPr>
+      <p:sp>
+        <p:nvSpPr>
+          <p:cNvPr id="2" name="Text 0"/>
+          <p:cNvSpPr/>
+          <p:nvPr/>
+        </p:nvSpPr>
+        <p:spPr>
+          <a:xfrm>
+            <a:off x="812800" y="812800"/>
+            <a:ext cx="10883392" cy="238720"/>
+          </a:xfrm>
+          <a:prstGeom prst="rect">
+            <a:avLst/>
+          </a:prstGeom>
+          <a:noFill/>
+          <a:ln/>
+        </p:spPr>
+        <p:txBody>
+          <a:bodyPr wrap="square" lIns="0" tIns="0" rIns="0" bIns="0" rtlCol="0" anchor="t">
+            <a:normAutofit/>
+          </a:bodyPr>
+          <a:lstStyle/>
+          <a:p>
+            <a:pPr algn="l" indent="0" marL="0">
+              <a:lnSpc>
+                <a:spcPts val="1680"/>
+              </a:lnSpc>
+              <a:buNone/>
+            </a:pPr>
+            <a:r>
+              <a:rPr lang="en-US" sz="1200" b="1" spc="150" kern="0" dirty="0">
+                <a:solidFill>
+                  <a:srgbClr val="15213B"/>
+                </a:solidFill>
+                <a:latin typeface="Public Sans" pitchFamily="34" charset="0"/>
+                <a:ea typeface="Public Sans" pitchFamily="34" charset="-122"/>
+                <a:cs typeface="Public Sans" pitchFamily="34" charset="-120"/>
+              </a:rPr>
+              <a:t>05 · CONCLUSIONS</a:t>
+            </a:r>
+            <a:endParaRPr lang="en-US" sz="1200" dirty="0"/>
+          </a:p>
+        </p:txBody>
+      </p:sp>
+      <p:sp>
+        <p:nvSpPr>
+          <p:cNvPr id="3" name="Text 1"/>
+          <p:cNvSpPr/>
+          <p:nvPr>
+            <p:ph type="title"/>
+          </p:nvPr>
+        </p:nvSpPr>
+        <p:spPr>
+          <a:xfrm>
+            <a:off x="812800" y="1026120"/>
+            <a:ext cx="10883392" cy="434330"/>
+          </a:xfrm>
+          <a:prstGeom prst="rect">
+            <a:avLst/>
+          </a:prstGeom>
+          <a:noFill/>
+          <a:ln/>
+        </p:spPr>
+        <p:txBody>
+          <a:bodyPr wrap="square" lIns="0" tIns="0" rIns="0" bIns="0" rtlCol="0" anchor="t">
+            <a:normAutofit/>
+          </a:bodyPr>
+          <a:lstStyle/>
+          <a:p>
+            <a:pPr algn="l" indent="0" marL="0">
+              <a:lnSpc>
+                <a:spcPts val="3220"/>
+              </a:lnSpc>
+              <a:buNone/>
+            </a:pPr>
+            <a:r>
+              <a:rPr lang="en-US" sz="2800" b="1" i="0" dirty="0">
+                <a:solidFill>
+                  <a:srgbClr val="15213B"/>
+                </a:solidFill>
+                <a:latin typeface="Libre Baskerville" pitchFamily="18" charset="0"/>
+                <a:ea typeface="Libre Baskerville" pitchFamily="18" charset="-122"/>
+                <a:cs typeface="Libre Baskerville" pitchFamily="18" charset="-120"/>
+              </a:rPr>
+              <a:t>Findings, limitations &amp; future work</a:t>
+            </a:r>
+            <a:endParaRPr lang="en-US" sz="2800" dirty="0"/>
+          </a:p>
+        </p:txBody>
+      </p:sp>
+      <p:sp>
+        <p:nvSpPr>
+          <p:cNvPr id="4" name="Shape 2"/>
+          <p:cNvSpPr/>
+          <p:nvPr/>
+        </p:nvSpPr>
+        <p:spPr>
+          <a:xfrm>
+            <a:off x="815975" y="1552525"/>
+            <a:ext cx="10560050" cy="516880"/>
+          </a:xfrm>
+          <a:prstGeom prst="roundRect">
+            <a:avLst>
+              <a:gd name="adj" fmla="val 14128"/>
+            </a:avLst>
+          </a:prstGeom>
+          <a:solidFill>
+            <a:srgbClr val="FDFDFB"/>
+          </a:solidFill>
+          <a:ln w="6350">
+            <a:solidFill>
+              <a:srgbClr val="E2DFD6"/>
+            </a:solidFill>
+            <a:prstDash val="solid"/>
+          </a:ln>
+        </p:spPr>
+        <p:txBody>
+          <a:bodyPr/>
+          <a:p/>
+        </p:txBody>
+      </p:sp>
+      <p:sp>
+        <p:nvSpPr>
+          <p:cNvPr id="5" name="Text 3"/>
+          <p:cNvSpPr/>
+          <p:nvPr/>
+        </p:nvSpPr>
+        <p:spPr>
+          <a:xfrm>
+            <a:off x="1022350" y="1695400"/>
+            <a:ext cx="2223770" cy="256530"/>
+          </a:xfrm>
+          <a:prstGeom prst="rect">
+            <a:avLst/>
+          </a:prstGeom>
+          <a:noFill/>
+          <a:ln/>
+        </p:spPr>
+        <p:txBody>
+          <a:bodyPr wrap="square" lIns="0" tIns="0" rIns="0" bIns="0" rtlCol="0" anchor="t">
+            <a:normAutofit/>
+          </a:bodyPr>
+          <a:lstStyle/>
+          <a:p>
+            <a:pPr algn="l" indent="0" marL="0">
+              <a:lnSpc>
+                <a:spcPts val="1820"/>
+              </a:lnSpc>
+              <a:buNone/>
+            </a:pPr>
+            <a:r>
+              <a:rPr lang="en-US" sz="1300" b="1" dirty="0">
+                <a:solidFill>
+                  <a:srgbClr val="B05A26"/>
+                </a:solidFill>
+                <a:latin typeface="Public Sans" pitchFamily="34" charset="0"/>
+                <a:ea typeface="Public Sans" pitchFamily="34" charset="-122"/>
+                <a:cs typeface="Public Sans" pitchFamily="34" charset="-120"/>
+              </a:rPr>
+              <a:t>Key finding</a:t>
+            </a:r>
+            <a:endParaRPr lang="en-US" sz="1300" dirty="0"/>
+          </a:p>
+        </p:txBody>
+      </p:sp>
+      <p:sp>
+        <p:nvSpPr>
+          <p:cNvPr id="6" name="Text 4"/>
+          <p:cNvSpPr/>
+          <p:nvPr/>
+        </p:nvSpPr>
+        <p:spPr>
+          <a:xfrm>
+            <a:off x="3333750" y="1695400"/>
+            <a:ext cx="8070977" cy="256530"/>
+          </a:xfrm>
+          <a:prstGeom prst="rect">
+            <a:avLst/>
+          </a:prstGeom>
+          <a:noFill/>
+          <a:ln/>
+        </p:spPr>
+        <p:txBody>
+          <a:bodyPr wrap="square" lIns="0" tIns="0" rIns="0" bIns="0" rtlCol="0" anchor="t">
+            <a:normAutofit/>
+          </a:bodyPr>
+          <a:lstStyle/>
+          <a:p>
+            <a:pPr algn="l" indent="0" marL="0">
+              <a:lnSpc>
+                <a:spcPts val="1820"/>
+              </a:lnSpc>
+              <a:buNone/>
+            </a:pPr>
+            <a:r>
+              <a:rPr lang="en-US" sz="1300" dirty="0">
+                <a:solidFill>
+                  <a:srgbClr val="46516B"/>
+                </a:solidFill>
+                <a:latin typeface="Public Sans" pitchFamily="34" charset="0"/>
+                <a:ea typeface="Public Sans" pitchFamily="34" charset="-122"/>
+                <a:cs typeface="Public Sans" pitchFamily="34" charset="-120"/>
+              </a:rPr>
+              <a:t>Gradient Boosting: 31.5% of fatal crashes with 15% of ALS capacity (2.1× random); MLP &amp; LR within 3 crashes</a:t>
+            </a:r>
+            <a:endParaRPr lang="en-US" sz="1300" dirty="0"/>
+          </a:p>
+        </p:txBody>
+      </p:sp>
+      <p:sp>
+        <p:nvSpPr>
+          <p:cNvPr id="7" name="Shape 5"/>
+          <p:cNvSpPr/>
+          <p:nvPr/>
+        </p:nvSpPr>
+        <p:spPr>
+          <a:xfrm>
+            <a:off x="815975" y="2151955"/>
+            <a:ext cx="10560050" cy="516880"/>
+          </a:xfrm>
+          <a:prstGeom prst="roundRect">
+            <a:avLst>
+              <a:gd name="adj" fmla="val 14128"/>
+            </a:avLst>
+          </a:prstGeom>
+          <a:solidFill>
+            <a:srgbClr val="FDFDFB"/>
+          </a:solidFill>
+          <a:ln w="6350">
+            <a:solidFill>
+              <a:srgbClr val="E2DFD6"/>
+            </a:solidFill>
+            <a:prstDash val="solid"/>
+          </a:ln>
+        </p:spPr>
+        <p:txBody>
+          <a:bodyPr/>
+          <a:p/>
+        </p:txBody>
+      </p:sp>
+      <p:sp>
+        <p:nvSpPr>
+          <p:cNvPr id="8" name="Text 6"/>
+          <p:cNvSpPr/>
+          <p:nvPr/>
+        </p:nvSpPr>
+        <p:spPr>
+          <a:xfrm>
+            <a:off x="1022350" y="2294830"/>
+            <a:ext cx="2223770" cy="256530"/>
+          </a:xfrm>
+          <a:prstGeom prst="rect">
+            <a:avLst/>
+          </a:prstGeom>
+          <a:noFill/>
+          <a:ln/>
+        </p:spPr>
+        <p:txBody>
+          <a:bodyPr wrap="square" lIns="0" tIns="0" rIns="0" bIns="0" rtlCol="0" anchor="t">
+            <a:normAutofit/>
+          </a:bodyPr>
+          <a:lstStyle/>
+          <a:p>
+            <a:pPr algn="l" indent="0" marL="0">
+              <a:lnSpc>
+                <a:spcPts val="1820"/>
+              </a:lnSpc>
+              <a:buNone/>
+            </a:pPr>
+            <a:r>
+              <a:rPr lang="en-US" sz="1300" b="1" dirty="0">
+                <a:solidFill>
+                  <a:srgbClr val="B05A26"/>
+                </a:solidFill>
+                <a:latin typeface="Public Sans" pitchFamily="34" charset="0"/>
+                <a:ea typeface="Public Sans" pitchFamily="34" charset="-122"/>
+                <a:cs typeface="Public Sans" pitchFamily="34" charset="-120"/>
+              </a:rPr>
+              <a:t>Actionable insight</a:t>
+            </a:r>
+            <a:endParaRPr lang="en-US" sz="1300" dirty="0"/>
+          </a:p>
+        </p:txBody>
+      </p:sp>
+      <p:sp>
+        <p:nvSpPr>
+          <p:cNvPr id="9" name="Text 7"/>
+          <p:cNvSpPr/>
+          <p:nvPr/>
+        </p:nvSpPr>
+        <p:spPr>
+          <a:xfrm>
+            <a:off x="3333750" y="2294830"/>
+            <a:ext cx="8070977" cy="256530"/>
+          </a:xfrm>
+          <a:prstGeom prst="rect">
+            <a:avLst/>
+          </a:prstGeom>
+          <a:noFill/>
+          <a:ln/>
+        </p:spPr>
+        <p:txBody>
+          <a:bodyPr wrap="square" lIns="0" tIns="0" rIns="0" bIns="0" rtlCol="0" anchor="t">
+            <a:normAutofit/>
+          </a:bodyPr>
+          <a:lstStyle/>
+          <a:p>
+            <a:pPr algn="l" indent="0" marL="0">
+              <a:lnSpc>
+                <a:spcPts val="1820"/>
+              </a:lnSpc>
+              <a:buNone/>
+            </a:pPr>
+            <a:r>
+              <a:rPr lang="en-US" sz="1300" dirty="0">
+                <a:solidFill>
+                  <a:srgbClr val="46516B"/>
+                </a:solidFill>
+                <a:latin typeface="Public Sans" pitchFamily="34" charset="0"/>
+                <a:ea typeface="Public Sans" pitchFamily="34" charset="-122"/>
+                <a:cs typeface="Public Sans" pitchFamily="34" charset="-120"/>
+              </a:rPr>
+              <a:t>Send ALS to the top-15% risk calls (≈ €585k per 1,000 calls vs. random) · base ALS near North-East hotspots</a:t>
+            </a:r>
+            <a:endParaRPr lang="en-US" sz="1300" dirty="0"/>
+          </a:p>
+        </p:txBody>
+      </p:sp>
+      <p:sp>
+        <p:nvSpPr>
+          <p:cNvPr id="10" name="Shape 8"/>
+          <p:cNvSpPr/>
+          <p:nvPr/>
+        </p:nvSpPr>
+        <p:spPr>
+          <a:xfrm>
+            <a:off x="815975" y="2751386"/>
+            <a:ext cx="10560050" cy="748010"/>
+          </a:xfrm>
+          <a:prstGeom prst="roundRect">
+            <a:avLst>
+              <a:gd name="adj" fmla="val 9763"/>
+            </a:avLst>
+          </a:prstGeom>
+          <a:solidFill>
+            <a:srgbClr val="FDFDFB"/>
+          </a:solidFill>
+          <a:ln w="6350">
+            <a:solidFill>
+              <a:srgbClr val="E2DFD6"/>
+            </a:solidFill>
+            <a:prstDash val="solid"/>
+          </a:ln>
+        </p:spPr>
+        <p:txBody>
+          <a:bodyPr/>
+          <a:p/>
+        </p:txBody>
+      </p:sp>
+      <p:sp>
+        <p:nvSpPr>
+          <p:cNvPr id="11" name="Text 9"/>
+          <p:cNvSpPr/>
+          <p:nvPr/>
+        </p:nvSpPr>
+        <p:spPr>
+          <a:xfrm>
+            <a:off x="1022350" y="2894261"/>
+            <a:ext cx="2223770" cy="487660"/>
+          </a:xfrm>
+          <a:prstGeom prst="rect">
+            <a:avLst/>
+          </a:prstGeom>
+          <a:noFill/>
+          <a:ln/>
+        </p:spPr>
+        <p:txBody>
+          <a:bodyPr wrap="square" lIns="0" tIns="0" rIns="0" bIns="0" rtlCol="0" anchor="t">
+            <a:normAutofit/>
+          </a:bodyPr>
+          <a:lstStyle/>
+          <a:p>
+            <a:pPr algn="l" indent="0" marL="0">
+              <a:lnSpc>
+                <a:spcPts val="1820"/>
+              </a:lnSpc>
+              <a:buNone/>
+            </a:pPr>
+            <a:r>
+              <a:rPr lang="en-US" sz="1300" b="1" dirty="0">
+                <a:solidFill>
+                  <a:srgbClr val="B05A26"/>
+                </a:solidFill>
+                <a:latin typeface="Public Sans" pitchFamily="34" charset="0"/>
+                <a:ea typeface="Public Sans" pitchFamily="34" charset="-122"/>
+                <a:cs typeface="Public Sans" pitchFamily="34" charset="-120"/>
+              </a:rPr>
+              <a:t>Limitations</a:t>
+            </a:r>
+            <a:endParaRPr lang="en-US" sz="1300" dirty="0"/>
+          </a:p>
+        </p:txBody>
+      </p:sp>
+      <p:sp>
+        <p:nvSpPr>
+          <p:cNvPr id="12" name="Text 10"/>
+          <p:cNvSpPr/>
+          <p:nvPr/>
+        </p:nvSpPr>
+        <p:spPr>
+          <a:xfrm>
+            <a:off x="3333750" y="2894261"/>
+            <a:ext cx="8070977" cy="487660"/>
+          </a:xfrm>
+          <a:prstGeom prst="rect">
+            <a:avLst/>
+          </a:prstGeom>
+          <a:noFill/>
+          <a:ln/>
+        </p:spPr>
+        <p:txBody>
+          <a:bodyPr wrap="square" lIns="0" tIns="0" rIns="0" bIns="0" rtlCol="0" anchor="t">
+            <a:normAutofit/>
+          </a:bodyPr>
+          <a:lstStyle/>
+          <a:p>
+            <a:pPr algn="l" indent="0" marL="0">
+              <a:lnSpc>
+                <a:spcPts val="1820"/>
+              </a:lnSpc>
+              <a:buNone/>
+            </a:pPr>
+            <a:r>
+              <a:rPr lang="en-US" sz="1300" dirty="0">
+                <a:solidFill>
+                  <a:srgbClr val="46516B"/>
+                </a:solidFill>
+                <a:latin typeface="Public Sans" pitchFamily="34" charset="0"/>
+                <a:ea typeface="Public Sans" pitchFamily="34" charset="-122"/>
+                <a:cs typeface="Public Sans" pitchFamily="34" charset="-120"/>
+              </a:rPr>
+              <a:t>Reporting change in 2015 (e-DAT) limits older data · GPS only from 2017 and no highway ID, so location is approximate · no traffic, weather or caller information · 150,000-row sample</a:t>
+            </a:r>
+            <a:endParaRPr lang="en-US" sz="1300" dirty="0"/>
+          </a:p>
+        </p:txBody>
+      </p:sp>
+      <p:sp>
+        <p:nvSpPr>
+          <p:cNvPr id="13" name="Shape 11"/>
+          <p:cNvSpPr/>
+          <p:nvPr/>
+        </p:nvSpPr>
+        <p:spPr>
+          <a:xfrm>
+            <a:off x="815975" y="3581946"/>
+            <a:ext cx="10560050" cy="516880"/>
+          </a:xfrm>
+          <a:prstGeom prst="roundRect">
+            <a:avLst>
+              <a:gd name="adj" fmla="val 14128"/>
+            </a:avLst>
+          </a:prstGeom>
+          <a:solidFill>
+            <a:srgbClr val="FDFDFB"/>
+          </a:solidFill>
+          <a:ln w="6350">
+            <a:solidFill>
+              <a:srgbClr val="E2DFD6"/>
+            </a:solidFill>
+            <a:prstDash val="solid"/>
+          </a:ln>
+        </p:spPr>
+        <p:txBody>
+          <a:bodyPr/>
+          <a:p/>
+        </p:txBody>
+      </p:sp>
+      <p:sp>
+        <p:nvSpPr>
+          <p:cNvPr id="14" name="Text 12"/>
+          <p:cNvSpPr/>
+          <p:nvPr/>
+        </p:nvSpPr>
+        <p:spPr>
+          <a:xfrm>
+            <a:off x="1022350" y="3724821"/>
+            <a:ext cx="2223770" cy="256530"/>
+          </a:xfrm>
+          <a:prstGeom prst="rect">
+            <a:avLst/>
+          </a:prstGeom>
+          <a:noFill/>
+          <a:ln/>
+        </p:spPr>
+        <p:txBody>
+          <a:bodyPr wrap="square" lIns="0" tIns="0" rIns="0" bIns="0" rtlCol="0" anchor="t">
+            <a:normAutofit/>
+          </a:bodyPr>
+          <a:lstStyle/>
+          <a:p>
+            <a:pPr algn="l" indent="0" marL="0">
+              <a:lnSpc>
+                <a:spcPts val="1820"/>
+              </a:lnSpc>
+              <a:buNone/>
+            </a:pPr>
+            <a:r>
+              <a:rPr lang="en-US" sz="1300" b="1" dirty="0">
+                <a:solidFill>
+                  <a:srgbClr val="B05A26"/>
+                </a:solidFill>
+                <a:latin typeface="Public Sans" pitchFamily="34" charset="0"/>
+                <a:ea typeface="Public Sans" pitchFamily="34" charset="-122"/>
+                <a:cs typeface="Public Sans" pitchFamily="34" charset="-120"/>
+              </a:rPr>
+              <a:t>Future work</a:t>
+            </a:r>
+            <a:endParaRPr lang="en-US" sz="1300" dirty="0"/>
+          </a:p>
+        </p:txBody>
+      </p:sp>
+      <p:sp>
+        <p:nvSpPr>
+          <p:cNvPr id="15" name="Text 13"/>
+          <p:cNvSpPr/>
+          <p:nvPr/>
+        </p:nvSpPr>
+        <p:spPr>
+          <a:xfrm>
+            <a:off x="3333750" y="3724821"/>
+            <a:ext cx="8070977" cy="256530"/>
+          </a:xfrm>
+          <a:prstGeom prst="rect">
+            <a:avLst/>
+          </a:prstGeom>
+          <a:noFill/>
+          <a:ln/>
+        </p:spPr>
+        <p:txBody>
+          <a:bodyPr wrap="square" lIns="0" tIns="0" rIns="0" bIns="0" rtlCol="0" anchor="t">
+            <a:normAutofit/>
+          </a:bodyPr>
+          <a:lstStyle/>
+          <a:p>
+            <a:pPr algn="l" indent="0" marL="0">
+              <a:lnSpc>
+                <a:spcPts val="1820"/>
+              </a:lnSpc>
+              <a:buNone/>
+            </a:pPr>
+            <a:r>
+              <a:rPr lang="en-US" sz="1300" dirty="0">
+                <a:solidFill>
+                  <a:srgbClr val="46516B"/>
+                </a:solidFill>
+                <a:latin typeface="Public Sans" pitchFamily="34" charset="0"/>
+                <a:ea typeface="Public Sans" pitchFamily="34" charset="-122"/>
+                <a:cs typeface="Public Sans" pitchFamily="34" charset="-120"/>
+              </a:rPr>
+              <a:t>Collect GPS at every call and retrain with location risk (test PR-AUC 0.131 → 0.141) · add weather, traffic &amp; caller details</a:t>
+            </a:r>
+            <a:endParaRPr lang="en-US" sz="1300" dirty="0"/>
+          </a:p>
+        </p:txBody>
+      </p:sp>
+      <p:sp>
+        <p:nvSpPr>
+          <p:cNvPr id="16" name="Text 14"/>
+          <p:cNvSpPr/>
+          <p:nvPr/>
+        </p:nvSpPr>
+        <p:spPr>
+          <a:xfrm>
+            <a:off x="812800" y="6238280"/>
+            <a:ext cx="4057174" cy="238720"/>
+          </a:xfrm>
+          <a:prstGeom prst="rect">
+            <a:avLst/>
+          </a:prstGeom>
+          <a:noFill/>
+          <a:ln/>
+        </p:spPr>
+        <p:txBody>
+          <a:bodyPr wrap="square" lIns="0" tIns="0" rIns="0" bIns="0" rtlCol="0" anchor="t">
+            <a:normAutofit/>
+          </a:bodyPr>
+          <a:lstStyle/>
+          <a:p>
+            <a:pPr algn="l" indent="0" marL="0">
+              <a:lnSpc>
+                <a:spcPts val="1680"/>
+              </a:lnSpc>
+              <a:buNone/>
+            </a:pPr>
+            <a:r>
+              <a:rPr lang="en-US" sz="1200" dirty="0">
+                <a:solidFill>
+                  <a:srgbClr val="8B9099"/>
+                </a:solidFill>
+                <a:latin typeface="Public Sans" pitchFamily="34" charset="0"/>
+                <a:ea typeface="Public Sans" pitchFamily="34" charset="-122"/>
+                <a:cs typeface="Public Sans" pitchFamily="34" charset="-120"/>
+              </a:rPr>
+              <a:t>Road Safety Predictive Analytics — Group 6</a:t>
+            </a:r>
+            <a:endParaRPr lang="en-US" sz="1200" dirty="0"/>
+          </a:p>
+        </p:txBody>
+      </p:sp>
+      <p:sp>
+        <p:nvSpPr>
+          <p:cNvPr id="17" name="Text 15"/>
+          <p:cNvSpPr/>
+          <p:nvPr/>
+        </p:nvSpPr>
+        <p:spPr>
+          <a:xfrm>
+            <a:off x="11218466" y="6238280"/>
+            <a:ext cx="211534" cy="238720"/>
+          </a:xfrm>
+          <a:prstGeom prst="rect">
+            <a:avLst/>
+          </a:prstGeom>
+          <a:noFill/>
+          <a:ln/>
+        </p:spPr>
+        <p:txBody>
+          <a:bodyPr wrap="square" lIns="0" tIns="0" rIns="0" bIns="0" rtlCol="0" anchor="t">
+            <a:normAutofit/>
+          </a:bodyPr>
+          <a:lstStyle/>
+          <a:p>
+            <a:pPr algn="l" indent="0" marL="0">
+              <a:lnSpc>
+                <a:spcPts val="1680"/>
+              </a:lnSpc>
+              <a:buNone/>
+            </a:pPr>
+            <a:r>
+              <a:rPr lang="en-US" sz="1200" dirty="0">
+                <a:solidFill>
+                  <a:srgbClr val="8B9099"/>
+                </a:solidFill>
+                <a:latin typeface="Public Sans" pitchFamily="34" charset="0"/>
+                <a:ea typeface="Public Sans" pitchFamily="34" charset="-122"/>
+                <a:cs typeface="Public Sans" pitchFamily="34" charset="-120"/>
+              </a:rPr>
+              <a:t>26</a:t>
+            </a:r>
+            <a:endParaRPr lang="en-US" sz="1200" dirty="0"/>
+          </a:p>
+        </p:txBody>
+      </p:sp>
+    </p:spTree>
+  </p:cSld>
+  <p:clrMapOvr>
+    <a:masterClrMapping/>
+  </p:clrMapOvr>
+</p:sld>
+</file>
+
+<file path=ppt/slides/slide27.xml><?xml version="1.0" encoding="utf-8"?>
+<p:sld xmlns:a="http://schemas.openxmlformats.org/drawingml/2006/main" xmlns:r="http://schemas.openxmlformats.org/officeDocument/2006/relationships" xmlns:p="http://schemas.openxmlformats.org/presentationml/2006/main">
+  <p:cSld name="Slide 17">
+    <p:bg>
+      <p:bgPr>
+        <a:solidFill>
+          <a:srgbClr val="15213B"/>
+        </a:solidFill>
+      </p:bgPr>
+    </p:bg>
+    <p:spTree>
+      <p:nvGrpSpPr>
+        <p:cNvPr id="1" name=""/>
+        <p:cNvGrpSpPr/>
+        <p:nvPr/>
+      </p:nvGrpSpPr>
+      <p:grpSpPr>
+        <a:xfrm>
+          <a:off x="0" y="0"/>
+          <a:ext cx="0" cy="0"/>
+          <a:chOff x="0" y="0"/>
+          <a:chExt cx="0" cy="0"/>
+        </a:xfrm>
+      </p:grpSpPr>
+      <p:sp>
+        <p:nvSpPr>
+          <p:cNvPr id="2" name="Text 0"/>
+          <p:cNvSpPr/>
+          <p:nvPr/>
+        </p:nvSpPr>
+        <p:spPr>
+          <a:xfrm>
+            <a:off x="812800" y="2673350"/>
+            <a:ext cx="10883392" cy="381000"/>
+          </a:xfrm>
+          <a:prstGeom prst="rect">
+            <a:avLst/>
+          </a:prstGeom>
+          <a:noFill/>
+          <a:ln/>
+        </p:spPr>
+        <p:txBody>
+          <a:bodyPr wrap="square" lIns="0" tIns="0" rIns="0" bIns="0" rtlCol="0" anchor="t">
+            <a:normAutofit/>
+          </a:bodyPr>
+          <a:lstStyle/>
+          <a:p>
+            <a:pPr algn="l" indent="0" marL="0">
+              <a:lnSpc>
+                <a:spcPts val="2800"/>
+              </a:lnSpc>
+              <a:buNone/>
+            </a:pPr>
+            <a:r>
+              <a:rPr lang="en-US" sz="2000" b="1" dirty="0">
+                <a:solidFill>
+                  <a:srgbClr val="C7CCDD"/>
+                </a:solidFill>
+                <a:latin typeface="Public Sans" pitchFamily="34" charset="0"/>
+                <a:ea typeface="Public Sans" pitchFamily="34" charset="-122"/>
+                <a:cs typeface="Public Sans" pitchFamily="34" charset="-120"/>
+              </a:rPr>
+              <a:t>06</a:t>
+            </a:r>
+            <a:endParaRPr lang="en-US" sz="2000" dirty="0"/>
+          </a:p>
+        </p:txBody>
+      </p:sp>
+      <p:sp>
+        <p:nvSpPr>
+          <p:cNvPr id="3" name="Text 1"/>
+          <p:cNvSpPr/>
+          <p:nvPr>
+            <p:ph type="title"/>
+          </p:nvPr>
+        </p:nvSpPr>
+        <p:spPr>
+          <a:xfrm>
+            <a:off x="812800" y="3181350"/>
+            <a:ext cx="10883392" cy="609600"/>
+          </a:xfrm>
+          <a:prstGeom prst="rect">
+            <a:avLst/>
+          </a:prstGeom>
+          <a:noFill/>
+          <a:ln/>
+        </p:spPr>
+        <p:txBody>
+          <a:bodyPr wrap="square" lIns="0" tIns="0" rIns="0" bIns="0" rtlCol="0" anchor="t">
+            <a:normAutofit/>
+          </a:bodyPr>
+          <a:lstStyle/>
+          <a:p>
+            <a:pPr algn="l" indent="0" marL="0">
+              <a:lnSpc>
+                <a:spcPts val="4600"/>
+              </a:lnSpc>
+              <a:buNone/>
+            </a:pPr>
+            <a:r>
+              <a:rPr lang="en-US" sz="4000" b="1" i="0" dirty="0">
+                <a:solidFill>
+                  <a:srgbClr val="F4F1E8"/>
+                </a:solidFill>
+                <a:latin typeface="Libre Baskerville" pitchFamily="18" charset="0"/>
+                <a:ea typeface="Libre Baskerville" pitchFamily="18" charset="-122"/>
+                <a:cs typeface="Libre Baskerville" pitchFamily="18" charset="-120"/>
+              </a:rPr>
+              <a:t>Annexes</a:t>
+            </a:r>
+            <a:endParaRPr lang="en-US" sz="4000" dirty="0"/>
+          </a:p>
+        </p:txBody>
+      </p:sp>
+      <p:sp>
+        <p:nvSpPr>
+          <p:cNvPr id="4" name="Text 2"/>
+          <p:cNvSpPr/>
+          <p:nvPr/>
+        </p:nvSpPr>
+        <p:spPr>
+          <a:xfrm>
+            <a:off x="812800" y="3917950"/>
+            <a:ext cx="8502650" cy="292100"/>
+          </a:xfrm>
+          <a:prstGeom prst="rect">
+            <a:avLst/>
+          </a:prstGeom>
+          <a:noFill/>
+          <a:ln/>
+        </p:spPr>
+        <p:txBody>
+          <a:bodyPr wrap="square" lIns="0" tIns="0" rIns="0" bIns="0" rtlCol="0" anchor="t">
+            <a:normAutofit/>
+          </a:bodyPr>
+          <a:lstStyle/>
+          <a:p>
+            <a:pPr algn="l" indent="0" marL="0">
+              <a:lnSpc>
+                <a:spcPts val="2100"/>
+              </a:lnSpc>
+              <a:buNone/>
+            </a:pPr>
+            <a:r>
+              <a:rPr lang="en-US" sz="1500" dirty="0">
+                <a:solidFill>
+                  <a:srgbClr val="C7CCDD"/>
+                </a:solidFill>
+                <a:latin typeface="Public Sans" pitchFamily="34" charset="0"/>
+                <a:ea typeface="Public Sans" pitchFamily="34" charset="-122"/>
+                <a:cs typeface="Public Sans" pitchFamily="34" charset="-120"/>
+              </a:rPr>
+              <a:t>Details for questions, not presented in the 10 minutes.</a:t>
+            </a:r>
+            <a:endParaRPr lang="en-US" sz="1500" dirty="0"/>
+          </a:p>
+        </p:txBody>
+      </p:sp>
+    </p:spTree>
+  </p:cSld>
+  <p:clrMapOvr>
+    <a:masterClrMapping/>
+  </p:clrMapOvr>
+</p:sld>
+</file>
+
+<file path=ppt/slides/slide28.xml><?xml version="1.0" encoding="utf-8"?>
 <p:sld xmlns:a="http://schemas.openxmlformats.org/drawingml/2006/main" xmlns:r="http://schemas.openxmlformats.org/officeDocument/2006/relationships" xmlns:p="http://schemas.openxmlformats.org/presentationml/2006/main">
   <p:cSld name="Slide 19">
     <p:bg>
@@ -19962,7 +21059,7 @@
 </p:sld>
 </file>
 
-<file path=ppt/slides/slide27.xml><?xml version="1.0" encoding="utf-8"?>
+<file path=ppt/slides/slide29.xml><?xml version="1.0" encoding="utf-8"?>
 <p:sld xmlns:a="http://schemas.openxmlformats.org/drawingml/2006/main" xmlns:r="http://schemas.openxmlformats.org/officeDocument/2006/relationships" xmlns:p="http://schemas.openxmlformats.org/presentationml/2006/main">
   <p:cSld name="Slide 20">
     <p:bg>
@@ -20808,500 +21905,6 @@
 </p:sld>
 </file>
 
-<file path=ppt/slides/slide28.xml><?xml version="1.0" encoding="utf-8"?>
-<p:sld xmlns:a="http://schemas.openxmlformats.org/drawingml/2006/main" xmlns:r="http://schemas.openxmlformats.org/officeDocument/2006/relationships" xmlns:p="http://schemas.openxmlformats.org/presentationml/2006/main">
-  <p:cSld name="Slide 21">
-    <p:bg>
-      <p:bgPr>
-        <a:solidFill>
-          <a:srgbClr val="15213B"/>
-        </a:solidFill>
-      </p:bgPr>
-    </p:bg>
-    <p:spTree>
-      <p:nvGrpSpPr>
-        <p:cNvPr id="1" name=""/>
-        <p:cNvGrpSpPr/>
-        <p:nvPr/>
-      </p:nvGrpSpPr>
-      <p:grpSpPr>
-        <a:xfrm>
-          <a:off x="0" y="0"/>
-          <a:ext cx="0" cy="0"/>
-          <a:chOff x="0" y="0"/>
-          <a:chExt cx="0" cy="0"/>
-        </a:xfrm>
-      </p:grpSpPr>
-      <p:sp>
-        <p:nvSpPr>
-          <p:cNvPr id="2" name="Text 0"/>
-          <p:cNvSpPr/>
-          <p:nvPr>
-            <p:ph type="title"/>
-          </p:nvPr>
-        </p:nvSpPr>
-        <p:spPr>
-          <a:xfrm>
-            <a:off x="3915494" y="2644180"/>
-            <a:ext cx="4360962" cy="723900"/>
-          </a:xfrm>
-          <a:prstGeom prst="rect">
-            <a:avLst/>
-          </a:prstGeom>
-          <a:noFill/>
-          <a:ln/>
-        </p:spPr>
-        <p:txBody>
-          <a:bodyPr wrap="square" lIns="0" tIns="0" rIns="0" bIns="0" rtlCol="0" anchor="t">
-            <a:normAutofit/>
-          </a:bodyPr>
-          <a:lstStyle/>
-          <a:p>
-            <a:pPr algn="ctr" indent="0" marL="0">
-              <a:lnSpc>
-                <a:spcPts val="5500"/>
-              </a:lnSpc>
-              <a:buNone/>
-            </a:pPr>
-            <a:r>
-              <a:rPr lang="en-US" sz="5000" b="1" i="0" dirty="0">
-                <a:solidFill>
-                  <a:srgbClr val="F4F1E8"/>
-                </a:solidFill>
-                <a:latin typeface="Libre Baskerville" pitchFamily="18" charset="0"/>
-                <a:ea typeface="Libre Baskerville" pitchFamily="18" charset="-122"/>
-                <a:cs typeface="Libre Baskerville" pitchFamily="18" charset="-120"/>
-              </a:rPr>
-              <a:t>Thank you</a:t>
-            </a:r>
-            <a:endParaRPr lang="en-US" sz="5000" dirty="0"/>
-          </a:p>
-        </p:txBody>
-      </p:sp>
-      <p:sp>
-        <p:nvSpPr>
-          <p:cNvPr id="3" name="Text 1"/>
-          <p:cNvSpPr/>
-          <p:nvPr/>
-        </p:nvSpPr>
-        <p:spPr>
-          <a:xfrm>
-            <a:off x="4707081" y="3520480"/>
-            <a:ext cx="2777788" cy="327620"/>
-          </a:xfrm>
-          <a:prstGeom prst="rect">
-            <a:avLst/>
-          </a:prstGeom>
-          <a:noFill/>
-          <a:ln/>
-        </p:spPr>
-        <p:txBody>
-          <a:bodyPr wrap="square" lIns="0" tIns="0" rIns="0" bIns="0" rtlCol="0" anchor="t">
-            <a:normAutofit/>
-          </a:bodyPr>
-          <a:lstStyle/>
-          <a:p>
-            <a:pPr algn="ctr" indent="0" marL="0">
-              <a:lnSpc>
-                <a:spcPts val="2380"/>
-              </a:lnSpc>
-              <a:buNone/>
-            </a:pPr>
-            <a:r>
-              <a:rPr lang="en-US" sz="1700" dirty="0">
-                <a:solidFill>
-                  <a:srgbClr val="C7CCDD"/>
-                </a:solidFill>
-                <a:latin typeface="Public Sans" pitchFamily="34" charset="0"/>
-                <a:ea typeface="Public Sans" pitchFamily="34" charset="-122"/>
-                <a:cs typeface="Public Sans" pitchFamily="34" charset="-120"/>
-              </a:rPr>
-              <a:t>Questions &amp; discussion</a:t>
-            </a:r>
-            <a:endParaRPr lang="en-US" sz="1700" dirty="0"/>
-          </a:p>
-        </p:txBody>
-      </p:sp>
-      <p:sp>
-        <p:nvSpPr>
-          <p:cNvPr id="4" name="Text 2"/>
-          <p:cNvSpPr/>
-          <p:nvPr/>
-        </p:nvSpPr>
-        <p:spPr>
-          <a:xfrm>
-            <a:off x="1527048" y="4000500"/>
-            <a:ext cx="9144000" cy="238720"/>
-          </a:xfrm>
-          <a:prstGeom prst="rect">
-            <a:avLst/>
-          </a:prstGeom>
-          <a:noFill/>
-          <a:ln/>
-        </p:spPr>
-        <p:txBody>
-          <a:bodyPr wrap="square" lIns="0" tIns="0" rIns="0" bIns="0" rtlCol="0" anchor="t">
-            <a:normAutofit/>
-          </a:bodyPr>
-          <a:lstStyle/>
-          <a:p>
-            <a:pPr algn="ctr" indent="0" marL="0">
-              <a:lnSpc>
-                <a:spcPts val="1680"/>
-              </a:lnSpc>
-              <a:buNone/>
-            </a:pPr>
-            <a:r>
-              <a:rPr lang="en-US" sz="1200" dirty="0">
-                <a:solidFill>
-                  <a:srgbClr val="8B93AC"/>
-                </a:solidFill>
-                <a:latin typeface="Public Sans" pitchFamily="34" charset="0"/>
-                <a:ea typeface="Public Sans" pitchFamily="34" charset="-122"/>
-                <a:cs typeface="Public Sans" pitchFamily="34" charset="-120"/>
-              </a:rPr>
-              <a:t>Group 6 · Joao · Olena · Samuel · Nuno · Pedro · Predictive Analytics &amp; Forecasting · EMBAAI</a:t>
-            </a:r>
-            <a:endParaRPr lang="en-US" sz="1200" dirty="0"/>
-          </a:p>
-        </p:txBody>
-      </p:sp>
-    </p:spTree>
-  </p:cSld>
-  <p:clrMapOvr>
-    <a:masterClrMapping/>
-  </p:clrMapOvr>
-</p:sld>
-</file>
-
-<file path=ppt/slides/slide29.xml><?xml version="1.0" encoding="utf-8"?>
-<p:sld xmlns:a="http://schemas.openxmlformats.org/drawingml/2006/main" xmlns:p="http://schemas.openxmlformats.org/presentationml/2006/main" xmlns:r="http://schemas.openxmlformats.org/officeDocument/2006/relationships">
-  <p:cSld>
-    <p:spTree>
-      <p:nvGrpSpPr>
-        <p:cNvPr id="1" name=""/>
-        <p:cNvGrpSpPr/>
-        <p:nvPr/>
-      </p:nvGrpSpPr>
-      <p:grpSpPr/>
-      <p:sp>
-        <p:nvSpPr>
-          <p:cNvPr id="2" name="Text 0"/>
-          <p:cNvSpPr/>
-          <p:nvPr/>
-        </p:nvSpPr>
-        <p:spPr>
-          <a:xfrm>
-            <a:off x="812800" y="812800"/>
-            <a:ext cx="10883392" cy="238720"/>
-          </a:xfrm>
-          <a:prstGeom prst="rect">
-            <a:avLst/>
-          </a:prstGeom>
-          <a:noFill/>
-          <a:ln/>
-        </p:spPr>
-        <p:txBody>
-          <a:bodyPr wrap="square" lIns="0" tIns="0" rIns="0" bIns="0" rtlCol="0" anchor="t">
-            <a:normAutofit/>
-          </a:bodyPr>
-          <a:lstStyle/>
-          <a:p>
-            <a:pPr algn="l" indent="0" marL="0">
-              <a:lnSpc>
-                <a:spcPts val="1680"/>
-              </a:lnSpc>
-              <a:buNone/>
-            </a:pPr>
-            <a:r>
-              <a:rPr lang="en-US" sz="1200" b="1" spc="150" kern="0" dirty="0">
-                <a:solidFill>
-                  <a:srgbClr val="15213B"/>
-                </a:solidFill>
-                <a:latin typeface="Public Sans" pitchFamily="34" charset="0"/>
-                <a:ea typeface="Public Sans" pitchFamily="34" charset="-122"/>
-                <a:cs typeface="Public Sans" pitchFamily="34" charset="-120"/>
-              </a:rPr>
-              <a:t>04 · ORIGINALITY</a:t>
-            </a:r>
-            <a:endParaRPr lang="en-US" sz="1200" dirty="0"/>
-          </a:p>
-        </p:txBody>
-      </p:sp>
-      <p:sp>
-        <p:nvSpPr>
-          <p:cNvPr id="3" name="Text 1"/>
-          <p:cNvSpPr/>
-          <p:nvPr>
-            <p:ph type="title"/>
-          </p:nvPr>
-        </p:nvSpPr>
-        <p:spPr>
-          <a:xfrm>
-            <a:off x="812800" y="1026120"/>
-            <a:ext cx="10883392" cy="463550"/>
-          </a:xfrm>
-          <a:prstGeom prst="rect">
-            <a:avLst/>
-          </a:prstGeom>
-          <a:noFill/>
-          <a:ln/>
-        </p:spPr>
-        <p:txBody>
-          <a:bodyPr wrap="square" lIns="0" tIns="0" rIns="0" bIns="0" rtlCol="0" anchor="t">
-            <a:normAutofit/>
-          </a:bodyPr>
-          <a:lstStyle/>
-          <a:p>
-            <a:pPr algn="l" indent="0" marL="0">
-              <a:lnSpc>
-                <a:spcPts val="3450"/>
-              </a:lnSpc>
-              <a:buNone/>
-            </a:pPr>
-            <a:r>
-              <a:rPr lang="en-US" sz="3000" b="1" i="0" dirty="0">
-                <a:solidFill>
-                  <a:srgbClr val="15213B"/>
-                </a:solidFill>
-                <a:latin typeface="Libre Baskerville" pitchFamily="18" charset="0"/>
-                <a:ea typeface="Libre Baskerville" pitchFamily="18" charset="-122"/>
-                <a:cs typeface="Libre Baskerville" pitchFamily="18" charset="-120"/>
-              </a:rPr>
-              <a:t>What is the model worth? Cost-benefit of ALS capacity</a:t>
-            </a:r>
-            <a:endParaRPr lang="en-US" sz="3000" dirty="0"/>
-          </a:p>
-        </p:txBody>
-      </p:sp>
-      <p:sp>
-        <p:nvSpPr>
-          <p:cNvPr id="4" name="Text 2"/>
-          <p:cNvSpPr/>
-          <p:nvPr/>
-        </p:nvSpPr>
-        <p:spPr>
-          <a:xfrm>
-            <a:off x="6400000" y="1642070"/>
-            <a:ext cx="5288572" cy="4300000"/>
-          </a:xfrm>
-          <a:prstGeom prst="rect">
-            <a:avLst/>
-          </a:prstGeom>
-          <a:noFill/>
-          <a:ln/>
-        </p:spPr>
-        <p:txBody>
-          <a:bodyPr wrap="square" lIns="0" tIns="0" rIns="0" bIns="0" rtlCol="0" anchor="t">
-            <a:normAutofit/>
-          </a:bodyPr>
-          <a:lstStyle/>
-          <a:p>
-            <a:pPr algn="l" marL="155956" indent="-155956">
-              <a:lnSpc>
-                <a:spcPts val="1950"/>
-              </a:lnSpc>
-              <a:buSzPct val="100000"/>
-              <a:buChar char="•"/>
-            </a:pPr>
-            <a:r>
-              <a:rPr lang="en-US" sz="1300" dirty="0">
-                <a:solidFill>
-                  <a:srgbClr val="46516B"/>
-                </a:solidFill>
-                <a:latin typeface="Public Sans" pitchFamily="34" charset="0"/>
-                <a:ea typeface="Public Sans" pitchFamily="34" charset="-122"/>
-                <a:cs typeface="Public Sans" pitchFamily="34" charset="-120"/>
-              </a:rPr>
-              <a:t>At 15% capacity, an ALS unit sent by the model reaches a fatal crash 14.9% of the time — vs. 7.1% when sent at random.</a:t>
-            </a:r>
-            <a:endParaRPr lang="en-US" sz="1300" dirty="0"/>
-          </a:p>
-          <a:p>
-            <a:pPr algn="l" marL="155956" indent="-155956">
-              <a:lnSpc>
-                <a:spcPts val="1950"/>
-              </a:lnSpc>
-              <a:buSzPct val="100000"/>
-              <a:buChar char="•"/>
-            </a:pPr>
-            <a:r>
-              <a:rPr lang="en-US" sz="1300" dirty="0">
-                <a:solidFill>
-                  <a:srgbClr val="46516B"/>
-                </a:solidFill>
-                <a:latin typeface="Public Sans" pitchFamily="34" charset="0"/>
-                <a:ea typeface="Public Sans" pitchFamily="34" charset="-122"/>
-                <a:cs typeface="Public Sans" pitchFamily="34" charset="-120"/>
-              </a:rPr>
-              <a:t>≈ €585k of value added per 1,000 calls vs. random dispatch (€2,500 per ALS, €50,000 per fatal crash reached).</a:t>
-            </a:r>
-            <a:endParaRPr lang="en-US" sz="1300" dirty="0"/>
-          </a:p>
-          <a:p>
-            <a:pPr algn="l" marL="155956" indent="-155956">
-              <a:lnSpc>
-                <a:spcPts val="1950"/>
-              </a:lnSpc>
-              <a:buSzPct val="100000"/>
-              <a:buChar char="•"/>
-            </a:pPr>
-            <a:r>
-              <a:rPr lang="en-US" sz="1300" dirty="0">
-                <a:solidFill>
-                  <a:srgbClr val="46516B"/>
-                </a:solidFill>
-                <a:latin typeface="Public Sans" pitchFamily="34" charset="0"/>
-                <a:ea typeface="Public Sans" pitchFamily="34" charset="-122"/>
-                <a:cs typeface="Public Sans" pitchFamily="34" charset="-120"/>
-              </a:rPr>
-              <a:t>Robust to the €50k assumption: dispatch pays off once reaching a fatal crash is worth &gt; €16.8k with the model, vs. &gt; €35.2k at random.</a:t>
-            </a:r>
-            <a:endParaRPr lang="en-US" sz="1300" dirty="0"/>
-          </a:p>
-          <a:p>
-            <a:pPr algn="l" marL="155956" indent="-155956">
-              <a:lnSpc>
-                <a:spcPts val="1950"/>
-              </a:lnSpc>
-              <a:buSzPct val="100000"/>
-              <a:buChar char="•"/>
-            </a:pPr>
-            <a:r>
-              <a:rPr lang="en-US" sz="1300" dirty="0">
-                <a:solidFill>
-                  <a:srgbClr val="46516B"/>
-                </a:solidFill>
-                <a:latin typeface="Public Sans" pitchFamily="34" charset="0"/>
-                <a:ea typeface="Public Sans" pitchFamily="34" charset="-122"/>
-                <a:cs typeface="Public Sans" pitchFamily="34" charset="-120"/>
-              </a:rPr>
-              <a:t>Net benefit peaks at ~64% capacity: ALS is undersized, with diminishing returns — the first 15% is worth €743k per 1,000 calls, the next 10% only €278k more.</a:t>
-            </a:r>
-            <a:endParaRPr lang="en-US" sz="1300" dirty="0"/>
-          </a:p>
-        </p:txBody>
-      </p:sp>
-      <p:sp>
-        <p:nvSpPr>
-          <p:cNvPr id="5" name="Text 3"/>
-          <p:cNvSpPr/>
-          <p:nvPr/>
-        </p:nvSpPr>
-        <p:spPr>
-          <a:xfrm>
-            <a:off x="812800" y="6238280"/>
-            <a:ext cx="4057174" cy="238720"/>
-          </a:xfrm>
-          <a:prstGeom prst="rect">
-            <a:avLst/>
-          </a:prstGeom>
-          <a:noFill/>
-          <a:ln/>
-        </p:spPr>
-        <p:txBody>
-          <a:bodyPr wrap="square" lIns="0" tIns="0" rIns="0" bIns="0" rtlCol="0" anchor="t">
-            <a:normAutofit/>
-          </a:bodyPr>
-          <a:lstStyle/>
-          <a:p>
-            <a:pPr algn="l" indent="0" marL="0">
-              <a:lnSpc>
-                <a:spcPts val="1680"/>
-              </a:lnSpc>
-              <a:buNone/>
-            </a:pPr>
-            <a:r>
-              <a:rPr lang="en-US" sz="1200" dirty="0">
-                <a:solidFill>
-                  <a:srgbClr val="8B9099"/>
-                </a:solidFill>
-                <a:latin typeface="Public Sans" pitchFamily="34" charset="0"/>
-                <a:ea typeface="Public Sans" pitchFamily="34" charset="-122"/>
-                <a:cs typeface="Public Sans" pitchFamily="34" charset="-120"/>
-              </a:rPr>
-              <a:t>Road Safety Predictive Analytics — Group 6</a:t>
-            </a:r>
-            <a:endParaRPr lang="en-US" sz="1200" dirty="0"/>
-          </a:p>
-        </p:txBody>
-      </p:sp>
-      <p:sp>
-        <p:nvSpPr>
-          <p:cNvPr id="6" name="Text 4"/>
-          <p:cNvSpPr/>
-          <p:nvPr/>
-        </p:nvSpPr>
-        <p:spPr>
-          <a:xfrm>
-            <a:off x="11221145" y="6238280"/>
-            <a:ext cx="208855" cy="238720"/>
-          </a:xfrm>
-          <a:prstGeom prst="rect">
-            <a:avLst/>
-          </a:prstGeom>
-          <a:noFill/>
-          <a:ln/>
-        </p:spPr>
-        <p:txBody>
-          <a:bodyPr wrap="square" lIns="0" tIns="0" rIns="0" bIns="0" rtlCol="0" anchor="t">
-            <a:normAutofit/>
-          </a:bodyPr>
-          <a:lstStyle/>
-          <a:p>
-            <a:pPr algn="l" indent="0" marL="0">
-              <a:lnSpc>
-                <a:spcPts val="1680"/>
-              </a:lnSpc>
-              <a:buNone/>
-            </a:pPr>
-            <a:r>
-              <a:rPr lang="en-US" sz="1200" dirty="0">
-                <a:solidFill>
-                  <a:srgbClr val="8B9099"/>
-                </a:solidFill>
-                <a:latin typeface="Public Sans" pitchFamily="34" charset="0"/>
-                <a:ea typeface="Public Sans" pitchFamily="34" charset="-122"/>
-                <a:cs typeface="Public Sans" pitchFamily="34" charset="-120"/>
-              </a:rPr>
-              <a:t>23</a:t>
-            </a:r>
-            <a:endParaRPr lang="en-US" sz="1200" dirty="0"/>
-          </a:p>
-        </p:txBody>
-      </p:sp>
-      <p:pic>
-        <p:nvPicPr>
-          <p:cNvPr id="7" name="Picture 6" descr="task3_value_vs_capacity.png"/>
-          <p:cNvPicPr>
-            <a:picLocks noChangeAspect="1"/>
-          </p:cNvPicPr>
-          <p:nvPr/>
-        </p:nvPicPr>
-        <p:blipFill>
-          <a:blip r:embed="rId2"/>
-          <a:stretch>
-            <a:fillRect/>
-          </a:stretch>
-        </p:blipFill>
-        <p:spPr>
-          <a:xfrm>
-            <a:off x="812800" y="1642070"/>
-            <a:ext cx="5400000" cy="3349367"/>
-          </a:xfrm>
-          <a:prstGeom prst="rect">
-            <a:avLst/>
-          </a:prstGeom>
-        </p:spPr>
-      </p:pic>
-    </p:spTree>
-  </p:cSld>
-  <p:clrMapOvr>
-    <a:masterClrMapping/>
-  </p:clrMapOvr>
-</p:sld>
-</file>
-
 <file path=ppt/slides/slide3.xml><?xml version="1.0" encoding="utf-8"?>
 <p:sld xmlns:a="http://schemas.openxmlformats.org/drawingml/2006/main" xmlns:r="http://schemas.openxmlformats.org/officeDocument/2006/relationships" xmlns:p="http://schemas.openxmlformats.org/presentationml/2006/main">
   <p:cSld name="Slide 3">
@@ -21838,25 +22441,41 @@
 </file>
 
 <file path=ppt/slides/slide30.xml><?xml version="1.0" encoding="utf-8"?>
-<p:sld xmlns:a="http://schemas.openxmlformats.org/drawingml/2006/main" xmlns:p="http://schemas.openxmlformats.org/presentationml/2006/main" xmlns:r="http://schemas.openxmlformats.org/officeDocument/2006/relationships">
-  <p:cSld>
+<p:sld xmlns:a="http://schemas.openxmlformats.org/drawingml/2006/main" xmlns:r="http://schemas.openxmlformats.org/officeDocument/2006/relationships" xmlns:p="http://schemas.openxmlformats.org/presentationml/2006/main">
+  <p:cSld name="Slide 21">
+    <p:bg>
+      <p:bgPr>
+        <a:solidFill>
+          <a:srgbClr val="15213B"/>
+        </a:solidFill>
+      </p:bgPr>
+    </p:bg>
     <p:spTree>
       <p:nvGrpSpPr>
         <p:cNvPr id="1" name=""/>
         <p:cNvGrpSpPr/>
         <p:nvPr/>
       </p:nvGrpSpPr>
-      <p:grpSpPr/>
+      <p:grpSpPr>
+        <a:xfrm>
+          <a:off x="0" y="0"/>
+          <a:ext cx="0" cy="0"/>
+          <a:chOff x="0" y="0"/>
+          <a:chExt cx="0" cy="0"/>
+        </a:xfrm>
+      </p:grpSpPr>
       <p:sp>
         <p:nvSpPr>
           <p:cNvPr id="2" name="Text 0"/>
           <p:cNvSpPr/>
-          <p:nvPr/>
+          <p:nvPr>
+            <p:ph type="title"/>
+          </p:nvPr>
         </p:nvSpPr>
         <p:spPr>
           <a:xfrm>
-            <a:off x="812800" y="812800"/>
-            <a:ext cx="10883392" cy="238720"/>
+            <a:off x="3915494" y="2644180"/>
+            <a:ext cx="4360962" cy="723900"/>
           </a:xfrm>
           <a:prstGeom prst="rect">
             <a:avLst/>
@@ -21870,24 +22489,24 @@
           </a:bodyPr>
           <a:lstStyle/>
           <a:p>
-            <a:pPr algn="l" indent="0" marL="0">
+            <a:pPr algn="ctr" indent="0" marL="0">
               <a:lnSpc>
-                <a:spcPts val="1680"/>
+                <a:spcPts val="5500"/>
               </a:lnSpc>
               <a:buNone/>
             </a:pPr>
             <a:r>
-              <a:rPr lang="en-US" sz="1200" b="1" spc="150" kern="0" dirty="0">
+              <a:rPr lang="en-US" sz="5000" b="1" i="0" dirty="0">
                 <a:solidFill>
-                  <a:srgbClr val="15213B"/>
+                  <a:srgbClr val="F4F1E8"/>
                 </a:solidFill>
-                <a:latin typeface="Public Sans" pitchFamily="34" charset="0"/>
-                <a:ea typeface="Public Sans" pitchFamily="34" charset="-122"/>
-                <a:cs typeface="Public Sans" pitchFamily="34" charset="-120"/>
+                <a:latin typeface="Libre Baskerville" pitchFamily="18" charset="0"/>
+                <a:ea typeface="Libre Baskerville" pitchFamily="18" charset="-122"/>
+                <a:cs typeface="Libre Baskerville" pitchFamily="18" charset="-120"/>
               </a:rPr>
-              <a:t>04 · ORIGINALITY</a:t>
-            </a:r>
-            <a:endParaRPr lang="en-US" sz="1200" dirty="0"/>
+              <a:t>Thank you</a:t>
+            </a:r>
+            <a:endParaRPr lang="en-US" sz="5000" dirty="0"/>
           </a:p>
         </p:txBody>
       </p:sp>
@@ -21895,14 +22514,12 @@
         <p:nvSpPr>
           <p:cNvPr id="3" name="Text 1"/>
           <p:cNvSpPr/>
-          <p:nvPr>
-            <p:ph type="title"/>
-          </p:nvPr>
+          <p:nvPr/>
         </p:nvSpPr>
         <p:spPr>
           <a:xfrm>
-            <a:off x="812800" y="1026120"/>
-            <a:ext cx="10883392" cy="463550"/>
+            <a:off x="4707081" y="3520480"/>
+            <a:ext cx="2777788" cy="327620"/>
           </a:xfrm>
           <a:prstGeom prst="rect">
             <a:avLst/>
@@ -21916,24 +22533,24 @@
           </a:bodyPr>
           <a:lstStyle/>
           <a:p>
-            <a:pPr algn="l" indent="0" marL="0">
+            <a:pPr algn="ctr" indent="0" marL="0">
               <a:lnSpc>
-                <a:spcPts val="3450"/>
+                <a:spcPts val="2380"/>
               </a:lnSpc>
               <a:buNone/>
             </a:pPr>
             <a:r>
-              <a:rPr lang="en-US" sz="3000" b="1" i="0" dirty="0">
+              <a:rPr lang="en-US" sz="1700" dirty="0">
                 <a:solidFill>
-                  <a:srgbClr val="15213B"/>
+                  <a:srgbClr val="C7CCDD"/>
                 </a:solidFill>
-                <a:latin typeface="Libre Baskerville" pitchFamily="18" charset="0"/>
-                <a:ea typeface="Libre Baskerville" pitchFamily="18" charset="-122"/>
-                <a:cs typeface="Libre Baskerville" pitchFamily="18" charset="-120"/>
+                <a:latin typeface="Public Sans" pitchFamily="34" charset="0"/>
+                <a:ea typeface="Public Sans" pitchFamily="34" charset="-122"/>
+                <a:cs typeface="Public Sans" pitchFamily="34" charset="-120"/>
               </a:rPr>
-              <a:t>Fatal hotspots persist — and GPS is the missing signal</a:t>
-            </a:r>
-            <a:endParaRPr lang="en-US" sz="3000" dirty="0"/>
+              <a:t>Questions &amp; discussion</a:t>
+            </a:r>
+            <a:endParaRPr lang="en-US" sz="1700" dirty="0"/>
           </a:p>
         </p:txBody>
       </p:sp>
@@ -21945,8 +22562,8 @@
         </p:nvSpPr>
         <p:spPr>
           <a:xfrm>
-            <a:off x="6400000" y="1642070"/>
-            <a:ext cx="5288572" cy="4300000"/>
+            <a:off x="1527048" y="4000500"/>
+            <a:ext cx="9144000" cy="238720"/>
           </a:xfrm>
           <a:prstGeom prst="rect">
             <a:avLst/>
@@ -21960,224 +22577,27 @@
           </a:bodyPr>
           <a:lstStyle/>
           <a:p>
-            <a:pPr algn="l" marL="155956" indent="-155956">
+            <a:pPr algn="ctr" indent="0" marL="0">
               <a:lnSpc>
-                <a:spcPts val="1950"/>
+                <a:spcPts val="1680"/>
               </a:lnSpc>
-              <a:buSzPct val="100000"/>
-              <a:buChar char="•"/>
+              <a:buNone/>
             </a:pPr>
             <a:r>
-              <a:rPr lang="en-US" sz="1300" dirty="0">
+              <a:rPr lang="en-US" sz="1200" dirty="0">
                 <a:solidFill>
-                  <a:srgbClr val="46516B"/>
+                  <a:srgbClr val="8B93AC"/>
                 </a:solidFill>
                 <a:latin typeface="Public Sans" pitchFamily="34" charset="0"/>
                 <a:ea typeface="Public Sans" pitchFamily="34" charset="-122"/>
                 <a:cs typeface="Public Sans" pitchFamily="34" charset="-120"/>
               </a:rPr>
-              <a:t>1° grid (≈ 110 km) on the GPS years 2017–2023; hotspots = riskiest cells holding 15% of crashes (109 cells).</a:t>
-            </a:r>
-            <a:endParaRPr lang="en-US" sz="1300" dirty="0"/>
-          </a:p>
-          <a:p>
-            <a:pPr algn="l" marL="155956" indent="-155956">
-              <a:lnSpc>
-                <a:spcPts val="1950"/>
-              </a:lnSpc>
-              <a:buSzPct val="100000"/>
-              <a:buChar char="•"/>
-            </a:pPr>
-            <a:r>
-              <a:rPr lang="en-US" sz="1300" dirty="0">
-                <a:solidFill>
-                  <a:srgbClr val="46516B"/>
-                </a:solidFill>
-                <a:latin typeface="Public Sans" pitchFamily="34" charset="0"/>
-                <a:ea typeface="Public Sans" pitchFamily="34" charset="-122"/>
-                <a:cs typeface="Public Sans" pitchFamily="34" charset="-120"/>
-              </a:rPr>
-              <a:t>Checked on 2024–25, never seen: 14% of crashes but 25.5% of deaths; fatal rate 12.6% vs. 6.2% elsewhere.</a:t>
-            </a:r>
-            <a:endParaRPr lang="en-US" sz="1300" dirty="0"/>
-          </a:p>
-          <a:p>
-            <a:pPr algn="l" marL="155956" indent="-155956">
-              <a:lnSpc>
-                <a:spcPts val="1950"/>
-              </a:lnSpc>
-              <a:buSzPct val="100000"/>
-              <a:buChar char="•"/>
-            </a:pPr>
-            <a:r>
-              <a:rPr lang="en-US" sz="1300" dirty="0">
-                <a:solidFill>
-                  <a:srgbClr val="46516B"/>
-                </a:solidFill>
-                <a:latin typeface="Public Sans" pitchFamily="34" charset="0"/>
-                <a:ea typeface="Public Sans" pitchFamily="34" charset="-122"/>
-                <a:cs typeface="Public Sans" pitchFamily="34" charset="-120"/>
-              </a:rPr>
-              <a:t>Highest risk in the North-East (Pernambuco, Bahia): candidate ALS / helicopter bases and inspections.</a:t>
-            </a:r>
-            <a:endParaRPr lang="en-US" sz="1300" dirty="0"/>
-          </a:p>
-          <a:p>
-            <a:pPr algn="l" marL="155956" indent="-155956">
-              <a:lnSpc>
-                <a:spcPts val="1950"/>
-              </a:lnSpc>
-              <a:buSzPct val="100000"/>
-              <a:buChar char="•"/>
-            </a:pPr>
-            <a:r>
-              <a:rPr lang="en-US" sz="1300" dirty="0">
-                <a:solidFill>
-                  <a:srgbClr val="46516B"/>
-                </a:solidFill>
-                <a:latin typeface="Public Sans" pitchFamily="34" charset="0"/>
-                <a:ea typeface="Public Sans" pitchFamily="34" charset="-122"/>
-                <a:cs typeface="Public Sans" pitchFamily="34" charset="-120"/>
-              </a:rPr>
-              <a:t>Adding GPS cell risk to Gradient Boosting (train 2017–21): test PR-AUC 0.131 → 0.141, validation 0.132 → 0.153 — more than any change of algorithm.</a:t>
-            </a:r>
-            <a:endParaRPr lang="en-US" sz="1300" dirty="0"/>
-          </a:p>
-          <a:p>
-            <a:pPr algn="l" marL="155956" indent="-155956">
-              <a:lnSpc>
-                <a:spcPts val="1950"/>
-              </a:lnSpc>
-              <a:buSzPct val="100000"/>
-              <a:buChar char="•"/>
-            </a:pPr>
-            <a:r>
-              <a:rPr lang="en-US" sz="1300" dirty="0">
-                <a:solidFill>
-                  <a:srgbClr val="46516B"/>
-                </a:solidFill>
-                <a:latin typeface="Public Sans" pitchFamily="34" charset="0"/>
-                <a:ea typeface="Public Sans" pitchFamily="34" charset="-122"/>
-                <a:cs typeface="Public Sans" pitchFamily="34" charset="-120"/>
-              </a:rPr>
-              <a:t>Interactive Folium map: reports/figures/task3_hotspot_map.html</a:t>
-            </a:r>
-            <a:endParaRPr lang="en-US" sz="1300" dirty="0"/>
-          </a:p>
-        </p:txBody>
-      </p:sp>
-      <p:sp>
-        <p:nvSpPr>
-          <p:cNvPr id="5" name="Text 3"/>
-          <p:cNvSpPr/>
-          <p:nvPr/>
-        </p:nvSpPr>
-        <p:spPr>
-          <a:xfrm>
-            <a:off x="812800" y="6238280"/>
-            <a:ext cx="4057174" cy="238720"/>
-          </a:xfrm>
-          <a:prstGeom prst="rect">
-            <a:avLst/>
-          </a:prstGeom>
-          <a:noFill/>
-          <a:ln/>
-        </p:spPr>
-        <p:txBody>
-          <a:bodyPr wrap="square" lIns="0" tIns="0" rIns="0" bIns="0" rtlCol="0" anchor="t">
-            <a:normAutofit/>
-          </a:bodyPr>
-          <a:lstStyle/>
-          <a:p>
-            <a:pPr algn="l" indent="0" marL="0">
-              <a:lnSpc>
-                <a:spcPts val="1680"/>
-              </a:lnSpc>
-              <a:buNone/>
-            </a:pPr>
-            <a:r>
-              <a:rPr lang="en-US" sz="1200" dirty="0">
-                <a:solidFill>
-                  <a:srgbClr val="8B9099"/>
-                </a:solidFill>
-                <a:latin typeface="Public Sans" pitchFamily="34" charset="0"/>
-                <a:ea typeface="Public Sans" pitchFamily="34" charset="-122"/>
-                <a:cs typeface="Public Sans" pitchFamily="34" charset="-120"/>
-              </a:rPr>
-              <a:t>Road Safety Predictive Analytics — Group 6</a:t>
+              <a:t>Group 6 · Joao · Olena · Samuel · Nuno · Pedro · Predictive Analytics &amp; Forecasting · EMBAAI</a:t>
             </a:r>
             <a:endParaRPr lang="en-US" sz="1200" dirty="0"/>
           </a:p>
         </p:txBody>
       </p:sp>
-      <p:sp>
-        <p:nvSpPr>
-          <p:cNvPr id="6" name="Text 4"/>
-          <p:cNvSpPr/>
-          <p:nvPr/>
-        </p:nvSpPr>
-        <p:spPr>
-          <a:xfrm>
-            <a:off x="11221145" y="6238280"/>
-            <a:ext cx="208855" cy="238720"/>
-          </a:xfrm>
-          <a:prstGeom prst="rect">
-            <a:avLst/>
-          </a:prstGeom>
-          <a:noFill/>
-          <a:ln/>
-        </p:spPr>
-        <p:txBody>
-          <a:bodyPr wrap="square" lIns="0" tIns="0" rIns="0" bIns="0" rtlCol="0" anchor="t">
-            <a:normAutofit/>
-          </a:bodyPr>
-          <a:lstStyle/>
-          <a:p>
-            <a:pPr algn="l" indent="0" marL="0">
-              <a:lnSpc>
-                <a:spcPts val="1680"/>
-              </a:lnSpc>
-              <a:buNone/>
-            </a:pPr>
-            <a:r>
-              <a:rPr lang="en-US" sz="1200" dirty="0">
-                <a:solidFill>
-                  <a:srgbClr val="8B9099"/>
-                </a:solidFill>
-                <a:latin typeface="Public Sans" pitchFamily="34" charset="0"/>
-                <a:ea typeface="Public Sans" pitchFamily="34" charset="-122"/>
-                <a:cs typeface="Public Sans" pitchFamily="34" charset="-120"/>
-              </a:rPr>
-              <a:t>24</a:t>
-            </a:r>
-            <a:endParaRPr lang="en-US" sz="1200" dirty="0"/>
-          </a:p>
-        </p:txBody>
-      </p:sp>
-      <p:pic>
-        <p:nvPicPr>
-          <p:cNvPr id="7" name="Picture 6" descr="task3_hotspots.png"/>
-          <p:cNvPicPr>
-            <a:picLocks noChangeAspect="1"/>
-          </p:cNvPicPr>
-          <p:nvPr/>
-        </p:nvPicPr>
-        <p:blipFill>
-          <a:blip r:embed="rId2"/>
-          <a:stretch>
-            <a:fillRect/>
-          </a:stretch>
-        </p:blipFill>
-        <p:spPr>
-          <a:xfrm>
-            <a:off x="812800" y="1642070"/>
-            <a:ext cx="4416202" cy="4450000"/>
-          </a:xfrm>
-          <a:prstGeom prst="rect">
-            <a:avLst/>
-          </a:prstGeom>
-        </p:spPr>
-      </p:pic>
     </p:spTree>
   </p:cSld>
   <p:clrMapOvr>

</xml_diff>

<commit_message>
Fix layout of presentation slides 22-28
- Slide 22: widen Model column, move winner callout so text fits
- Slides 23-24: one-line title on 23, 14pt bullets, align content with slides 20-21
- Slide 26: 30pt title, rows sized so text stays inside cards
- Slide 28: make all five rows the same light style

Co-Authored-By: Claude Opus 5.5 <noreply@anthropic.com>
</commit_message>
<xml_diff>
--- a/reports/presentation/Road Safety Predictive Analytics — Group 6.pptx
+++ b/reports/presentation/Road Safety Predictive Analytics — Group 6.pptx
@@ -16346,12 +16346,12 @@
             <a:tbl>
               <a:tblPr/>
               <a:tblGrid>
-                <a:gridCol w="1899666"/>
-                <a:gridCol w="2110740"/>
-                <a:gridCol w="1688592"/>
-                <a:gridCol w="1688592"/>
-                <a:gridCol w="1477518"/>
-                <a:gridCol w="1688592"/>
+                <a:gridCol w="4069080"/>
+                <a:gridCol w="1097280"/>
+                <a:gridCol w="1097280"/>
+                <a:gridCol w="1600200"/>
+                <a:gridCol w="1463040"/>
+                <a:gridCol w="1226820"/>
               </a:tblGrid>
               <a:tr h="359321">
                 <a:tc>
@@ -18433,8 +18433,8 @@
         </p:nvSpPr>
         <p:spPr>
           <a:xfrm>
-            <a:off x="812800" y="4114800"/>
-            <a:ext cx="10566400" cy="1150000"/>
+            <a:off x="812800" y="3977639"/>
+            <a:ext cx="10566400" cy="1371600"/>
           </a:xfrm>
           <a:prstGeom prst="roundRect">
             <a:avLst>
@@ -18663,7 +18663,7 @@
                 <a:ea typeface="Libre Baskerville" pitchFamily="18" charset="-122"/>
                 <a:cs typeface="Libre Baskerville" pitchFamily="18" charset="-120"/>
               </a:rPr>
-              <a:t>What is the model worth? Cost-benefit of ALS capacity</a:t>
+              <a:t>What is the model worth? ALS cost-benefit</a:t>
             </a:r>
             <a:endParaRPr lang="en-US" sz="3000" dirty="0"/>
           </a:p>
@@ -18677,7 +18677,7 @@
         </p:nvSpPr>
         <p:spPr>
           <a:xfrm>
-            <a:off x="6400000" y="1642070"/>
+            <a:off x="6400000" y="1682496"/>
             <a:ext cx="5288572" cy="4300000"/>
           </a:xfrm>
           <a:prstGeom prst="rect">
@@ -18692,7 +18692,7 @@
           </a:bodyPr>
           <a:lstStyle/>
           <a:p>
-            <a:pPr algn="l" marL="155956" indent="-155956">
+            <a:pPr algn="l" marL="171450" indent="-171450">
               <a:lnSpc>
                 <a:spcPts val="1950"/>
               </a:lnSpc>
@@ -18700,7 +18700,7 @@
               <a:buChar char="•"/>
             </a:pPr>
             <a:r>
-              <a:rPr lang="en-US" sz="1300" dirty="0">
+              <a:rPr lang="en-US" sz="1400" dirty="0">
                 <a:solidFill>
                   <a:srgbClr val="46516B"/>
                 </a:solidFill>
@@ -18713,7 +18713,7 @@
             <a:endParaRPr lang="en-US" sz="1300" dirty="0"/>
           </a:p>
           <a:p>
-            <a:pPr algn="l" marL="155956" indent="-155956">
+            <a:pPr algn="l" marL="171450" indent="-171450">
               <a:lnSpc>
                 <a:spcPts val="1950"/>
               </a:lnSpc>
@@ -18721,7 +18721,7 @@
               <a:buChar char="•"/>
             </a:pPr>
             <a:r>
-              <a:rPr lang="en-US" sz="1300" dirty="0">
+              <a:rPr lang="en-US" sz="1400" dirty="0">
                 <a:solidFill>
                   <a:srgbClr val="46516B"/>
                 </a:solidFill>
@@ -18734,7 +18734,7 @@
             <a:endParaRPr lang="en-US" sz="1300" dirty="0"/>
           </a:p>
           <a:p>
-            <a:pPr algn="l" marL="155956" indent="-155956">
+            <a:pPr algn="l" marL="171450" indent="-171450">
               <a:lnSpc>
                 <a:spcPts val="1950"/>
               </a:lnSpc>
@@ -18742,7 +18742,7 @@
               <a:buChar char="•"/>
             </a:pPr>
             <a:r>
-              <a:rPr lang="en-US" sz="1300" dirty="0">
+              <a:rPr lang="en-US" sz="1400" dirty="0">
                 <a:solidFill>
                   <a:srgbClr val="46516B"/>
                 </a:solidFill>
@@ -18755,7 +18755,7 @@
             <a:endParaRPr lang="en-US" sz="1300" dirty="0"/>
           </a:p>
           <a:p>
-            <a:pPr algn="l" marL="155956" indent="-155956">
+            <a:pPr algn="l" marL="171450" indent="-171450">
               <a:lnSpc>
                 <a:spcPts val="1950"/>
               </a:lnSpc>
@@ -18763,7 +18763,7 @@
               <a:buChar char="•"/>
             </a:pPr>
             <a:r>
-              <a:rPr lang="en-US" sz="1300" dirty="0">
+              <a:rPr lang="en-US" sz="1400" dirty="0">
                 <a:solidFill>
                   <a:srgbClr val="46516B"/>
                 </a:solidFill>
@@ -18881,7 +18881,7 @@
         </p:blipFill>
         <p:spPr>
           <a:xfrm>
-            <a:off x="812800" y="1642070"/>
+            <a:off x="812800" y="1682496"/>
             <a:ext cx="5400000" cy="3349367"/>
           </a:xfrm>
           <a:prstGeom prst="rect">
@@ -19005,7 +19005,7 @@
         </p:nvSpPr>
         <p:spPr>
           <a:xfrm>
-            <a:off x="6400000" y="1642070"/>
+            <a:off x="6400000" y="1682496"/>
             <a:ext cx="5288572" cy="4300000"/>
           </a:xfrm>
           <a:prstGeom prst="rect">
@@ -19020,7 +19020,7 @@
           </a:bodyPr>
           <a:lstStyle/>
           <a:p>
-            <a:pPr algn="l" marL="155956" indent="-155956">
+            <a:pPr algn="l" marL="171450" indent="-171450">
               <a:lnSpc>
                 <a:spcPts val="1950"/>
               </a:lnSpc>
@@ -19028,7 +19028,7 @@
               <a:buChar char="•"/>
             </a:pPr>
             <a:r>
-              <a:rPr lang="en-US" sz="1300" dirty="0">
+              <a:rPr lang="en-US" sz="1400" dirty="0">
                 <a:solidFill>
                   <a:srgbClr val="46516B"/>
                 </a:solidFill>
@@ -19041,7 +19041,7 @@
             <a:endParaRPr lang="en-US" sz="1300" dirty="0"/>
           </a:p>
           <a:p>
-            <a:pPr algn="l" marL="155956" indent="-155956">
+            <a:pPr algn="l" marL="171450" indent="-171450">
               <a:lnSpc>
                 <a:spcPts val="1950"/>
               </a:lnSpc>
@@ -19049,7 +19049,7 @@
               <a:buChar char="•"/>
             </a:pPr>
             <a:r>
-              <a:rPr lang="en-US" sz="1300" dirty="0">
+              <a:rPr lang="en-US" sz="1400" dirty="0">
                 <a:solidFill>
                   <a:srgbClr val="46516B"/>
                 </a:solidFill>
@@ -19062,7 +19062,7 @@
             <a:endParaRPr lang="en-US" sz="1300" dirty="0"/>
           </a:p>
           <a:p>
-            <a:pPr algn="l" marL="155956" indent="-155956">
+            <a:pPr algn="l" marL="171450" indent="-171450">
               <a:lnSpc>
                 <a:spcPts val="1950"/>
               </a:lnSpc>
@@ -19070,7 +19070,7 @@
               <a:buChar char="•"/>
             </a:pPr>
             <a:r>
-              <a:rPr lang="en-US" sz="1300" dirty="0">
+              <a:rPr lang="en-US" sz="1400" dirty="0">
                 <a:solidFill>
                   <a:srgbClr val="46516B"/>
                 </a:solidFill>
@@ -19083,7 +19083,7 @@
             <a:endParaRPr lang="en-US" sz="1300" dirty="0"/>
           </a:p>
           <a:p>
-            <a:pPr algn="l" marL="155956" indent="-155956">
+            <a:pPr algn="l" marL="171450" indent="-171450">
               <a:lnSpc>
                 <a:spcPts val="1950"/>
               </a:lnSpc>
@@ -19091,7 +19091,7 @@
               <a:buChar char="•"/>
             </a:pPr>
             <a:r>
-              <a:rPr lang="en-US" sz="1300" dirty="0">
+              <a:rPr lang="en-US" sz="1400" dirty="0">
                 <a:solidFill>
                   <a:srgbClr val="46516B"/>
                 </a:solidFill>
@@ -19104,7 +19104,7 @@
             <a:endParaRPr lang="en-US" sz="1300" dirty="0"/>
           </a:p>
           <a:p>
-            <a:pPr algn="l" marL="155956" indent="-155956">
+            <a:pPr algn="l" marL="171450" indent="-171450">
               <a:lnSpc>
                 <a:spcPts val="1950"/>
               </a:lnSpc>
@@ -19112,7 +19112,7 @@
               <a:buChar char="•"/>
             </a:pPr>
             <a:r>
-              <a:rPr lang="en-US" sz="1300" dirty="0">
+              <a:rPr lang="en-US" sz="1400" dirty="0">
                 <a:solidFill>
                   <a:srgbClr val="46516B"/>
                 </a:solidFill>
@@ -19230,8 +19230,8 @@
         </p:blipFill>
         <p:spPr>
           <a:xfrm>
-            <a:off x="812800" y="1642070"/>
-            <a:ext cx="4416202" cy="4450000"/>
+            <a:off x="812800" y="1682496"/>
+            <a:ext cx="4310411" cy="4343400"/>
           </a:xfrm>
           <a:prstGeom prst="rect">
             <a:avLst/>
@@ -19491,7 +19491,7 @@
         <p:spPr>
           <a:xfrm>
             <a:off x="812800" y="1026120"/>
-            <a:ext cx="10883392" cy="434330"/>
+            <a:ext cx="10883392" cy="463550"/>
           </a:xfrm>
           <a:prstGeom prst="rect">
             <a:avLst/>
@@ -19507,12 +19507,12 @@
           <a:p>
             <a:pPr algn="l" indent="0" marL="0">
               <a:lnSpc>
-                <a:spcPts val="3220"/>
+                <a:spcPts val="3450"/>
               </a:lnSpc>
               <a:buNone/>
             </a:pPr>
             <a:r>
-              <a:rPr lang="en-US" sz="2800" b="1" i="0" dirty="0">
+              <a:rPr lang="en-US" sz="3000" b="1" i="0" dirty="0">
                 <a:solidFill>
                   <a:srgbClr val="15213B"/>
                 </a:solidFill>
@@ -19534,8 +19534,8 @@
         </p:nvSpPr>
         <p:spPr>
           <a:xfrm>
-            <a:off x="815975" y="1552525"/>
-            <a:ext cx="10560050" cy="516880"/>
+            <a:off x="813816" y="1682496"/>
+            <a:ext cx="10561320" cy="777240"/>
           </a:xfrm>
           <a:prstGeom prst="roundRect">
             <a:avLst>
@@ -19565,8 +19565,8 @@
         </p:nvSpPr>
         <p:spPr>
           <a:xfrm>
-            <a:off x="1022350" y="1695400"/>
-            <a:ext cx="2223770" cy="256530"/>
+            <a:off x="1024128" y="1819656"/>
+            <a:ext cx="1828800" cy="274320"/>
           </a:xfrm>
           <a:prstGeom prst="rect">
             <a:avLst/>
@@ -19587,7 +19587,7 @@
               <a:buNone/>
             </a:pPr>
             <a:r>
-              <a:rPr lang="en-US" sz="1300" b="1" dirty="0">
+              <a:rPr lang="en-US" sz="1400" b="1" dirty="0">
                 <a:solidFill>
                   <a:srgbClr val="B05A26"/>
                 </a:solidFill>
@@ -19609,8 +19609,8 @@
         </p:nvSpPr>
         <p:spPr>
           <a:xfrm>
-            <a:off x="3333750" y="1695400"/>
-            <a:ext cx="8070977" cy="256530"/>
+            <a:off x="2980944" y="1819656"/>
+            <a:ext cx="8211312" cy="548640"/>
           </a:xfrm>
           <a:prstGeom prst="rect">
             <a:avLst/>
@@ -19631,7 +19631,7 @@
               <a:buNone/>
             </a:pPr>
             <a:r>
-              <a:rPr lang="en-US" sz="1300" dirty="0">
+              <a:rPr lang="en-US" sz="1400" dirty="0">
                 <a:solidFill>
                   <a:srgbClr val="46516B"/>
                 </a:solidFill>
@@ -19653,8 +19653,8 @@
         </p:nvSpPr>
         <p:spPr>
           <a:xfrm>
-            <a:off x="815975" y="2151955"/>
-            <a:ext cx="10560050" cy="516880"/>
+            <a:off x="813816" y="2551176"/>
+            <a:ext cx="10561320" cy="777240"/>
           </a:xfrm>
           <a:prstGeom prst="roundRect">
             <a:avLst>
@@ -19684,8 +19684,8 @@
         </p:nvSpPr>
         <p:spPr>
           <a:xfrm>
-            <a:off x="1022350" y="2294830"/>
-            <a:ext cx="2223770" cy="256530"/>
+            <a:off x="1024128" y="2688336"/>
+            <a:ext cx="1828800" cy="274320"/>
           </a:xfrm>
           <a:prstGeom prst="rect">
             <a:avLst/>
@@ -19706,7 +19706,7 @@
               <a:buNone/>
             </a:pPr>
             <a:r>
-              <a:rPr lang="en-US" sz="1300" b="1" dirty="0">
+              <a:rPr lang="en-US" sz="1400" b="1" dirty="0">
                 <a:solidFill>
                   <a:srgbClr val="B05A26"/>
                 </a:solidFill>
@@ -19728,8 +19728,8 @@
         </p:nvSpPr>
         <p:spPr>
           <a:xfrm>
-            <a:off x="3333750" y="2294830"/>
-            <a:ext cx="8070977" cy="256530"/>
+            <a:off x="2980944" y="2688336"/>
+            <a:ext cx="8211312" cy="548640"/>
           </a:xfrm>
           <a:prstGeom prst="rect">
             <a:avLst/>
@@ -19750,7 +19750,7 @@
               <a:buNone/>
             </a:pPr>
             <a:r>
-              <a:rPr lang="en-US" sz="1300" dirty="0">
+              <a:rPr lang="en-US" sz="1400" dirty="0">
                 <a:solidFill>
                   <a:srgbClr val="46516B"/>
                 </a:solidFill>
@@ -19772,8 +19772,8 @@
         </p:nvSpPr>
         <p:spPr>
           <a:xfrm>
-            <a:off x="815975" y="2751386"/>
-            <a:ext cx="10560050" cy="748010"/>
+            <a:off x="813816" y="3419856"/>
+            <a:ext cx="10561320" cy="777240"/>
           </a:xfrm>
           <a:prstGeom prst="roundRect">
             <a:avLst>
@@ -19803,8 +19803,8 @@
         </p:nvSpPr>
         <p:spPr>
           <a:xfrm>
-            <a:off x="1022350" y="2894261"/>
-            <a:ext cx="2223770" cy="487660"/>
+            <a:off x="1024128" y="3557016"/>
+            <a:ext cx="1828800" cy="274320"/>
           </a:xfrm>
           <a:prstGeom prst="rect">
             <a:avLst/>
@@ -19825,7 +19825,7 @@
               <a:buNone/>
             </a:pPr>
             <a:r>
-              <a:rPr lang="en-US" sz="1300" b="1" dirty="0">
+              <a:rPr lang="en-US" sz="1400" b="1" dirty="0">
                 <a:solidFill>
                   <a:srgbClr val="B05A26"/>
                 </a:solidFill>
@@ -19847,8 +19847,8 @@
         </p:nvSpPr>
         <p:spPr>
           <a:xfrm>
-            <a:off x="3333750" y="2894261"/>
-            <a:ext cx="8070977" cy="487660"/>
+            <a:off x="2980944" y="3557016"/>
+            <a:ext cx="8211312" cy="548640"/>
           </a:xfrm>
           <a:prstGeom prst="rect">
             <a:avLst/>
@@ -19869,7 +19869,7 @@
               <a:buNone/>
             </a:pPr>
             <a:r>
-              <a:rPr lang="en-US" sz="1300" dirty="0">
+              <a:rPr lang="en-US" sz="1400" dirty="0">
                 <a:solidFill>
                   <a:srgbClr val="46516B"/>
                 </a:solidFill>
@@ -19891,8 +19891,8 @@
         </p:nvSpPr>
         <p:spPr>
           <a:xfrm>
-            <a:off x="815975" y="3581946"/>
-            <a:ext cx="10560050" cy="516880"/>
+            <a:off x="813816" y="4288536"/>
+            <a:ext cx="10561320" cy="777240"/>
           </a:xfrm>
           <a:prstGeom prst="roundRect">
             <a:avLst>
@@ -19922,8 +19922,8 @@
         </p:nvSpPr>
         <p:spPr>
           <a:xfrm>
-            <a:off x="1022350" y="3724821"/>
-            <a:ext cx="2223770" cy="256530"/>
+            <a:off x="1024128" y="4425696"/>
+            <a:ext cx="1828800" cy="274320"/>
           </a:xfrm>
           <a:prstGeom prst="rect">
             <a:avLst/>
@@ -19944,7 +19944,7 @@
               <a:buNone/>
             </a:pPr>
             <a:r>
-              <a:rPr lang="en-US" sz="1300" b="1" dirty="0">
+              <a:rPr lang="en-US" sz="1400" b="1" dirty="0">
                 <a:solidFill>
                   <a:srgbClr val="B05A26"/>
                 </a:solidFill>
@@ -19966,8 +19966,8 @@
         </p:nvSpPr>
         <p:spPr>
           <a:xfrm>
-            <a:off x="3333750" y="3724821"/>
-            <a:ext cx="8070977" cy="256530"/>
+            <a:off x="2980944" y="4425696"/>
+            <a:ext cx="8211312" cy="548640"/>
           </a:xfrm>
           <a:prstGeom prst="rect">
             <a:avLst/>
@@ -19988,7 +19988,7 @@
               <a:buNone/>
             </a:pPr>
             <a:r>
-              <a:rPr lang="en-US" sz="1300" dirty="0">
+              <a:rPr lang="en-US" sz="1400" dirty="0">
                 <a:solidFill>
                   <a:srgbClr val="46516B"/>
                 </a:solidFill>
@@ -20743,8 +20743,8 @@
         </p:nvSpPr>
         <p:spPr>
           <a:xfrm>
-            <a:off x="812800" y="3519041"/>
-            <a:ext cx="10566400" cy="528290"/>
+            <a:off x="815975" y="3519041"/>
+            <a:ext cx="10560050" cy="528290"/>
           </a:xfrm>
           <a:prstGeom prst="roundRect">
             <a:avLst>
@@ -20752,9 +20752,14 @@
             </a:avLst>
           </a:prstGeom>
           <a:solidFill>
-            <a:srgbClr val="15213B"/>
+            <a:srgbClr val="FDFDFB"/>
           </a:solidFill>
-          <a:ln/>
+          <a:ln w="6350">
+            <a:solidFill>
+              <a:srgbClr val="E2DFD6"/>
+            </a:solidFill>
+            <a:prstDash val="solid"/>
+          </a:ln>
         </p:spPr>
         <p:txBody>
           <a:bodyPr/>
@@ -20769,7 +20774,7 @@
         </p:nvSpPr>
         <p:spPr>
           <a:xfrm>
-            <a:off x="1016000" y="3658741"/>
+            <a:off x="1022350" y="3658741"/>
             <a:ext cx="1831340" cy="274290"/>
           </a:xfrm>
           <a:prstGeom prst="rect">
@@ -20793,7 +20798,7 @@
             <a:r>
               <a:rPr lang="en-US" sz="1400" b="1" dirty="0">
                 <a:solidFill>
-                  <a:srgbClr val="F4F1E8"/>
+                  <a:srgbClr val="B05A26"/>
                 </a:solidFill>
                 <a:latin typeface="Public Sans" pitchFamily="34" charset="0"/>
                 <a:ea typeface="Public Sans" pitchFamily="34" charset="-122"/>
@@ -20813,8 +20818,8 @@
         </p:nvSpPr>
         <p:spPr>
           <a:xfrm>
-            <a:off x="2971800" y="3658741"/>
-            <a:ext cx="8450326" cy="274290"/>
+            <a:off x="2978150" y="3658741"/>
+            <a:ext cx="8437245" cy="274290"/>
           </a:xfrm>
           <a:prstGeom prst="rect">
             <a:avLst/>
@@ -20837,7 +20842,7 @@
             <a:r>
               <a:rPr lang="en-US" sz="1400" dirty="0">
                 <a:solidFill>
-                  <a:srgbClr val="F4F1E8"/>
+                  <a:srgbClr val="15213B"/>
                 </a:solidFill>
                 <a:latin typeface="Public Sans" pitchFamily="34" charset="0"/>
                 <a:ea typeface="Public Sans" pitchFamily="34" charset="-122"/>
@@ -20857,8 +20862,8 @@
         </p:nvSpPr>
         <p:spPr>
           <a:xfrm>
-            <a:off x="812800" y="4123531"/>
-            <a:ext cx="10566400" cy="528290"/>
+            <a:off x="815975" y="4123531"/>
+            <a:ext cx="10560050" cy="528290"/>
           </a:xfrm>
           <a:prstGeom prst="roundRect">
             <a:avLst>
@@ -20866,9 +20871,14 @@
             </a:avLst>
           </a:prstGeom>
           <a:solidFill>
-            <a:srgbClr val="15213B"/>
+            <a:srgbClr val="FDFDFB"/>
           </a:solidFill>
-          <a:ln/>
+          <a:ln w="6350">
+            <a:solidFill>
+              <a:srgbClr val="E2DFD6"/>
+            </a:solidFill>
+            <a:prstDash val="solid"/>
+          </a:ln>
         </p:spPr>
         <p:txBody>
           <a:bodyPr/>
@@ -20883,7 +20893,7 @@
         </p:nvSpPr>
         <p:spPr>
           <a:xfrm>
-            <a:off x="1016000" y="4263231"/>
+            <a:off x="1022350" y="4263231"/>
             <a:ext cx="1831340" cy="274290"/>
           </a:xfrm>
           <a:prstGeom prst="rect">
@@ -20907,7 +20917,7 @@
             <a:r>
               <a:rPr lang="en-US" sz="1400" b="1" dirty="0">
                 <a:solidFill>
-                  <a:srgbClr val="F4F1E8"/>
+                  <a:srgbClr val="B05A26"/>
                 </a:solidFill>
                 <a:latin typeface="Public Sans" pitchFamily="34" charset="0"/>
                 <a:ea typeface="Public Sans" pitchFamily="34" charset="-122"/>
@@ -20927,8 +20937,8 @@
         </p:nvSpPr>
         <p:spPr>
           <a:xfrm>
-            <a:off x="2971800" y="4263231"/>
-            <a:ext cx="8450326" cy="274290"/>
+            <a:off x="2978150" y="4263231"/>
+            <a:ext cx="8437245" cy="274290"/>
           </a:xfrm>
           <a:prstGeom prst="rect">
             <a:avLst/>
@@ -20951,7 +20961,7 @@
             <a:r>
               <a:rPr lang="en-US" sz="1400" dirty="0">
                 <a:solidFill>
-                  <a:srgbClr val="F4F1E8"/>
+                  <a:srgbClr val="15213B"/>
                 </a:solidFill>
                 <a:latin typeface="Public Sans" pitchFamily="34" charset="0"/>
                 <a:ea typeface="Public Sans" pitchFamily="34" charset="-122"/>

</xml_diff>